<commit_message>
chore: freeze CampusMind course project release
</commit_message>
<xml_diff>
--- a/ppt/智问校园CampusMind答辩PPT.pptx
+++ b/ppt/智问校园CampusMind答辩PPT.pptx
@@ -194,10 +194,10 @@
                     <c:v>Vector(TF-IDF)</c:v>
                   </c:pt>
                   <c:pt idx="2">
-                    <c:v>Hybrid+RRF</c:v>
+                    <c:v>Hybrid+RRF(默认)</c:v>
                   </c:pt>
                   <c:pt idx="3">
-                    <c:v>Hybrid+Rerank(生产)</c:v>
+                    <c:v>Hybrid+Rerank(开关)</c:v>
                   </c:pt>
                 </c:lvl>
               </c:multiLvlStrCache>
@@ -283,10 +283,10 @@
                     <c:v>Vector(TF-IDF)</c:v>
                   </c:pt>
                   <c:pt idx="2">
-                    <c:v>Hybrid+RRF</c:v>
+                    <c:v>Hybrid+RRF(默认)</c:v>
                   </c:pt>
                   <c:pt idx="3">
-                    <c:v>Hybrid+Rerank(生产)</c:v>
+                    <c:v>Hybrid+Rerank(开关)</c:v>
                   </c:pt>
                 </c:lvl>
               </c:multiLvlStrCache>
@@ -305,7 +305,7 @@
                   <c:v>93.5</c:v>
                 </c:pt>
                 <c:pt idx="2">
-                  <c:v>95.2</c:v>
+                  <c:v>98.4</c:v>
                 </c:pt>
                 <c:pt idx="3">
                   <c:v>90.3</c:v>
@@ -5155,7 +5155,7 @@
                 <a:ea typeface="PingFang SC" pitchFamily="34" charset="-122"/>
                 <a:cs typeface="PingFang SC" pitchFamily="34" charset="-120"/>
               </a:rPr>
-              <a:t>数据源：scripts/eval_matrix.py，n=62，MRR：0.884 / 0.844 / 0.863 / 0.815</a:t>
+              <a:t>数据源：scripts/eval_matrix.py，n=62，统一文档级去重口径，MRR：0.884 / 0.844 / 0.884 / 0.815</a:t>
             </a:r>
             <a:endParaRPr lang="en-US" sz="1000" dirty="0"/>
           </a:p>
@@ -5257,7 +5257,7 @@
                 <a:ea typeface="PingFang SC" pitchFamily="34" charset="-122"/>
                 <a:cs typeface="PingFang SC" pitchFamily="34" charset="-120"/>
               </a:rPr>
-              <a:t>① 停用词表构造 bug（整串未 split）② RRF 候选池截断压缩文档多样性 ③ 缺文档级去重（引用卡片重复根因），生产链路 Hit@3 82.3% → 90.3%</a:t>
+              <a:t>① 停用词表构造 bug（整串未 split）② RRF 候选池截断压缩文档多样性 ③ 缺文档级去重（引用卡片重复根因），统一口径后 RRF 实测 98.4%（旧口径 95.2% 存在重复占位失真）</a:t>
             </a:r>
             <a:endParaRPr lang="en-US" sz="1250" dirty="0"/>
           </a:p>
@@ -5356,7 +5356,7 @@
                 <a:ea typeface="PingFang SC" pitchFamily="34" charset="-122"/>
                 <a:cs typeface="PingFang SC" pitchFamily="34" charset="-120"/>
               </a:rPr>
-              <a:t>轻量词面重排无法稳定超越双通道排序，其价值在质量控制（兑底阈值）；排序增益需 Cross-Encoder，已列演进（与 ADR-2/4 呼应）</a:t>
+              <a:t>BM25 对关键词密集型规章问题最好；TF-IDF 向量补充另一视角但未稳定超过 BM25；轻量 Reranker 实测无收益，默认关闭保持 Provider 化，待替换 Cross-Encoder 后再评估</a:t>
             </a:r>
             <a:endParaRPr lang="en-US" sz="1250" dirty="0"/>
           </a:p>
@@ -6174,7 +6174,7 @@
                           <a:ea typeface="PingFang SC" pitchFamily="34" charset="-122"/>
                           <a:cs typeface="PingFang SC" pitchFamily="34" charset="-120"/>
                         </a:rPr>
-                        <a:t>217.8</a:t>
+                        <a:t>251.4</a:t>
                       </a:r>
                       <a:endParaRPr lang="en-US" sz="1250" dirty="0">
                         <a:latin typeface="PingFang SC" charset="0"/>
@@ -6242,7 +6242,7 @@
                           <a:ea typeface="PingFang SC" pitchFamily="34" charset="-122"/>
                           <a:cs typeface="PingFang SC" pitchFamily="34" charset="-120"/>
                         </a:rPr>
-                        <a:t>4.1ms</a:t>
+                        <a:t>3.4ms</a:t>
                       </a:r>
                       <a:endParaRPr lang="en-US" sz="1250" dirty="0">
                         <a:latin typeface="PingFang SC" charset="0"/>
@@ -6310,7 +6310,7 @@
                           <a:ea typeface="PingFang SC" pitchFamily="34" charset="-122"/>
                           <a:cs typeface="PingFang SC" pitchFamily="34" charset="-120"/>
                         </a:rPr>
-                        <a:t>8.7ms</a:t>
+                        <a:t>7.0ms</a:t>
                       </a:r>
                       <a:endParaRPr lang="en-US" sz="1250" dirty="0">
                         <a:latin typeface="PingFang SC" charset="0"/>
@@ -6378,7 +6378,7 @@
                           <a:ea typeface="PingFang SC" pitchFamily="34" charset="-122"/>
                           <a:cs typeface="PingFang SC" pitchFamily="34" charset="-120"/>
                         </a:rPr>
-                        <a:t>9.5ms</a:t>
+                        <a:t>7.2ms</a:t>
                       </a:r>
                       <a:endParaRPr lang="en-US" sz="1250" dirty="0">
                         <a:latin typeface="PingFang SC" charset="0"/>
@@ -6652,7 +6652,7 @@
                           <a:ea typeface="PingFang SC" pitchFamily="34" charset="-122"/>
                           <a:cs typeface="PingFang SC" pitchFamily="34" charset="-120"/>
                         </a:rPr>
-                        <a:t>42.0</a:t>
+                        <a:t>44.1</a:t>
                       </a:r>
                       <a:endParaRPr lang="en-US" sz="1250" dirty="0">
                         <a:latin typeface="PingFang SC" charset="0"/>
@@ -6720,7 +6720,7 @@
                           <a:ea typeface="PingFang SC" pitchFamily="34" charset="-122"/>
                           <a:cs typeface="PingFang SC" pitchFamily="34" charset="-120"/>
                         </a:rPr>
-                        <a:t>436ms</a:t>
+                        <a:t>415.7ms</a:t>
                       </a:r>
                       <a:endParaRPr lang="en-US" sz="1250" dirty="0">
                         <a:latin typeface="PingFang SC" charset="0"/>
@@ -6788,7 +6788,7 @@
                           <a:ea typeface="PingFang SC" pitchFamily="34" charset="-122"/>
                           <a:cs typeface="PingFang SC" pitchFamily="34" charset="-120"/>
                         </a:rPr>
-                        <a:t>632ms</a:t>
+                        <a:t>601.0ms</a:t>
                       </a:r>
                       <a:endParaRPr lang="en-US" sz="1250" dirty="0">
                         <a:latin typeface="PingFang SC" charset="0"/>
@@ -6856,7 +6856,7 @@
                           <a:ea typeface="PingFang SC" pitchFamily="34" charset="-122"/>
                           <a:cs typeface="PingFang SC" pitchFamily="34" charset="-120"/>
                         </a:rPr>
-                        <a:t>683ms</a:t>
+                        <a:t>611.1ms</a:t>
                       </a:r>
                       <a:endParaRPr lang="en-US" sz="1250" dirty="0">
                         <a:latin typeface="PingFang SC" charset="0"/>
@@ -7013,7 +7013,7 @@
                 <a:ea typeface="PingFang SC" pitchFamily="34" charset="-122"/>
                 <a:cs typeface="PingFang SC" pitchFamily="34" charset="-120"/>
               </a:rPr>
-              <a:t>217.8</a:t>
+              <a:t>251.4</a:t>
             </a:r>
             <a:endParaRPr lang="en-US" sz="4400" dirty="0"/>
           </a:p>
@@ -7091,7 +7091,7 @@
                 <a:ea typeface="PingFang SC" pitchFamily="34" charset="-122"/>
                 <a:cs typeface="PingFang SC" pitchFamily="34" charset="-120"/>
               </a:rPr>
-              <a:t>p95 8.7ms，远优于 50ms 目标</a:t>
+              <a:t>p95 7.0ms，远优于 50ms 目标</a:t>
             </a:r>
             <a:endParaRPr lang="en-US" sz="1050" dirty="0"/>
           </a:p>
@@ -7130,7 +7130,7 @@
                 <a:ea typeface="PingFang SC" pitchFamily="34" charset="-122"/>
                 <a:cs typeface="PingFang SC" pitchFamily="34" charset="-120"/>
               </a:rPr>
-              <a:t>42.0</a:t>
+              <a:t>44.1</a:t>
             </a:r>
             <a:endParaRPr lang="en-US" sz="4400" dirty="0"/>
           </a:p>
@@ -7208,7 +7208,7 @@
                 <a:ea typeface="PingFang SC" pitchFamily="34" charset="-122"/>
                 <a:cs typeface="PingFang SC" pitchFamily="34" charset="-120"/>
               </a:rPr>
-              <a:t>p99 683ms，200/200 成功</a:t>
+              <a:t>p99 611ms，200/200 成功</a:t>
             </a:r>
             <a:endParaRPr lang="en-US" sz="1050" dirty="0"/>
           </a:p>
@@ -7295,7 +7295,7 @@
                 <a:ea typeface="PingFang SC" pitchFamily="34" charset="-122"/>
                 <a:cs typeface="PingFang SC" pitchFamily="34" charset="-120"/>
               </a:rPr>
-              <a:t>E2E 吞吐较早期 67.8 QPS 下降，因本轮修复后检索链路更完整（候选池 4×、文档级去重、组合排序），以准确性优先。</a:t>
+              <a:t>历史对照：Rerank 默认时期 217.8 / 42.0 QPS，初版 67.8 QPS；默认切换至 RRF 后检索计算量下降，吞吐回升，数据如实呈现。</a:t>
             </a:r>
             <a:endParaRPr lang="en-US" sz="1200" dirty="0"/>
           </a:p>
@@ -16376,7 +16376,7 @@
                 <a:ea typeface="PingFang SC" pitchFamily="34" charset="-122"/>
                 <a:cs typeface="PingFang SC" pitchFamily="34" charset="-120"/>
               </a:rPr>
-              <a:t>重排序 Top-3</a:t>
+              <a:t>重排序(可选开关)</a:t>
             </a:r>
             <a:endParaRPr lang="en-US" sz="1350" dirty="0"/>
           </a:p>
@@ -16415,7 +16415,7 @@
                 <a:ea typeface="PingFang SC" pitchFamily="34" charset="-122"/>
                 <a:cs typeface="PingFang SC" pitchFamily="34" charset="-120"/>
               </a:rPr>
-              <a:t>特征化精排</a:t>
+              <a:t>默认关闭 RERANK_ENABLED</a:t>
             </a:r>
             <a:endParaRPr lang="en-US" sz="1000" dirty="0"/>
           </a:p>
@@ -16800,7 +16800,7 @@
                 <a:ea typeface="PingFang SC" pitchFamily="34" charset="-122"/>
                 <a:cs typeface="PingFang SC" pitchFamily="34" charset="-120"/>
               </a:rPr>
-              <a:t>调试接口与前端引用卡片同步暴露双通道排名与重排分数 —— 检索过程可解释、可课件化、可调参（如右图：BM25#1 · VEC#1 · 85%）</a:t>
+              <a:t>调试接口与前端引用卡片同步暴露双通道排名与融合分数 —— 检索过程可解释、可课件化、可调参（如右图：BM25#1 · VEC#1 · 85%）</a:t>
             </a:r>
             <a:endParaRPr lang="en-US" sz="1350" dirty="0"/>
           </a:p>
@@ -17143,7 +17143,7 @@
                 <a:ea typeface="PingFang SC" pitchFamily="34" charset="-122"/>
                 <a:cs typeface="PingFang SC" pitchFamily="34" charset="-120"/>
               </a:rPr>
-              <a:t>ADR-2 混合检索+RRF+重排</a:t>
+              <a:t>ADR-2 混合检索默认 RRF</a:t>
             </a:r>
             <a:endParaRPr lang="en-US" sz="1450" dirty="0"/>
           </a:p>
@@ -17185,7 +17185,7 @@
                 <a:ea typeface="PingFang SC" pitchFamily="34" charset="-122"/>
                 <a:cs typeface="PingFang SC" pitchFamily="34" charset="-120"/>
               </a:rPr>
-              <a:t>否决单一通道；向量现态 TF-IDF，云端语义 Provider 可插拔（ADR-7）</a:t>
+              <a:t>否决单一通道；重排实测无收益降为开关；向量现态 TF-IDF（ADR-7）</a:t>
             </a:r>
             <a:endParaRPr lang="en-US" sz="1150" dirty="0"/>
           </a:p>

</xml_diff>

<commit_message>
docs: fill team roster (Wang Ruozhang, He Li, Guo Zuoliang) across deliverables
</commit_message>
<xml_diff>
--- a/ppt/智问校园CampusMind答辩PPT.pptx
+++ b/ppt/智问校园CampusMind答辩PPT.pptx
@@ -3263,7 +3263,7 @@
                 <a:ea typeface="PingFang SC" pitchFamily="34" charset="-122"/>
                 <a:cs typeface="PingFang SC" pitchFamily="34" charset="-120"/>
               </a:rPr>
-              <a:t>汇报人：CampusMind 项目组（3–5 人）</a:t>
+              <a:t>汇报人：王若璋（组长/架构） · 何俐 · 郭祚梁</a:t>
             </a:r>
             <a:endParaRPr lang="en-US" sz="1300" dirty="0"/>
           </a:p>
@@ -11312,7 +11312,7 @@
               <a:buNone/>
             </a:pPr>
             <a:r>
-              <a:rPr lang="en-US" sz="1300" dirty="0">
+              <a:rPr lang="en-US" sz="1100" dirty="0">
                 <a:solidFill>
                   <a:srgbClr val="C9D2F5"/>
                 </a:solidFill>
@@ -11320,7 +11320,7 @@
                 <a:ea typeface="PingFang SC" pitchFamily="34" charset="-122"/>
                 <a:cs typeface="PingFang SC" pitchFamily="34" charset="-120"/>
               </a:rPr>
-              <a:t>架构师（总控架构与 ADR）· 后端工程 ×2（检索引擎与 API）· 前端工程（聊天与看板）· 数据运营（知识库与同义词）· 测试（评测与压测）</a:t>
+              <a:t>王若璋（组长/架构：架构与 ADR、检索引擎、测试验收）· 何俐（后端/数据：生成与 Provider、摄取与热更新、评测集）· 郭祚梁（前端/材料：三视图、流式溯源、文档与答辩材料）</a:t>
             </a:r>
             <a:endParaRPr lang="en-US" sz="1350" dirty="0"/>
           </a:p>
@@ -15385,7 +15385,7 @@
                 <a:ea typeface="PingFang SC" pitchFamily="34" charset="-122"/>
                 <a:cs typeface="PingFang SC" pitchFamily="34" charset="-120"/>
               </a:rPr>
-              <a:t>约束条件：8 周工期 · 3–5 人团队 · 零预算演示 · 回答必须可溯源不编造</a:t>
+              <a:t>约束条件：8 周工期 · 3 人团队 · 零预算演示 · 回答必须可溯源不编造</a:t>
             </a:r>
             <a:endParaRPr lang="en-US" sz="1200" dirty="0"/>
           </a:p>

</xml_diff>

<commit_message>
fix: switch PPT font to Microsoft YaHei for cross-platform playback
</commit_message>
<xml_diff>
--- a/ppt/智问校园CampusMind答辩PPT.pptx
+++ b/ppt/智问校园CampusMind答辩PPT.pptx
@@ -168,7 +168,7 @@
                     <a:solidFill>
                       <a:srgbClr val="1C2333"/>
                     </a:solidFill>
-                    <a:latin typeface="Arial"/>
+                    <a:latin typeface="Microsoft YaHei"/>
                   </a:defRPr>
                 </a:pPr>
               </a:p>
@@ -257,7 +257,7 @@
                     <a:solidFill>
                       <a:srgbClr val="1C2333"/>
                     </a:solidFill>
-                    <a:latin typeface="Arial"/>
+                    <a:latin typeface="Microsoft YaHei"/>
                   </a:defRPr>
                 </a:pPr>
               </a:p>
@@ -325,7 +325,7 @@
                   <a:solidFill>
                     <a:srgbClr val="1C2333"/>
                   </a:solidFill>
-                  <a:latin typeface="Arial"/>
+                  <a:latin typeface="Microsoft YaHei"/>
                 </a:defRPr>
               </a:pPr>
             </a:p>
@@ -373,7 +373,7 @@
                 <a:solidFill>
                   <a:srgbClr val="6A7390"/>
                 </a:solidFill>
-                <a:latin typeface="Arial"/>
+                <a:latin typeface="Microsoft YaHei"/>
               </a:defRPr>
             </a:pPr>
             <a:endParaRPr lang="en-US"/>
@@ -455,7 +455,7 @@
                 <a:solidFill>
                   <a:srgbClr val="6A7390"/>
                 </a:solidFill>
-                <a:latin typeface="Arial"/>
+                <a:latin typeface="Microsoft YaHei"/>
               </a:defRPr>
             </a:pPr>
             <a:endParaRPr lang="en-US"/>
@@ -485,6 +485,8 @@
               <a:solidFill>
                 <a:srgbClr val="6A7390"/>
               </a:solidFill>
+              <a:latin typeface="Microsoft YaHei"/>
+              <a:cs typeface="Microsoft YaHei"/>
             </a:defRPr>
           </a:pPr>
           <a:endParaRPr lang="en-US"/>
@@ -2875,9 +2877,9 @@
                 <a:solidFill>
                   <a:srgbClr val="FFFFFF"/>
                 </a:solidFill>
-                <a:latin typeface="PingFang SC" pitchFamily="34" charset="0"/>
-                <a:ea typeface="PingFang SC" pitchFamily="34" charset="-122"/>
-                <a:cs typeface="PingFang SC" pitchFamily="34" charset="-120"/>
+                <a:latin typeface="Microsoft YaHei" pitchFamily="34" charset="0"/>
+                <a:ea typeface="Microsoft YaHei" pitchFamily="34" charset="-122"/>
+                <a:cs typeface="Microsoft YaHei" pitchFamily="34" charset="-120"/>
               </a:rPr>
               <a:t>智</a:t>
             </a:r>
@@ -2914,9 +2916,9 @@
                 <a:solidFill>
                   <a:srgbClr val="FFFFFF"/>
                 </a:solidFill>
-                <a:latin typeface="PingFang SC" pitchFamily="34" charset="0"/>
-                <a:ea typeface="PingFang SC" pitchFamily="34" charset="-122"/>
-                <a:cs typeface="PingFang SC" pitchFamily="34" charset="-120"/>
+                <a:latin typeface="Microsoft YaHei" pitchFamily="34" charset="0"/>
+                <a:ea typeface="Microsoft YaHei" pitchFamily="34" charset="-122"/>
+                <a:cs typeface="Microsoft YaHei" pitchFamily="34" charset="-120"/>
               </a:rPr>
               <a:t>智问校园 CampusMind</a:t>
             </a:r>
@@ -2953,9 +2955,9 @@
                 <a:solidFill>
                   <a:srgbClr val="C9D2F5"/>
                 </a:solidFill>
-                <a:latin typeface="PingFang SC" pitchFamily="34" charset="0"/>
-                <a:ea typeface="PingFang SC" pitchFamily="34" charset="-122"/>
-                <a:cs typeface="PingFang SC" pitchFamily="34" charset="-120"/>
+                <a:latin typeface="Microsoft YaHei" pitchFamily="34" charset="0"/>
+                <a:ea typeface="Microsoft YaHei" pitchFamily="34" charset="-122"/>
+                <a:cs typeface="Microsoft YaHei" pitchFamily="34" charset="-120"/>
               </a:rPr>
               <a:t>基于 AI + RAG 的校园智能问答系统 · 软件体系结构课程答辩</a:t>
             </a:r>
@@ -3019,9 +3021,9 @@
                 <a:solidFill>
                   <a:srgbClr val="AFBCF0"/>
                 </a:solidFill>
-                <a:latin typeface="PingFang SC" pitchFamily="34" charset="0"/>
-                <a:ea typeface="PingFang SC" pitchFamily="34" charset="-122"/>
-                <a:cs typeface="PingFang SC" pitchFamily="34" charset="-120"/>
+                <a:latin typeface="Microsoft YaHei" pitchFamily="34" charset="0"/>
+                <a:ea typeface="Microsoft YaHei" pitchFamily="34" charset="-122"/>
+                <a:cs typeface="Microsoft YaHei" pitchFamily="34" charset="-120"/>
               </a:rPr>
               <a:t>混合检索 BM25 ∥ 向量</a:t>
             </a:r>
@@ -3085,9 +3087,9 @@
                 <a:solidFill>
                   <a:srgbClr val="AFBCF0"/>
                 </a:solidFill>
-                <a:latin typeface="PingFang SC" pitchFamily="34" charset="0"/>
-                <a:ea typeface="PingFang SC" pitchFamily="34" charset="-122"/>
-                <a:cs typeface="PingFang SC" pitchFamily="34" charset="-120"/>
+                <a:latin typeface="Microsoft YaHei" pitchFamily="34" charset="0"/>
+                <a:ea typeface="Microsoft YaHei" pitchFamily="34" charset="-122"/>
+                <a:cs typeface="Microsoft YaHei" pitchFamily="34" charset="-120"/>
               </a:rPr>
               <a:t>RRF 融合 + 重排序</a:t>
             </a:r>
@@ -3151,9 +3153,9 @@
                 <a:solidFill>
                   <a:srgbClr val="AFBCF0"/>
                 </a:solidFill>
-                <a:latin typeface="PingFang SC" pitchFamily="34" charset="0"/>
-                <a:ea typeface="PingFang SC" pitchFamily="34" charset="-122"/>
-                <a:cs typeface="PingFang SC" pitchFamily="34" charset="-120"/>
+                <a:latin typeface="Microsoft YaHei" pitchFamily="34" charset="0"/>
+                <a:ea typeface="Microsoft YaHei" pitchFamily="34" charset="-122"/>
+                <a:cs typeface="Microsoft YaHei" pitchFamily="34" charset="-120"/>
               </a:rPr>
               <a:t>SSE 流式生成</a:t>
             </a:r>
@@ -3217,9 +3219,9 @@
                 <a:solidFill>
                   <a:srgbClr val="AFBCF0"/>
                 </a:solidFill>
-                <a:latin typeface="PingFang SC" pitchFamily="34" charset="0"/>
-                <a:ea typeface="PingFang SC" pitchFamily="34" charset="-122"/>
-                <a:cs typeface="PingFang SC" pitchFamily="34" charset="-120"/>
+                <a:latin typeface="Microsoft YaHei" pitchFamily="34" charset="0"/>
+                <a:ea typeface="Microsoft YaHei" pitchFamily="34" charset="-122"/>
+                <a:cs typeface="Microsoft YaHei" pitchFamily="34" charset="-120"/>
               </a:rPr>
               <a:t>引用溯源</a:t>
             </a:r>
@@ -3259,9 +3261,9 @@
                 <a:solidFill>
                   <a:srgbClr val="8B97C9"/>
                 </a:solidFill>
-                <a:latin typeface="PingFang SC" pitchFamily="34" charset="0"/>
-                <a:ea typeface="PingFang SC" pitchFamily="34" charset="-122"/>
-                <a:cs typeface="PingFang SC" pitchFamily="34" charset="-120"/>
+                <a:latin typeface="Microsoft YaHei" pitchFamily="34" charset="0"/>
+                <a:ea typeface="Microsoft YaHei" pitchFamily="34" charset="-122"/>
+                <a:cs typeface="Microsoft YaHei" pitchFamily="34" charset="-120"/>
               </a:rPr>
               <a:t>汇报人：王若璋（组长/架构） · 何俐 · 郭祚梁</a:t>
             </a:r>
@@ -3279,9 +3281,9 @@
                 <a:solidFill>
                   <a:srgbClr val="8B97C9"/>
                 </a:solidFill>
-                <a:latin typeface="PingFang SC" pitchFamily="34" charset="0"/>
-                <a:ea typeface="PingFang SC" pitchFamily="34" charset="-122"/>
-                <a:cs typeface="PingFang SC" pitchFamily="34" charset="-120"/>
+                <a:latin typeface="Microsoft YaHei" pitchFamily="34" charset="0"/>
+                <a:ea typeface="Microsoft YaHei" pitchFamily="34" charset="-122"/>
+                <a:cs typeface="Microsoft YaHei" pitchFamily="34" charset="-120"/>
               </a:rPr>
               <a:t>2026 年 9 月 18 日</a:t>
             </a:r>
@@ -3350,9 +3352,9 @@
                 <a:solidFill>
                   <a:srgbClr val="1C2333"/>
                 </a:solidFill>
-                <a:latin typeface="PingFang SC" pitchFamily="34" charset="0"/>
-                <a:ea typeface="PingFang SC" pitchFamily="34" charset="-122"/>
-                <a:cs typeface="PingFang SC" pitchFamily="34" charset="-120"/>
+                <a:latin typeface="Microsoft YaHei" pitchFamily="34" charset="0"/>
+                <a:ea typeface="Microsoft YaHei" pitchFamily="34" charset="-122"/>
+                <a:cs typeface="Microsoft YaHei" pitchFamily="34" charset="-120"/>
               </a:rPr>
               <a:t>系统演示：流式回答与运行看板</a:t>
             </a:r>
@@ -3389,9 +3391,9 @@
                 <a:solidFill>
                   <a:srgbClr val="6A7390"/>
                 </a:solidFill>
-                <a:latin typeface="PingFang SC" pitchFamily="34" charset="0"/>
-                <a:ea typeface="PingFang SC" pitchFamily="34" charset="-122"/>
-                <a:cs typeface="PingFang SC" pitchFamily="34" charset="-120"/>
+                <a:latin typeface="Microsoft YaHei" pitchFamily="34" charset="0"/>
+                <a:ea typeface="Microsoft YaHei" pitchFamily="34" charset="-122"/>
+                <a:cs typeface="Microsoft YaHei" pitchFamily="34" charset="-120"/>
               </a:rPr>
               <a:t>实机截图 —— 完整演示见 60 秒录屏 video/demo_frontend_v2.webm</a:t>
             </a:r>
@@ -3428,9 +3430,9 @@
                 <a:solidFill>
                   <a:srgbClr val="6A7390"/>
                 </a:solidFill>
-                <a:latin typeface="PingFang SC" pitchFamily="34" charset="0"/>
-                <a:ea typeface="PingFang SC" pitchFamily="34" charset="-122"/>
-                <a:cs typeface="PingFang SC" pitchFamily="34" charset="-120"/>
+                <a:latin typeface="Microsoft YaHei" pitchFamily="34" charset="0"/>
+                <a:ea typeface="Microsoft YaHei" pitchFamily="34" charset="-122"/>
+                <a:cs typeface="Microsoft YaHei" pitchFamily="34" charset="-120"/>
               </a:rPr>
               <a:t>10</a:t>
             </a:r>
@@ -3547,9 +3549,9 @@
                 <a:solidFill>
                   <a:srgbClr val="3B5BFD"/>
                 </a:solidFill>
-                <a:latin typeface="PingFang SC" pitchFamily="34" charset="0"/>
-                <a:ea typeface="PingFang SC" pitchFamily="34" charset="-122"/>
-                <a:cs typeface="PingFang SC" pitchFamily="34" charset="-120"/>
+                <a:latin typeface="Microsoft YaHei" pitchFamily="34" charset="0"/>
+                <a:ea typeface="Microsoft YaHei" pitchFamily="34" charset="-122"/>
+                <a:cs typeface="Microsoft YaHei" pitchFamily="34" charset="-120"/>
               </a:rPr>
               <a:t>流式回答 + 引用溯源卡片</a:t>
             </a:r>
@@ -3666,9 +3668,9 @@
                 <a:solidFill>
                   <a:srgbClr val="3B5BFD"/>
                 </a:solidFill>
-                <a:latin typeface="PingFang SC" pitchFamily="34" charset="0"/>
-                <a:ea typeface="PingFang SC" pitchFamily="34" charset="-122"/>
-                <a:cs typeface="PingFang SC" pitchFamily="34" charset="-120"/>
+                <a:latin typeface="Microsoft YaHei" pitchFamily="34" charset="0"/>
+                <a:ea typeface="Microsoft YaHei" pitchFamily="34" charset="-122"/>
+                <a:cs typeface="Microsoft YaHei" pitchFamily="34" charset="-120"/>
               </a:rPr>
               <a:t>运行看板：命中率/时延/热点</a:t>
             </a:r>
@@ -3705,9 +3707,9 @@
                 <a:solidFill>
                   <a:srgbClr val="3B5BFD"/>
                 </a:solidFill>
-                <a:latin typeface="PingFang SC" pitchFamily="34" charset="0"/>
-                <a:ea typeface="PingFang SC" pitchFamily="34" charset="-122"/>
-                <a:cs typeface="PingFang SC" pitchFamily="34" charset="-120"/>
+                <a:latin typeface="Microsoft YaHei" pitchFamily="34" charset="0"/>
+                <a:ea typeface="Microsoft YaHei" pitchFamily="34" charset="-122"/>
+                <a:cs typeface="Microsoft YaHei" pitchFamily="34" charset="-120"/>
               </a:rPr>
               <a:t>100%</a:t>
             </a:r>
@@ -3744,9 +3746,9 @@
                 <a:solidFill>
                   <a:srgbClr val="1C2333"/>
                 </a:solidFill>
-                <a:latin typeface="PingFang SC" pitchFamily="34" charset="0"/>
-                <a:ea typeface="PingFang SC" pitchFamily="34" charset="-122"/>
-                <a:cs typeface="PingFang SC" pitchFamily="34" charset="-120"/>
+                <a:latin typeface="Microsoft YaHei" pitchFamily="34" charset="0"/>
+                <a:ea typeface="Microsoft YaHei" pitchFamily="34" charset="-122"/>
+                <a:cs typeface="Microsoft YaHei" pitchFamily="34" charset="-120"/>
               </a:rPr>
               <a:t>知识命中率（演示会话）</a:t>
             </a:r>
@@ -3783,9 +3785,9 @@
                 <a:solidFill>
                   <a:srgbClr val="FF8A3D"/>
                 </a:solidFill>
-                <a:latin typeface="PingFang SC" pitchFamily="34" charset="0"/>
-                <a:ea typeface="PingFang SC" pitchFamily="34" charset="-122"/>
-                <a:cs typeface="PingFang SC" pitchFamily="34" charset="-120"/>
+                <a:latin typeface="Microsoft YaHei" pitchFamily="34" charset="0"/>
+                <a:ea typeface="Microsoft YaHei" pitchFamily="34" charset="-122"/>
+                <a:cs typeface="Microsoft YaHei" pitchFamily="34" charset="-120"/>
               </a:rPr>
               <a:t>4.5ms</a:t>
             </a:r>
@@ -3822,9 +3824,9 @@
                 <a:solidFill>
                   <a:srgbClr val="1C2333"/>
                 </a:solidFill>
-                <a:latin typeface="PingFang SC" pitchFamily="34" charset="0"/>
-                <a:ea typeface="PingFang SC" pitchFamily="34" charset="-122"/>
-                <a:cs typeface="PingFang SC" pitchFamily="34" charset="-120"/>
+                <a:latin typeface="Microsoft YaHei" pitchFamily="34" charset="0"/>
+                <a:ea typeface="Microsoft YaHei" pitchFamily="34" charset="-122"/>
+                <a:cs typeface="Microsoft YaHei" pitchFamily="34" charset="-120"/>
               </a:rPr>
               <a:t>新知识即时检索命中</a:t>
             </a:r>
@@ -3861,9 +3863,9 @@
                 <a:solidFill>
                   <a:srgbClr val="7C4DFF"/>
                 </a:solidFill>
-                <a:latin typeface="PingFang SC" pitchFamily="34" charset="0"/>
-                <a:ea typeface="PingFang SC" pitchFamily="34" charset="-122"/>
-                <a:cs typeface="PingFang SC" pitchFamily="34" charset="-120"/>
+                <a:latin typeface="Microsoft YaHei" pitchFamily="34" charset="0"/>
+                <a:ea typeface="Microsoft YaHei" pitchFamily="34" charset="-122"/>
+                <a:cs typeface="Microsoft YaHei" pitchFamily="34" charset="-120"/>
               </a:rPr>
               <a:t>v6</a:t>
             </a:r>
@@ -3900,9 +3902,9 @@
                 <a:solidFill>
                   <a:srgbClr val="1C2333"/>
                 </a:solidFill>
-                <a:latin typeface="PingFang SC" pitchFamily="34" charset="0"/>
-                <a:ea typeface="PingFang SC" pitchFamily="34" charset="-122"/>
-                <a:cs typeface="PingFang SC" pitchFamily="34" charset="-120"/>
+                <a:latin typeface="Microsoft YaHei" pitchFamily="34" charset="0"/>
+                <a:ea typeface="Microsoft YaHei" pitchFamily="34" charset="-122"/>
+                <a:cs typeface="Microsoft YaHei" pitchFamily="34" charset="-120"/>
               </a:rPr>
               <a:t>索引版本(顶栏可见)</a:t>
             </a:r>
@@ -3971,9 +3973,9 @@
                 <a:solidFill>
                   <a:srgbClr val="1C2333"/>
                 </a:solidFill>
-                <a:latin typeface="PingFang SC" pitchFamily="34" charset="0"/>
-                <a:ea typeface="PingFang SC" pitchFamily="34" charset="-122"/>
-                <a:cs typeface="PingFang SC" pitchFamily="34" charset="-120"/>
+                <a:latin typeface="Microsoft YaHei" pitchFamily="34" charset="0"/>
+                <a:ea typeface="Microsoft YaHei" pitchFamily="34" charset="-122"/>
+                <a:cs typeface="Microsoft YaHei" pitchFamily="34" charset="-120"/>
               </a:rPr>
               <a:t>知识热更新闭环：录入即可答</a:t>
             </a:r>
@@ -4010,9 +4012,9 @@
                 <a:solidFill>
                   <a:srgbClr val="6A7390"/>
                 </a:solidFill>
-                <a:latin typeface="PingFang SC" pitchFamily="34" charset="0"/>
-                <a:ea typeface="PingFang SC" pitchFamily="34" charset="-122"/>
-                <a:cs typeface="PingFang SC" pitchFamily="34" charset="-120"/>
+                <a:latin typeface="Microsoft YaHei" pitchFamily="34" charset="0"/>
+                <a:ea typeface="Microsoft YaHei" pitchFamily="34" charset="-122"/>
+                <a:cs typeface="Microsoft YaHei" pitchFamily="34" charset="-120"/>
               </a:rPr>
               <a:t>录屏实况：新增「快递驿站取件」条目 → 索引热重建 → 立即命中回答</a:t>
             </a:r>
@@ -4049,9 +4051,9 @@
                 <a:solidFill>
                   <a:srgbClr val="6A7390"/>
                 </a:solidFill>
-                <a:latin typeface="PingFang SC" pitchFamily="34" charset="0"/>
-                <a:ea typeface="PingFang SC" pitchFamily="34" charset="-122"/>
-                <a:cs typeface="PingFang SC" pitchFamily="34" charset="-120"/>
+                <a:latin typeface="Microsoft YaHei" pitchFamily="34" charset="0"/>
+                <a:ea typeface="Microsoft YaHei" pitchFamily="34" charset="-122"/>
+                <a:cs typeface="Microsoft YaHei" pitchFamily="34" charset="-120"/>
               </a:rPr>
               <a:t>11</a:t>
             </a:r>
@@ -4115,9 +4117,9 @@
                 <a:solidFill>
                   <a:srgbClr val="FFFFFF"/>
                 </a:solidFill>
-                <a:latin typeface="PingFang SC" pitchFamily="34" charset="0"/>
-                <a:ea typeface="PingFang SC" pitchFamily="34" charset="-122"/>
-                <a:cs typeface="PingFang SC" pitchFamily="34" charset="-120"/>
+                <a:latin typeface="Microsoft YaHei" pitchFamily="34" charset="0"/>
+                <a:ea typeface="Microsoft YaHei" pitchFamily="34" charset="-122"/>
+                <a:cs typeface="Microsoft YaHei" pitchFamily="34" charset="-120"/>
               </a:rPr>
               <a:t>1</a:t>
             </a:r>
@@ -4178,9 +4180,9 @@
                 <a:solidFill>
                   <a:srgbClr val="1C2333"/>
                 </a:solidFill>
-                <a:latin typeface="PingFang SC" pitchFamily="34" charset="0"/>
-                <a:ea typeface="PingFang SC" pitchFamily="34" charset="-122"/>
-                <a:cs typeface="PingFang SC" pitchFamily="34" charset="-120"/>
+                <a:latin typeface="Microsoft YaHei" pitchFamily="34" charset="0"/>
+                <a:ea typeface="Microsoft YaHei" pitchFamily="34" charset="-122"/>
+                <a:cs typeface="Microsoft YaHei" pitchFamily="34" charset="-120"/>
               </a:rPr>
               <a:t>录入新知识</a:t>
             </a:r>
@@ -4220,9 +4222,9 @@
                 <a:solidFill>
                   <a:srgbClr val="6A7390"/>
                 </a:solidFill>
-                <a:latin typeface="PingFang SC" pitchFamily="34" charset="0"/>
-                <a:ea typeface="PingFang SC" pitchFamily="34" charset="-122"/>
-                <a:cs typeface="PingFang SC" pitchFamily="34" charset="-120"/>
+                <a:latin typeface="Microsoft YaHei" pitchFamily="34" charset="0"/>
+                <a:ea typeface="Microsoft YaHei" pitchFamily="34" charset="-122"/>
+                <a:cs typeface="Microsoft YaHei" pitchFamily="34" charset="-120"/>
               </a:rPr>
               <a:t>管理端填写问法/答案/来源</a:t>
             </a:r>
@@ -4286,9 +4288,9 @@
                 <a:solidFill>
                   <a:srgbClr val="FFFFFF"/>
                 </a:solidFill>
-                <a:latin typeface="PingFang SC" pitchFamily="34" charset="0"/>
-                <a:ea typeface="PingFang SC" pitchFamily="34" charset="-122"/>
-                <a:cs typeface="PingFang SC" pitchFamily="34" charset="-120"/>
+                <a:latin typeface="Microsoft YaHei" pitchFamily="34" charset="0"/>
+                <a:ea typeface="Microsoft YaHei" pitchFamily="34" charset="-122"/>
+                <a:cs typeface="Microsoft YaHei" pitchFamily="34" charset="-120"/>
               </a:rPr>
               <a:t>2</a:t>
             </a:r>
@@ -4349,9 +4351,9 @@
                 <a:solidFill>
                   <a:srgbClr val="1C2333"/>
                 </a:solidFill>
-                <a:latin typeface="PingFang SC" pitchFamily="34" charset="0"/>
-                <a:ea typeface="PingFang SC" pitchFamily="34" charset="-122"/>
-                <a:cs typeface="PingFang SC" pitchFamily="34" charset="-120"/>
+                <a:latin typeface="Microsoft YaHei" pitchFamily="34" charset="0"/>
+                <a:ea typeface="Microsoft YaHei" pitchFamily="34" charset="-122"/>
+                <a:cs typeface="Microsoft YaHei" pitchFamily="34" charset="-120"/>
               </a:rPr>
               <a:t>索引热重建</a:t>
             </a:r>
@@ -4391,9 +4393,9 @@
                 <a:solidFill>
                   <a:srgbClr val="6A7390"/>
                 </a:solidFill>
-                <a:latin typeface="PingFang SC" pitchFamily="34" charset="0"/>
-                <a:ea typeface="PingFang SC" pitchFamily="34" charset="-122"/>
-                <a:cs typeface="PingFang SC" pitchFamily="34" charset="-120"/>
+                <a:latin typeface="Microsoft YaHei" pitchFamily="34" charset="0"/>
+                <a:ea typeface="Microsoft YaHei" pitchFamily="34" charset="-122"/>
+                <a:cs typeface="Microsoft YaHei" pitchFamily="34" charset="-120"/>
               </a:rPr>
               <a:t>136 chunks · 版本递增 · 无需重启</a:t>
             </a:r>
@@ -4457,9 +4459,9 @@
                 <a:solidFill>
                   <a:srgbClr val="FFFFFF"/>
                 </a:solidFill>
-                <a:latin typeface="PingFang SC" pitchFamily="34" charset="0"/>
-                <a:ea typeface="PingFang SC" pitchFamily="34" charset="-122"/>
-                <a:cs typeface="PingFang SC" pitchFamily="34" charset="-120"/>
+                <a:latin typeface="Microsoft YaHei" pitchFamily="34" charset="0"/>
+                <a:ea typeface="Microsoft YaHei" pitchFamily="34" charset="-122"/>
+                <a:cs typeface="Microsoft YaHei" pitchFamily="34" charset="-120"/>
               </a:rPr>
               <a:t>3</a:t>
             </a:r>
@@ -4520,9 +4522,9 @@
                 <a:solidFill>
                   <a:srgbClr val="1C2333"/>
                 </a:solidFill>
-                <a:latin typeface="PingFang SC" pitchFamily="34" charset="0"/>
-                <a:ea typeface="PingFang SC" pitchFamily="34" charset="-122"/>
-                <a:cs typeface="PingFang SC" pitchFamily="34" charset="-120"/>
+                <a:latin typeface="Microsoft YaHei" pitchFamily="34" charset="0"/>
+                <a:ea typeface="Microsoft YaHei" pitchFamily="34" charset="-122"/>
+                <a:cs typeface="Microsoft YaHei" pitchFamily="34" charset="-120"/>
               </a:rPr>
               <a:t>提问验证</a:t>
             </a:r>
@@ -4562,9 +4564,9 @@
                 <a:solidFill>
                   <a:srgbClr val="6A7390"/>
                 </a:solidFill>
-                <a:latin typeface="PingFang SC" pitchFamily="34" charset="0"/>
-                <a:ea typeface="PingFang SC" pitchFamily="34" charset="-122"/>
-                <a:cs typeface="PingFang SC" pitchFamily="34" charset="-120"/>
+                <a:latin typeface="Microsoft YaHei" pitchFamily="34" charset="0"/>
+                <a:ea typeface="Microsoft YaHei" pitchFamily="34" charset="-122"/>
+                <a:cs typeface="Microsoft YaHei" pitchFamily="34" charset="-120"/>
               </a:rPr>
               <a:t>「快递驿站怎么取件」</a:t>
             </a:r>
@@ -4628,9 +4630,9 @@
                 <a:solidFill>
                   <a:srgbClr val="FFFFFF"/>
                 </a:solidFill>
-                <a:latin typeface="PingFang SC" pitchFamily="34" charset="0"/>
-                <a:ea typeface="PingFang SC" pitchFamily="34" charset="-122"/>
-                <a:cs typeface="PingFang SC" pitchFamily="34" charset="-120"/>
+                <a:latin typeface="Microsoft YaHei" pitchFamily="34" charset="0"/>
+                <a:ea typeface="Microsoft YaHei" pitchFamily="34" charset="-122"/>
+                <a:cs typeface="Microsoft YaHei" pitchFamily="34" charset="-120"/>
               </a:rPr>
               <a:t>4</a:t>
             </a:r>
@@ -4667,9 +4669,9 @@
                 <a:solidFill>
                   <a:srgbClr val="1C2333"/>
                 </a:solidFill>
-                <a:latin typeface="PingFang SC" pitchFamily="34" charset="0"/>
-                <a:ea typeface="PingFang SC" pitchFamily="34" charset="-122"/>
-                <a:cs typeface="PingFang SC" pitchFamily="34" charset="-120"/>
+                <a:latin typeface="Microsoft YaHei" pitchFamily="34" charset="0"/>
+                <a:ea typeface="Microsoft YaHei" pitchFamily="34" charset="-122"/>
+                <a:cs typeface="Microsoft YaHei" pitchFamily="34" charset="-120"/>
               </a:rPr>
               <a:t>命中回答</a:t>
             </a:r>
@@ -4709,9 +4711,9 @@
                 <a:solidFill>
                   <a:srgbClr val="6A7390"/>
                 </a:solidFill>
-                <a:latin typeface="PingFang SC" pitchFamily="34" charset="0"/>
-                <a:ea typeface="PingFang SC" pitchFamily="34" charset="-122"/>
-                <a:cs typeface="PingFang SC" pitchFamily="34" charset="-120"/>
+                <a:latin typeface="Microsoft YaHei" pitchFamily="34" charset="0"/>
+                <a:ea typeface="Microsoft YaHei" pitchFamily="34" charset="-122"/>
+                <a:cs typeface="Microsoft YaHei" pitchFamily="34" charset="-120"/>
               </a:rPr>
               <a:t>BM25#1 · VEC#1 · 置信 100%</a:t>
             </a:r>
@@ -4828,9 +4830,9 @@
                 <a:solidFill>
                   <a:srgbClr val="3B5BFD"/>
                 </a:solidFill>
-                <a:latin typeface="PingFang SC" pitchFamily="34" charset="0"/>
-                <a:ea typeface="PingFang SC" pitchFamily="34" charset="-122"/>
-                <a:cs typeface="PingFang SC" pitchFamily="34" charset="-120"/>
+                <a:latin typeface="Microsoft YaHei" pitchFamily="34" charset="0"/>
+                <a:ea typeface="Microsoft YaHei" pitchFamily="34" charset="-122"/>
+                <a:cs typeface="Microsoft YaHei" pitchFamily="34" charset="-120"/>
               </a:rPr>
               <a:t>录屏：管理端录入与提交</a:t>
             </a:r>
@@ -4947,9 +4949,9 @@
                 <a:solidFill>
                   <a:srgbClr val="3B5BFD"/>
                 </a:solidFill>
-                <a:latin typeface="PingFang SC" pitchFamily="34" charset="0"/>
-                <a:ea typeface="PingFang SC" pitchFamily="34" charset="-122"/>
-                <a:cs typeface="PingFang SC" pitchFamily="34" charset="-120"/>
+                <a:latin typeface="Microsoft YaHei" pitchFamily="34" charset="0"/>
+                <a:ea typeface="Microsoft YaHei" pitchFamily="34" charset="-122"/>
+                <a:cs typeface="Microsoft YaHei" pitchFamily="34" charset="-120"/>
               </a:rPr>
               <a:t>录屏：新知识被立即检索回答</a:t>
             </a:r>
@@ -5018,9 +5020,9 @@
                 <a:solidFill>
                   <a:srgbClr val="1C2333"/>
                 </a:solidFill>
-                <a:latin typeface="PingFang SC" pitchFamily="34" charset="0"/>
-                <a:ea typeface="PingFang SC" pitchFamily="34" charset="-122"/>
-                <a:cs typeface="PingFang SC" pitchFamily="34" charset="-120"/>
+                <a:latin typeface="Microsoft YaHei" pitchFamily="34" charset="0"/>
+                <a:ea typeface="Microsoft YaHei" pitchFamily="34" charset="-122"/>
+                <a:cs typeface="Microsoft YaHei" pitchFamily="34" charset="-120"/>
               </a:rPr>
               <a:t>评测矩阵：62 条口语化改写 × 四条链路</a:t>
             </a:r>
@@ -5057,9 +5059,9 @@
                 <a:solidFill>
                   <a:srgbClr val="6A7390"/>
                 </a:solidFill>
-                <a:latin typeface="PingFang SC" pitchFamily="34" charset="0"/>
-                <a:ea typeface="PingFang SC" pitchFamily="34" charset="-122"/>
-                <a:cs typeface="PingFang SC" pitchFamily="34" charset="-120"/>
+                <a:latin typeface="Microsoft YaHei" pitchFamily="34" charset="0"/>
+                <a:ea typeface="Microsoft YaHei" pitchFamily="34" charset="-122"/>
+                <a:cs typeface="Microsoft YaHei" pitchFamily="34" charset="-120"/>
               </a:rPr>
               <a:t>评估单位为文档级；向量通道为 TF-IDF 词袋（非语义嵌入，如实标注）</a:t>
             </a:r>
@@ -5096,9 +5098,9 @@
                 <a:solidFill>
                   <a:srgbClr val="6A7390"/>
                 </a:solidFill>
-                <a:latin typeface="PingFang SC" pitchFamily="34" charset="0"/>
-                <a:ea typeface="PingFang SC" pitchFamily="34" charset="-122"/>
-                <a:cs typeface="PingFang SC" pitchFamily="34" charset="-120"/>
+                <a:latin typeface="Microsoft YaHei" pitchFamily="34" charset="0"/>
+                <a:ea typeface="Microsoft YaHei" pitchFamily="34" charset="-122"/>
+                <a:cs typeface="Microsoft YaHei" pitchFamily="34" charset="-120"/>
               </a:rPr>
               <a:t>12</a:t>
             </a:r>
@@ -5151,9 +5153,9 @@
                 <a:solidFill>
                   <a:srgbClr val="6A7390"/>
                 </a:solidFill>
-                <a:latin typeface="PingFang SC" pitchFamily="34" charset="0"/>
-                <a:ea typeface="PingFang SC" pitchFamily="34" charset="-122"/>
-                <a:cs typeface="PingFang SC" pitchFamily="34" charset="-120"/>
+                <a:latin typeface="Microsoft YaHei" pitchFamily="34" charset="0"/>
+                <a:ea typeface="Microsoft YaHei" pitchFamily="34" charset="-122"/>
+                <a:cs typeface="Microsoft YaHei" pitchFamily="34" charset="-120"/>
               </a:rPr>
               <a:t>数据源：scripts/eval_matrix.py，n=62，统一文档级去重口径，MRR：0.884 / 0.844 / 0.884 / 0.815</a:t>
             </a:r>
@@ -5230,9 +5232,9 @@
                 <a:solidFill>
                   <a:srgbClr val="FF8A3D"/>
                 </a:solidFill>
-                <a:latin typeface="PingFang SC" pitchFamily="34" charset="0"/>
-                <a:ea typeface="PingFang SC" pitchFamily="34" charset="-122"/>
-                <a:cs typeface="PingFang SC" pitchFamily="34" charset="-120"/>
+                <a:latin typeface="Microsoft YaHei" pitchFamily="34" charset="0"/>
+                <a:ea typeface="Microsoft YaHei" pitchFamily="34" charset="-122"/>
+                <a:cs typeface="Microsoft YaHei" pitchFamily="34" charset="-120"/>
               </a:rPr>
               <a:t>调优过程修复三个真实缺陷：</a:t>
             </a:r>
@@ -5253,9 +5255,9 @@
                 <a:solidFill>
                   <a:srgbClr val="1C2333"/>
                 </a:solidFill>
-                <a:latin typeface="PingFang SC" pitchFamily="34" charset="0"/>
-                <a:ea typeface="PingFang SC" pitchFamily="34" charset="-122"/>
-                <a:cs typeface="PingFang SC" pitchFamily="34" charset="-120"/>
+                <a:latin typeface="Microsoft YaHei" pitchFamily="34" charset="0"/>
+                <a:ea typeface="Microsoft YaHei" pitchFamily="34" charset="-122"/>
+                <a:cs typeface="Microsoft YaHei" pitchFamily="34" charset="-120"/>
               </a:rPr>
               <a:t>① 停用词表构造 bug（整串未 split）② RRF 候选池截断压缩文档多样性 ③ 缺文档级去重（引用卡片重复根因），统一口径后 RRF 实测 98.4%（旧口径 95.2% 存在重复占位失真）</a:t>
             </a:r>
@@ -5332,9 +5334,9 @@
                 <a:solidFill>
                   <a:srgbClr val="FF8A3D"/>
                 </a:solidFill>
-                <a:latin typeface="PingFang SC" pitchFamily="34" charset="0"/>
-                <a:ea typeface="PingFang SC" pitchFamily="34" charset="-122"/>
-                <a:cs typeface="PingFang SC" pitchFamily="34" charset="-120"/>
+                <a:latin typeface="Microsoft YaHei" pitchFamily="34" charset="0"/>
+                <a:ea typeface="Microsoft YaHei" pitchFamily="34" charset="-122"/>
+                <a:cs typeface="Microsoft YaHei" pitchFamily="34" charset="-120"/>
               </a:rPr>
               <a:t>实证结论：</a:t>
             </a:r>
@@ -5352,9 +5354,9 @@
                 <a:solidFill>
                   <a:srgbClr val="C9D2F5"/>
                 </a:solidFill>
-                <a:latin typeface="PingFang SC" pitchFamily="34" charset="0"/>
-                <a:ea typeface="PingFang SC" pitchFamily="34" charset="-122"/>
-                <a:cs typeface="PingFang SC" pitchFamily="34" charset="-120"/>
+                <a:latin typeface="Microsoft YaHei" pitchFamily="34" charset="0"/>
+                <a:ea typeface="Microsoft YaHei" pitchFamily="34" charset="-122"/>
+                <a:cs typeface="Microsoft YaHei" pitchFamily="34" charset="-120"/>
               </a:rPr>
               <a:t>BM25 对关键词密集型规章问题最好；TF-IDF 向量补充另一视角但未稳定超过 BM25；轻量 Reranker 实测无收益，默认关闭保持 Provider 化，待替换 Cross-Encoder 后再评估</a:t>
             </a:r>
@@ -5423,9 +5425,9 @@
                 <a:solidFill>
                   <a:srgbClr val="1C2333"/>
                 </a:solidFill>
-                <a:latin typeface="PingFang SC" pitchFamily="34" charset="0"/>
-                <a:ea typeface="PingFang SC" pitchFamily="34" charset="-122"/>
-                <a:cs typeface="PingFang SC" pitchFamily="34" charset="-120"/>
+                <a:latin typeface="Microsoft YaHei" pitchFamily="34" charset="0"/>
+                <a:ea typeface="Microsoft YaHei" pitchFamily="34" charset="-122"/>
+                <a:cs typeface="Microsoft YaHei" pitchFamily="34" charset="-120"/>
               </a:rPr>
               <a:t>性能基准：检索与全链路拆分实测</a:t>
             </a:r>
@@ -5462,9 +5464,9 @@
                 <a:solidFill>
                   <a:srgbClr val="6A7390"/>
                 </a:solidFill>
-                <a:latin typeface="PingFang SC" pitchFamily="34" charset="0"/>
-                <a:ea typeface="PingFang SC" pitchFamily="34" charset="-122"/>
-                <a:cs typeface="PingFang SC" pitchFamily="34" charset="-120"/>
+                <a:latin typeface="Microsoft YaHei" pitchFamily="34" charset="0"/>
+                <a:ea typeface="Microsoft YaHei" pitchFamily="34" charset="-122"/>
+                <a:cs typeface="Microsoft YaHei" pitchFamily="34" charset="-120"/>
               </a:rPr>
               <a:t>retrieval-only 进程内直调；local-extractive E2E 含检索+流式生成+落库（HTTP，并发 20）</a:t>
             </a:r>
@@ -5501,9 +5503,9 @@
                 <a:solidFill>
                   <a:srgbClr val="6A7390"/>
                 </a:solidFill>
-                <a:latin typeface="PingFang SC" pitchFamily="34" charset="0"/>
-                <a:ea typeface="PingFang SC" pitchFamily="34" charset="-122"/>
-                <a:cs typeface="PingFang SC" pitchFamily="34" charset="-120"/>
+                <a:latin typeface="Microsoft YaHei" pitchFamily="34" charset="0"/>
+                <a:ea typeface="Microsoft YaHei" pitchFamily="34" charset="-122"/>
+                <a:cs typeface="Microsoft YaHei" pitchFamily="34" charset="-120"/>
               </a:rPr>
               <a:t>13</a:t>
             </a:r>
@@ -5556,16 +5558,16 @@
                           <a:solidFill>
                             <a:srgbClr val="FFFFFF"/>
                           </a:solidFill>
-                          <a:latin typeface="PingFang SC" pitchFamily="34" charset="0"/>
-                          <a:ea typeface="PingFang SC" pitchFamily="34" charset="-122"/>
-                          <a:cs typeface="PingFang SC" pitchFamily="34" charset="-120"/>
+                          <a:latin typeface="Microsoft YaHei" pitchFamily="34" charset="0"/>
+                          <a:ea typeface="Microsoft YaHei" pitchFamily="34" charset="-122"/>
+                          <a:cs typeface="Microsoft YaHei" pitchFamily="34" charset="-120"/>
                         </a:rPr>
                         <a:t>基准</a:t>
                       </a:r>
                       <a:endParaRPr lang="en-US" sz="1200" dirty="0">
-                        <a:latin typeface="PingFang SC" charset="0"/>
-                        <a:ea typeface="PingFang SC" charset="0"/>
-                        <a:cs typeface="PingFang SC" charset="0"/>
+                        <a:latin typeface="Microsoft YaHei" charset="0"/>
+                        <a:ea typeface="Microsoft YaHei" charset="0"/>
+                        <a:cs typeface="Microsoft YaHei" charset="0"/>
                       </a:endParaRPr>
                     </a:p>
                   </a:txBody>
@@ -5624,16 +5626,16 @@
                           <a:solidFill>
                             <a:srgbClr val="FFFFFF"/>
                           </a:solidFill>
-                          <a:latin typeface="PingFang SC" pitchFamily="34" charset="0"/>
-                          <a:ea typeface="PingFang SC" pitchFamily="34" charset="-122"/>
-                          <a:cs typeface="PingFang SC" pitchFamily="34" charset="-120"/>
+                          <a:latin typeface="Microsoft YaHei" pitchFamily="34" charset="0"/>
+                          <a:ea typeface="Microsoft YaHei" pitchFamily="34" charset="-122"/>
+                          <a:cs typeface="Microsoft YaHei" pitchFamily="34" charset="-120"/>
                         </a:rPr>
                         <a:t>样本</a:t>
                       </a:r>
                       <a:endParaRPr lang="en-US" sz="1200" dirty="0">
-                        <a:latin typeface="PingFang SC" charset="0"/>
-                        <a:ea typeface="PingFang SC" charset="0"/>
-                        <a:cs typeface="PingFang SC" charset="0"/>
+                        <a:latin typeface="Microsoft YaHei" charset="0"/>
+                        <a:ea typeface="Microsoft YaHei" charset="0"/>
+                        <a:cs typeface="Microsoft YaHei" charset="0"/>
                       </a:endParaRPr>
                     </a:p>
                   </a:txBody>
@@ -5692,16 +5694,16 @@
                           <a:solidFill>
                             <a:srgbClr val="FFFFFF"/>
                           </a:solidFill>
-                          <a:latin typeface="PingFang SC" pitchFamily="34" charset="0"/>
-                          <a:ea typeface="PingFang SC" pitchFamily="34" charset="-122"/>
-                          <a:cs typeface="PingFang SC" pitchFamily="34" charset="-120"/>
+                          <a:latin typeface="Microsoft YaHei" pitchFamily="34" charset="0"/>
+                          <a:ea typeface="Microsoft YaHei" pitchFamily="34" charset="-122"/>
+                          <a:cs typeface="Microsoft YaHei" pitchFamily="34" charset="-120"/>
                         </a:rPr>
                         <a:t>QPS</a:t>
                       </a:r>
                       <a:endParaRPr lang="en-US" sz="1200" dirty="0">
-                        <a:latin typeface="PingFang SC" charset="0"/>
-                        <a:ea typeface="PingFang SC" charset="0"/>
-                        <a:cs typeface="PingFang SC" charset="0"/>
+                        <a:latin typeface="Microsoft YaHei" charset="0"/>
+                        <a:ea typeface="Microsoft YaHei" charset="0"/>
+                        <a:cs typeface="Microsoft YaHei" charset="0"/>
                       </a:endParaRPr>
                     </a:p>
                   </a:txBody>
@@ -5760,16 +5762,16 @@
                           <a:solidFill>
                             <a:srgbClr val="FFFFFF"/>
                           </a:solidFill>
-                          <a:latin typeface="PingFang SC" pitchFamily="34" charset="0"/>
-                          <a:ea typeface="PingFang SC" pitchFamily="34" charset="-122"/>
-                          <a:cs typeface="PingFang SC" pitchFamily="34" charset="-120"/>
+                          <a:latin typeface="Microsoft YaHei" pitchFamily="34" charset="0"/>
+                          <a:ea typeface="Microsoft YaHei" pitchFamily="34" charset="-122"/>
+                          <a:cs typeface="Microsoft YaHei" pitchFamily="34" charset="-120"/>
                         </a:rPr>
                         <a:t>p50</a:t>
                       </a:r>
                       <a:endParaRPr lang="en-US" sz="1200" dirty="0">
-                        <a:latin typeface="PingFang SC" charset="0"/>
-                        <a:ea typeface="PingFang SC" charset="0"/>
-                        <a:cs typeface="PingFang SC" charset="0"/>
+                        <a:latin typeface="Microsoft YaHei" charset="0"/>
+                        <a:ea typeface="Microsoft YaHei" charset="0"/>
+                        <a:cs typeface="Microsoft YaHei" charset="0"/>
                       </a:endParaRPr>
                     </a:p>
                   </a:txBody>
@@ -5828,16 +5830,16 @@
                           <a:solidFill>
                             <a:srgbClr val="FFFFFF"/>
                           </a:solidFill>
-                          <a:latin typeface="PingFang SC" pitchFamily="34" charset="0"/>
-                          <a:ea typeface="PingFang SC" pitchFamily="34" charset="-122"/>
-                          <a:cs typeface="PingFang SC" pitchFamily="34" charset="-120"/>
+                          <a:latin typeface="Microsoft YaHei" pitchFamily="34" charset="0"/>
+                          <a:ea typeface="Microsoft YaHei" pitchFamily="34" charset="-122"/>
+                          <a:cs typeface="Microsoft YaHei" pitchFamily="34" charset="-120"/>
                         </a:rPr>
                         <a:t>p95</a:t>
                       </a:r>
                       <a:endParaRPr lang="en-US" sz="1200" dirty="0">
-                        <a:latin typeface="PingFang SC" charset="0"/>
-                        <a:ea typeface="PingFang SC" charset="0"/>
-                        <a:cs typeface="PingFang SC" charset="0"/>
+                        <a:latin typeface="Microsoft YaHei" charset="0"/>
+                        <a:ea typeface="Microsoft YaHei" charset="0"/>
+                        <a:cs typeface="Microsoft YaHei" charset="0"/>
                       </a:endParaRPr>
                     </a:p>
                   </a:txBody>
@@ -5896,16 +5898,16 @@
                           <a:solidFill>
                             <a:srgbClr val="FFFFFF"/>
                           </a:solidFill>
-                          <a:latin typeface="PingFang SC" pitchFamily="34" charset="0"/>
-                          <a:ea typeface="PingFang SC" pitchFamily="34" charset="-122"/>
-                          <a:cs typeface="PingFang SC" pitchFamily="34" charset="-120"/>
+                          <a:latin typeface="Microsoft YaHei" pitchFamily="34" charset="0"/>
+                          <a:ea typeface="Microsoft YaHei" pitchFamily="34" charset="-122"/>
+                          <a:cs typeface="Microsoft YaHei" pitchFamily="34" charset="-120"/>
                         </a:rPr>
                         <a:t>p99</a:t>
                       </a:r>
                       <a:endParaRPr lang="en-US" sz="1200" dirty="0">
-                        <a:latin typeface="PingFang SC" charset="0"/>
-                        <a:ea typeface="PingFang SC" charset="0"/>
-                        <a:cs typeface="PingFang SC" charset="0"/>
+                        <a:latin typeface="Microsoft YaHei" charset="0"/>
+                        <a:ea typeface="Microsoft YaHei" charset="0"/>
+                        <a:cs typeface="Microsoft YaHei" charset="0"/>
                       </a:endParaRPr>
                     </a:p>
                   </a:txBody>
@@ -5964,16 +5966,16 @@
                           <a:solidFill>
                             <a:srgbClr val="FFFFFF"/>
                           </a:solidFill>
-                          <a:latin typeface="PingFang SC" pitchFamily="34" charset="0"/>
-                          <a:ea typeface="PingFang SC" pitchFamily="34" charset="-122"/>
-                          <a:cs typeface="PingFang SC" pitchFamily="34" charset="-120"/>
+                          <a:latin typeface="Microsoft YaHei" pitchFamily="34" charset="0"/>
+                          <a:ea typeface="Microsoft YaHei" pitchFamily="34" charset="-122"/>
+                          <a:cs typeface="Microsoft YaHei" pitchFamily="34" charset="-120"/>
                         </a:rPr>
                         <a:t>失败</a:t>
                       </a:r>
                       <a:endParaRPr lang="en-US" sz="1200" dirty="0">
-                        <a:latin typeface="PingFang SC" charset="0"/>
-                        <a:ea typeface="PingFang SC" charset="0"/>
-                        <a:cs typeface="PingFang SC" charset="0"/>
+                        <a:latin typeface="Microsoft YaHei" charset="0"/>
+                        <a:ea typeface="Microsoft YaHei" charset="0"/>
+                        <a:cs typeface="Microsoft YaHei" charset="0"/>
                       </a:endParaRPr>
                     </a:p>
                   </a:txBody>
@@ -6034,16 +6036,16 @@
                           <a:solidFill>
                             <a:srgbClr val="3B5BFD"/>
                           </a:solidFill>
-                          <a:latin typeface="PingFang SC" pitchFamily="34" charset="0"/>
-                          <a:ea typeface="PingFang SC" pitchFamily="34" charset="-122"/>
-                          <a:cs typeface="PingFang SC" pitchFamily="34" charset="-120"/>
+                          <a:latin typeface="Microsoft YaHei" pitchFamily="34" charset="0"/>
+                          <a:ea typeface="Microsoft YaHei" pitchFamily="34" charset="-122"/>
+                          <a:cs typeface="Microsoft YaHei" pitchFamily="34" charset="-120"/>
                         </a:rPr>
                         <a:t>retrieval-only</a:t>
                       </a:r>
                       <a:endParaRPr lang="en-US" sz="1250" dirty="0">
-                        <a:latin typeface="PingFang SC" charset="0"/>
-                        <a:ea typeface="PingFang SC" charset="0"/>
-                        <a:cs typeface="PingFang SC" charset="0"/>
+                        <a:latin typeface="Microsoft YaHei" charset="0"/>
+                        <a:ea typeface="Microsoft YaHei" charset="0"/>
+                        <a:cs typeface="Microsoft YaHei" charset="0"/>
                       </a:endParaRPr>
                     </a:p>
                   </a:txBody>
@@ -6102,16 +6104,16 @@
                           <a:solidFill>
                             <a:srgbClr val="3B5BFD"/>
                           </a:solidFill>
-                          <a:latin typeface="PingFang SC" pitchFamily="34" charset="0"/>
-                          <a:ea typeface="PingFang SC" pitchFamily="34" charset="-122"/>
-                          <a:cs typeface="PingFang SC" pitchFamily="34" charset="-120"/>
+                          <a:latin typeface="Microsoft YaHei" pitchFamily="34" charset="0"/>
+                          <a:ea typeface="Microsoft YaHei" pitchFamily="34" charset="-122"/>
+                          <a:cs typeface="Microsoft YaHei" pitchFamily="34" charset="-120"/>
                         </a:rPr>
                         <a:t>300</a:t>
                       </a:r>
                       <a:endParaRPr lang="en-US" sz="1250" dirty="0">
-                        <a:latin typeface="PingFang SC" charset="0"/>
-                        <a:ea typeface="PingFang SC" charset="0"/>
-                        <a:cs typeface="PingFang SC" charset="0"/>
+                        <a:latin typeface="Microsoft YaHei" charset="0"/>
+                        <a:ea typeface="Microsoft YaHei" charset="0"/>
+                        <a:cs typeface="Microsoft YaHei" charset="0"/>
                       </a:endParaRPr>
                     </a:p>
                   </a:txBody>
@@ -6170,16 +6172,16 @@
                           <a:solidFill>
                             <a:srgbClr val="3B5BFD"/>
                           </a:solidFill>
-                          <a:latin typeface="PingFang SC" pitchFamily="34" charset="0"/>
-                          <a:ea typeface="PingFang SC" pitchFamily="34" charset="-122"/>
-                          <a:cs typeface="PingFang SC" pitchFamily="34" charset="-120"/>
+                          <a:latin typeface="Microsoft YaHei" pitchFamily="34" charset="0"/>
+                          <a:ea typeface="Microsoft YaHei" pitchFamily="34" charset="-122"/>
+                          <a:cs typeface="Microsoft YaHei" pitchFamily="34" charset="-120"/>
                         </a:rPr>
                         <a:t>251.4</a:t>
                       </a:r>
                       <a:endParaRPr lang="en-US" sz="1250" dirty="0">
-                        <a:latin typeface="PingFang SC" charset="0"/>
-                        <a:ea typeface="PingFang SC" charset="0"/>
-                        <a:cs typeface="PingFang SC" charset="0"/>
+                        <a:latin typeface="Microsoft YaHei" charset="0"/>
+                        <a:ea typeface="Microsoft YaHei" charset="0"/>
+                        <a:cs typeface="Microsoft YaHei" charset="0"/>
                       </a:endParaRPr>
                     </a:p>
                   </a:txBody>
@@ -6238,16 +6240,16 @@
                           <a:solidFill>
                             <a:srgbClr val="3B5BFD"/>
                           </a:solidFill>
-                          <a:latin typeface="PingFang SC" pitchFamily="34" charset="0"/>
-                          <a:ea typeface="PingFang SC" pitchFamily="34" charset="-122"/>
-                          <a:cs typeface="PingFang SC" pitchFamily="34" charset="-120"/>
+                          <a:latin typeface="Microsoft YaHei" pitchFamily="34" charset="0"/>
+                          <a:ea typeface="Microsoft YaHei" pitchFamily="34" charset="-122"/>
+                          <a:cs typeface="Microsoft YaHei" pitchFamily="34" charset="-120"/>
                         </a:rPr>
                         <a:t>3.4ms</a:t>
                       </a:r>
                       <a:endParaRPr lang="en-US" sz="1250" dirty="0">
-                        <a:latin typeface="PingFang SC" charset="0"/>
-                        <a:ea typeface="PingFang SC" charset="0"/>
-                        <a:cs typeface="PingFang SC" charset="0"/>
+                        <a:latin typeface="Microsoft YaHei" charset="0"/>
+                        <a:ea typeface="Microsoft YaHei" charset="0"/>
+                        <a:cs typeface="Microsoft YaHei" charset="0"/>
                       </a:endParaRPr>
                     </a:p>
                   </a:txBody>
@@ -6306,16 +6308,16 @@
                           <a:solidFill>
                             <a:srgbClr val="3B5BFD"/>
                           </a:solidFill>
-                          <a:latin typeface="PingFang SC" pitchFamily="34" charset="0"/>
-                          <a:ea typeface="PingFang SC" pitchFamily="34" charset="-122"/>
-                          <a:cs typeface="PingFang SC" pitchFamily="34" charset="-120"/>
+                          <a:latin typeface="Microsoft YaHei" pitchFamily="34" charset="0"/>
+                          <a:ea typeface="Microsoft YaHei" pitchFamily="34" charset="-122"/>
+                          <a:cs typeface="Microsoft YaHei" pitchFamily="34" charset="-120"/>
                         </a:rPr>
                         <a:t>7.0ms</a:t>
                       </a:r>
                       <a:endParaRPr lang="en-US" sz="1250" dirty="0">
-                        <a:latin typeface="PingFang SC" charset="0"/>
-                        <a:ea typeface="PingFang SC" charset="0"/>
-                        <a:cs typeface="PingFang SC" charset="0"/>
+                        <a:latin typeface="Microsoft YaHei" charset="0"/>
+                        <a:ea typeface="Microsoft YaHei" charset="0"/>
+                        <a:cs typeface="Microsoft YaHei" charset="0"/>
                       </a:endParaRPr>
                     </a:p>
                   </a:txBody>
@@ -6374,16 +6376,16 @@
                           <a:solidFill>
                             <a:srgbClr val="3B5BFD"/>
                           </a:solidFill>
-                          <a:latin typeface="PingFang SC" pitchFamily="34" charset="0"/>
-                          <a:ea typeface="PingFang SC" pitchFamily="34" charset="-122"/>
-                          <a:cs typeface="PingFang SC" pitchFamily="34" charset="-120"/>
+                          <a:latin typeface="Microsoft YaHei" pitchFamily="34" charset="0"/>
+                          <a:ea typeface="Microsoft YaHei" pitchFamily="34" charset="-122"/>
+                          <a:cs typeface="Microsoft YaHei" pitchFamily="34" charset="-120"/>
                         </a:rPr>
                         <a:t>7.2ms</a:t>
                       </a:r>
                       <a:endParaRPr lang="en-US" sz="1250" dirty="0">
-                        <a:latin typeface="PingFang SC" charset="0"/>
-                        <a:ea typeface="PingFang SC" charset="0"/>
-                        <a:cs typeface="PingFang SC" charset="0"/>
+                        <a:latin typeface="Microsoft YaHei" charset="0"/>
+                        <a:ea typeface="Microsoft YaHei" charset="0"/>
+                        <a:cs typeface="Microsoft YaHei" charset="0"/>
                       </a:endParaRPr>
                     </a:p>
                   </a:txBody>
@@ -6442,16 +6444,16 @@
                           <a:solidFill>
                             <a:srgbClr val="3B5BFD"/>
                           </a:solidFill>
-                          <a:latin typeface="PingFang SC" pitchFamily="34" charset="0"/>
-                          <a:ea typeface="PingFang SC" pitchFamily="34" charset="-122"/>
-                          <a:cs typeface="PingFang SC" pitchFamily="34" charset="-120"/>
+                          <a:latin typeface="Microsoft YaHei" pitchFamily="34" charset="0"/>
+                          <a:ea typeface="Microsoft YaHei" pitchFamily="34" charset="-122"/>
+                          <a:cs typeface="Microsoft YaHei" pitchFamily="34" charset="-120"/>
                         </a:rPr>
                         <a:t>0</a:t>
                       </a:r>
                       <a:endParaRPr lang="en-US" sz="1250" dirty="0">
-                        <a:latin typeface="PingFang SC" charset="0"/>
-                        <a:ea typeface="PingFang SC" charset="0"/>
-                        <a:cs typeface="PingFang SC" charset="0"/>
+                        <a:latin typeface="Microsoft YaHei" charset="0"/>
+                        <a:ea typeface="Microsoft YaHei" charset="0"/>
+                        <a:cs typeface="Microsoft YaHei" charset="0"/>
                       </a:endParaRPr>
                     </a:p>
                   </a:txBody>
@@ -6512,16 +6514,16 @@
                           <a:solidFill>
                             <a:srgbClr val="1C2333"/>
                           </a:solidFill>
-                          <a:latin typeface="PingFang SC" pitchFamily="34" charset="0"/>
-                          <a:ea typeface="PingFang SC" pitchFamily="34" charset="-122"/>
-                          <a:cs typeface="PingFang SC" pitchFamily="34" charset="-120"/>
+                          <a:latin typeface="Microsoft YaHei" pitchFamily="34" charset="0"/>
+                          <a:ea typeface="Microsoft YaHei" pitchFamily="34" charset="-122"/>
+                          <a:cs typeface="Microsoft YaHei" pitchFamily="34" charset="-120"/>
                         </a:rPr>
                         <a:t>local-extractive E2E</a:t>
                       </a:r>
                       <a:endParaRPr lang="en-US" sz="1250" dirty="0">
-                        <a:latin typeface="PingFang SC" charset="0"/>
-                        <a:ea typeface="PingFang SC" charset="0"/>
-                        <a:cs typeface="PingFang SC" charset="0"/>
+                        <a:latin typeface="Microsoft YaHei" charset="0"/>
+                        <a:ea typeface="Microsoft YaHei" charset="0"/>
+                        <a:cs typeface="Microsoft YaHei" charset="0"/>
                       </a:endParaRPr>
                     </a:p>
                   </a:txBody>
@@ -6580,16 +6582,16 @@
                           <a:solidFill>
                             <a:srgbClr val="1C2333"/>
                           </a:solidFill>
-                          <a:latin typeface="PingFang SC" pitchFamily="34" charset="0"/>
-                          <a:ea typeface="PingFang SC" pitchFamily="34" charset="-122"/>
-                          <a:cs typeface="PingFang SC" pitchFamily="34" charset="-120"/>
+                          <a:latin typeface="Microsoft YaHei" pitchFamily="34" charset="0"/>
+                          <a:ea typeface="Microsoft YaHei" pitchFamily="34" charset="-122"/>
+                          <a:cs typeface="Microsoft YaHei" pitchFamily="34" charset="-120"/>
                         </a:rPr>
                         <a:t>200</a:t>
                       </a:r>
                       <a:endParaRPr lang="en-US" sz="1250" dirty="0">
-                        <a:latin typeface="PingFang SC" charset="0"/>
-                        <a:ea typeface="PingFang SC" charset="0"/>
-                        <a:cs typeface="PingFang SC" charset="0"/>
+                        <a:latin typeface="Microsoft YaHei" charset="0"/>
+                        <a:ea typeface="Microsoft YaHei" charset="0"/>
+                        <a:cs typeface="Microsoft YaHei" charset="0"/>
                       </a:endParaRPr>
                     </a:p>
                   </a:txBody>
@@ -6648,16 +6650,16 @@
                           <a:solidFill>
                             <a:srgbClr val="1C2333"/>
                           </a:solidFill>
-                          <a:latin typeface="PingFang SC" pitchFamily="34" charset="0"/>
-                          <a:ea typeface="PingFang SC" pitchFamily="34" charset="-122"/>
-                          <a:cs typeface="PingFang SC" pitchFamily="34" charset="-120"/>
+                          <a:latin typeface="Microsoft YaHei" pitchFamily="34" charset="0"/>
+                          <a:ea typeface="Microsoft YaHei" pitchFamily="34" charset="-122"/>
+                          <a:cs typeface="Microsoft YaHei" pitchFamily="34" charset="-120"/>
                         </a:rPr>
                         <a:t>44.1</a:t>
                       </a:r>
                       <a:endParaRPr lang="en-US" sz="1250" dirty="0">
-                        <a:latin typeface="PingFang SC" charset="0"/>
-                        <a:ea typeface="PingFang SC" charset="0"/>
-                        <a:cs typeface="PingFang SC" charset="0"/>
+                        <a:latin typeface="Microsoft YaHei" charset="0"/>
+                        <a:ea typeface="Microsoft YaHei" charset="0"/>
+                        <a:cs typeface="Microsoft YaHei" charset="0"/>
                       </a:endParaRPr>
                     </a:p>
                   </a:txBody>
@@ -6716,16 +6718,16 @@
                           <a:solidFill>
                             <a:srgbClr val="1C2333"/>
                           </a:solidFill>
-                          <a:latin typeface="PingFang SC" pitchFamily="34" charset="0"/>
-                          <a:ea typeface="PingFang SC" pitchFamily="34" charset="-122"/>
-                          <a:cs typeface="PingFang SC" pitchFamily="34" charset="-120"/>
+                          <a:latin typeface="Microsoft YaHei" pitchFamily="34" charset="0"/>
+                          <a:ea typeface="Microsoft YaHei" pitchFamily="34" charset="-122"/>
+                          <a:cs typeface="Microsoft YaHei" pitchFamily="34" charset="-120"/>
                         </a:rPr>
                         <a:t>415.7ms</a:t>
                       </a:r>
                       <a:endParaRPr lang="en-US" sz="1250" dirty="0">
-                        <a:latin typeface="PingFang SC" charset="0"/>
-                        <a:ea typeface="PingFang SC" charset="0"/>
-                        <a:cs typeface="PingFang SC" charset="0"/>
+                        <a:latin typeface="Microsoft YaHei" charset="0"/>
+                        <a:ea typeface="Microsoft YaHei" charset="0"/>
+                        <a:cs typeface="Microsoft YaHei" charset="0"/>
                       </a:endParaRPr>
                     </a:p>
                   </a:txBody>
@@ -6784,16 +6786,16 @@
                           <a:solidFill>
                             <a:srgbClr val="1C2333"/>
                           </a:solidFill>
-                          <a:latin typeface="PingFang SC" pitchFamily="34" charset="0"/>
-                          <a:ea typeface="PingFang SC" pitchFamily="34" charset="-122"/>
-                          <a:cs typeface="PingFang SC" pitchFamily="34" charset="-120"/>
+                          <a:latin typeface="Microsoft YaHei" pitchFamily="34" charset="0"/>
+                          <a:ea typeface="Microsoft YaHei" pitchFamily="34" charset="-122"/>
+                          <a:cs typeface="Microsoft YaHei" pitchFamily="34" charset="-120"/>
                         </a:rPr>
                         <a:t>601.0ms</a:t>
                       </a:r>
                       <a:endParaRPr lang="en-US" sz="1250" dirty="0">
-                        <a:latin typeface="PingFang SC" charset="0"/>
-                        <a:ea typeface="PingFang SC" charset="0"/>
-                        <a:cs typeface="PingFang SC" charset="0"/>
+                        <a:latin typeface="Microsoft YaHei" charset="0"/>
+                        <a:ea typeface="Microsoft YaHei" charset="0"/>
+                        <a:cs typeface="Microsoft YaHei" charset="0"/>
                       </a:endParaRPr>
                     </a:p>
                   </a:txBody>
@@ -6852,16 +6854,16 @@
                           <a:solidFill>
                             <a:srgbClr val="1C2333"/>
                           </a:solidFill>
-                          <a:latin typeface="PingFang SC" pitchFamily="34" charset="0"/>
-                          <a:ea typeface="PingFang SC" pitchFamily="34" charset="-122"/>
-                          <a:cs typeface="PingFang SC" pitchFamily="34" charset="-120"/>
+                          <a:latin typeface="Microsoft YaHei" pitchFamily="34" charset="0"/>
+                          <a:ea typeface="Microsoft YaHei" pitchFamily="34" charset="-122"/>
+                          <a:cs typeface="Microsoft YaHei" pitchFamily="34" charset="-120"/>
                         </a:rPr>
                         <a:t>611.1ms</a:t>
                       </a:r>
                       <a:endParaRPr lang="en-US" sz="1250" dirty="0">
-                        <a:latin typeface="PingFang SC" charset="0"/>
-                        <a:ea typeface="PingFang SC" charset="0"/>
-                        <a:cs typeface="PingFang SC" charset="0"/>
+                        <a:latin typeface="Microsoft YaHei" charset="0"/>
+                        <a:ea typeface="Microsoft YaHei" charset="0"/>
+                        <a:cs typeface="Microsoft YaHei" charset="0"/>
                       </a:endParaRPr>
                     </a:p>
                   </a:txBody>
@@ -6920,16 +6922,16 @@
                           <a:solidFill>
                             <a:srgbClr val="1C2333"/>
                           </a:solidFill>
-                          <a:latin typeface="PingFang SC" pitchFamily="34" charset="0"/>
-                          <a:ea typeface="PingFang SC" pitchFamily="34" charset="-122"/>
-                          <a:cs typeface="PingFang SC" pitchFamily="34" charset="-120"/>
+                          <a:latin typeface="Microsoft YaHei" pitchFamily="34" charset="0"/>
+                          <a:ea typeface="Microsoft YaHei" pitchFamily="34" charset="-122"/>
+                          <a:cs typeface="Microsoft YaHei" pitchFamily="34" charset="-120"/>
                         </a:rPr>
                         <a:t>0</a:t>
                       </a:r>
                       <a:endParaRPr lang="en-US" sz="1250" dirty="0">
-                        <a:latin typeface="PingFang SC" charset="0"/>
-                        <a:ea typeface="PingFang SC" charset="0"/>
-                        <a:cs typeface="PingFang SC" charset="0"/>
+                        <a:latin typeface="Microsoft YaHei" charset="0"/>
+                        <a:ea typeface="Microsoft YaHei" charset="0"/>
+                        <a:cs typeface="Microsoft YaHei" charset="0"/>
                       </a:endParaRPr>
                     </a:p>
                   </a:txBody>
@@ -7009,9 +7011,9 @@
                 <a:solidFill>
                   <a:srgbClr val="3B5BFD"/>
                 </a:solidFill>
-                <a:latin typeface="PingFang SC" pitchFamily="34" charset="0"/>
-                <a:ea typeface="PingFang SC" pitchFamily="34" charset="-122"/>
-                <a:cs typeface="PingFang SC" pitchFamily="34" charset="-120"/>
+                <a:latin typeface="Microsoft YaHei" pitchFamily="34" charset="0"/>
+                <a:ea typeface="Microsoft YaHei" pitchFamily="34" charset="-122"/>
+                <a:cs typeface="Microsoft YaHei" pitchFamily="34" charset="-120"/>
               </a:rPr>
               <a:t>251.4</a:t>
             </a:r>
@@ -7048,9 +7050,9 @@
                 <a:solidFill>
                   <a:srgbClr val="1C2333"/>
                 </a:solidFill>
-                <a:latin typeface="PingFang SC" pitchFamily="34" charset="0"/>
-                <a:ea typeface="PingFang SC" pitchFamily="34" charset="-122"/>
-                <a:cs typeface="PingFang SC" pitchFamily="34" charset="-120"/>
+                <a:latin typeface="Microsoft YaHei" pitchFamily="34" charset="0"/>
+                <a:ea typeface="Microsoft YaHei" pitchFamily="34" charset="-122"/>
+                <a:cs typeface="Microsoft YaHei" pitchFamily="34" charset="-120"/>
               </a:rPr>
               <a:t>retrieval-only 吞吐（QPS）</a:t>
             </a:r>
@@ -7087,9 +7089,9 @@
                 <a:solidFill>
                   <a:srgbClr val="6A7390"/>
                 </a:solidFill>
-                <a:latin typeface="PingFang SC" pitchFamily="34" charset="0"/>
-                <a:ea typeface="PingFang SC" pitchFamily="34" charset="-122"/>
-                <a:cs typeface="PingFang SC" pitchFamily="34" charset="-120"/>
+                <a:latin typeface="Microsoft YaHei" pitchFamily="34" charset="0"/>
+                <a:ea typeface="Microsoft YaHei" pitchFamily="34" charset="-122"/>
+                <a:cs typeface="Microsoft YaHei" pitchFamily="34" charset="-120"/>
               </a:rPr>
               <a:t>p95 7.0ms，远优于 50ms 目标</a:t>
             </a:r>
@@ -7126,9 +7128,9 @@
                 <a:solidFill>
                   <a:srgbClr val="7C4DFF"/>
                 </a:solidFill>
-                <a:latin typeface="PingFang SC" pitchFamily="34" charset="0"/>
-                <a:ea typeface="PingFang SC" pitchFamily="34" charset="-122"/>
-                <a:cs typeface="PingFang SC" pitchFamily="34" charset="-120"/>
+                <a:latin typeface="Microsoft YaHei" pitchFamily="34" charset="0"/>
+                <a:ea typeface="Microsoft YaHei" pitchFamily="34" charset="-122"/>
+                <a:cs typeface="Microsoft YaHei" pitchFamily="34" charset="-120"/>
               </a:rPr>
               <a:t>44.1</a:t>
             </a:r>
@@ -7165,9 +7167,9 @@
                 <a:solidFill>
                   <a:srgbClr val="1C2333"/>
                 </a:solidFill>
-                <a:latin typeface="PingFang SC" pitchFamily="34" charset="0"/>
-                <a:ea typeface="PingFang SC" pitchFamily="34" charset="-122"/>
-                <a:cs typeface="PingFang SC" pitchFamily="34" charset="-120"/>
+                <a:latin typeface="Microsoft YaHei" pitchFamily="34" charset="0"/>
+                <a:ea typeface="Microsoft YaHei" pitchFamily="34" charset="-122"/>
+                <a:cs typeface="Microsoft YaHei" pitchFamily="34" charset="-120"/>
               </a:rPr>
               <a:t>E2E 吞吐（QPS，含生成）</a:t>
             </a:r>
@@ -7204,9 +7206,9 @@
                 <a:solidFill>
                   <a:srgbClr val="6A7390"/>
                 </a:solidFill>
-                <a:latin typeface="PingFang SC" pitchFamily="34" charset="0"/>
-                <a:ea typeface="PingFang SC" pitchFamily="34" charset="-122"/>
-                <a:cs typeface="PingFang SC" pitchFamily="34" charset="-120"/>
+                <a:latin typeface="Microsoft YaHei" pitchFamily="34" charset="0"/>
+                <a:ea typeface="Microsoft YaHei" pitchFamily="34" charset="-122"/>
+                <a:cs typeface="Microsoft YaHei" pitchFamily="34" charset="-120"/>
               </a:rPr>
               <a:t>p99 611ms，200/200 成功</a:t>
             </a:r>
@@ -7277,9 +7279,9 @@
                 <a:solidFill>
                   <a:srgbClr val="FF8A3D"/>
                 </a:solidFill>
-                <a:latin typeface="PingFang SC" pitchFamily="34" charset="0"/>
-                <a:ea typeface="PingFang SC" pitchFamily="34" charset="-122"/>
-                <a:cs typeface="PingFang SC" pitchFamily="34" charset="-120"/>
+                <a:latin typeface="Microsoft YaHei" pitchFamily="34" charset="0"/>
+                <a:ea typeface="Microsoft YaHei" pitchFamily="34" charset="-122"/>
+                <a:cs typeface="Microsoft YaHei" pitchFamily="34" charset="-120"/>
               </a:rPr>
               <a:t>如实说明：</a:t>
             </a:r>
@@ -7291,9 +7293,9 @@
                 <a:solidFill>
                   <a:srgbClr val="1C2333"/>
                 </a:solidFill>
-                <a:latin typeface="PingFang SC" pitchFamily="34" charset="0"/>
-                <a:ea typeface="PingFang SC" pitchFamily="34" charset="-122"/>
-                <a:cs typeface="PingFang SC" pitchFamily="34" charset="-120"/>
+                <a:latin typeface="Microsoft YaHei" pitchFamily="34" charset="0"/>
+                <a:ea typeface="Microsoft YaHei" pitchFamily="34" charset="-122"/>
+                <a:cs typeface="Microsoft YaHei" pitchFamily="34" charset="-120"/>
               </a:rPr>
               <a:t>历史对照：Rerank 默认时期 217.8 / 42.0 QPS，初版 67.8 QPS；默认切换至 RRF 后检索计算量下降，吞吐回升，数据如实呈现。</a:t>
             </a:r>
@@ -7330,9 +7332,9 @@
                 <a:solidFill>
                   <a:srgbClr val="6A7390"/>
                 </a:solidFill>
-                <a:latin typeface="PingFang SC" pitchFamily="34" charset="0"/>
-                <a:ea typeface="PingFang SC" pitchFamily="34" charset="-122"/>
-                <a:cs typeface="PingFang SC" pitchFamily="34" charset="-120"/>
+                <a:latin typeface="Microsoft YaHei" pitchFamily="34" charset="0"/>
+                <a:ea typeface="Microsoft YaHei" pitchFamily="34" charset="-122"/>
+                <a:cs typeface="Microsoft YaHei" pitchFamily="34" charset="-120"/>
               </a:rPr>
               <a:t>数据源：scripts/bench.py（retrieval / e2e 两模式），2026-09-18 实测</a:t>
             </a:r>
@@ -7401,9 +7403,9 @@
                 <a:solidFill>
                   <a:srgbClr val="1C2333"/>
                 </a:solidFill>
-                <a:latin typeface="PingFang SC" pitchFamily="34" charset="0"/>
-                <a:ea typeface="PingFang SC" pitchFamily="34" charset="-122"/>
-                <a:cs typeface="PingFang SC" pitchFamily="34" charset="-120"/>
+                <a:latin typeface="Microsoft YaHei" pitchFamily="34" charset="0"/>
+                <a:ea typeface="Microsoft YaHei" pitchFamily="34" charset="-122"/>
+                <a:cs typeface="Microsoft YaHei" pitchFamily="34" charset="-120"/>
               </a:rPr>
               <a:t>追踪矩阵与四项架构验收</a:t>
             </a:r>
@@ -7440,9 +7442,9 @@
                 <a:solidFill>
                   <a:srgbClr val="6A7390"/>
                 </a:solidFill>
-                <a:latin typeface="PingFang SC" pitchFamily="34" charset="0"/>
-                <a:ea typeface="PingFang SC" pitchFamily="34" charset="-122"/>
-                <a:cs typeface="PingFang SC" pitchFamily="34" charset="-120"/>
+                <a:latin typeface="Microsoft YaHei" pitchFamily="34" charset="0"/>
+                <a:ea typeface="Microsoft YaHei" pitchFamily="34" charset="-122"/>
+                <a:cs typeface="Microsoft YaHei" pitchFamily="34" charset="-120"/>
               </a:rPr>
               <a:t>需求 → 质量属性 → ADR → 模块 → 测试 → 证据，全链条可追溯（见 docs/traceability.md）</a:t>
             </a:r>
@@ -7479,9 +7481,9 @@
                 <a:solidFill>
                   <a:srgbClr val="6A7390"/>
                 </a:solidFill>
-                <a:latin typeface="PingFang SC" pitchFamily="34" charset="0"/>
-                <a:ea typeface="PingFang SC" pitchFamily="34" charset="-122"/>
-                <a:cs typeface="PingFang SC" pitchFamily="34" charset="-120"/>
+                <a:latin typeface="Microsoft YaHei" pitchFamily="34" charset="0"/>
+                <a:ea typeface="Microsoft YaHei" pitchFamily="34" charset="-122"/>
+                <a:cs typeface="Microsoft YaHei" pitchFamily="34" charset="-120"/>
               </a:rPr>
               <a:t>14</a:t>
             </a:r>
@@ -7531,16 +7533,16 @@
                           <a:solidFill>
                             <a:srgbClr val="FFFFFF"/>
                           </a:solidFill>
-                          <a:latin typeface="PingFang SC" pitchFamily="34" charset="0"/>
-                          <a:ea typeface="PingFang SC" pitchFamily="34" charset="-122"/>
-                          <a:cs typeface="PingFang SC" pitchFamily="34" charset="-120"/>
+                          <a:latin typeface="Microsoft YaHei" pitchFamily="34" charset="0"/>
+                          <a:ea typeface="Microsoft YaHei" pitchFamily="34" charset="-122"/>
+                          <a:cs typeface="Microsoft YaHei" pitchFamily="34" charset="-120"/>
                         </a:rPr>
                         <a:t>A1 生成降级</a:t>
                       </a:r>
                       <a:endParaRPr lang="en-US" sz="1200" dirty="0">
-                        <a:latin typeface="PingFang SC" charset="0"/>
-                        <a:ea typeface="PingFang SC" charset="0"/>
-                        <a:cs typeface="PingFang SC" charset="0"/>
+                        <a:latin typeface="Microsoft YaHei" charset="0"/>
+                        <a:ea typeface="Microsoft YaHei" charset="0"/>
+                        <a:cs typeface="Microsoft YaHei" charset="0"/>
                       </a:endParaRPr>
                     </a:p>
                   </a:txBody>
@@ -7599,16 +7601,16 @@
                           <a:solidFill>
                             <a:srgbClr val="FFFFFF"/>
                           </a:solidFill>
-                          <a:latin typeface="PingFang SC" pitchFamily="34" charset="0"/>
-                          <a:ea typeface="PingFang SC" pitchFamily="34" charset="-122"/>
-                          <a:cs typeface="PingFang SC" pitchFamily="34" charset="-120"/>
+                          <a:latin typeface="Microsoft YaHei" pitchFamily="34" charset="0"/>
+                          <a:ea typeface="Microsoft YaHei" pitchFamily="34" charset="-122"/>
+                          <a:cs typeface="Microsoft YaHei" pitchFamily="34" charset="-120"/>
                         </a:rPr>
                         <a:t>云端 GLM 无效 Key → 流内回退本地抽取式</a:t>
                       </a:r>
                       <a:endParaRPr lang="en-US" sz="1200" dirty="0">
-                        <a:latin typeface="PingFang SC" charset="0"/>
-                        <a:ea typeface="PingFang SC" charset="0"/>
-                        <a:cs typeface="PingFang SC" charset="0"/>
+                        <a:latin typeface="Microsoft YaHei" charset="0"/>
+                        <a:ea typeface="Microsoft YaHei" charset="0"/>
+                        <a:cs typeface="Microsoft YaHei" charset="0"/>
                       </a:endParaRPr>
                     </a:p>
                   </a:txBody>
@@ -7667,16 +7669,16 @@
                           <a:solidFill>
                             <a:srgbClr val="FFFFFF"/>
                           </a:solidFill>
-                          <a:latin typeface="PingFang SC" pitchFamily="34" charset="0"/>
-                          <a:ea typeface="PingFang SC" pitchFamily="34" charset="-122"/>
-                          <a:cs typeface="PingFang SC" pitchFamily="34" charset="-120"/>
+                          <a:latin typeface="Microsoft YaHei" pitchFamily="34" charset="0"/>
+                          <a:ea typeface="Microsoft YaHei" pitchFamily="34" charset="-122"/>
+                          <a:cs typeface="Microsoft YaHei" pitchFamily="34" charset="-120"/>
                         </a:rPr>
                         <a:t>PASS</a:t>
                       </a:r>
                       <a:endParaRPr lang="en-US" sz="1200" dirty="0">
-                        <a:latin typeface="PingFang SC" charset="0"/>
-                        <a:ea typeface="PingFang SC" charset="0"/>
-                        <a:cs typeface="PingFang SC" charset="0"/>
+                        <a:latin typeface="Microsoft YaHei" charset="0"/>
+                        <a:ea typeface="Microsoft YaHei" charset="0"/>
+                        <a:cs typeface="Microsoft YaHei" charset="0"/>
                       </a:endParaRPr>
                     </a:p>
                   </a:txBody>
@@ -7735,16 +7737,16 @@
                           <a:solidFill>
                             <a:srgbClr val="FFFFFF"/>
                           </a:solidFill>
-                          <a:latin typeface="PingFang SC" pitchFamily="34" charset="0"/>
-                          <a:ea typeface="PingFang SC" pitchFamily="34" charset="-122"/>
-                          <a:cs typeface="PingFang SC" pitchFamily="34" charset="-120"/>
+                          <a:latin typeface="Microsoft YaHei" pitchFamily="34" charset="0"/>
+                          <a:ea typeface="Microsoft YaHei" pitchFamily="34" charset="-122"/>
+                          <a:cs typeface="Microsoft YaHei" pitchFamily="34" charset="-120"/>
                         </a:rPr>
                         <a:t>降级产出 139 字正解，服务不中断</a:t>
                       </a:r>
                       <a:endParaRPr lang="en-US" sz="1200" dirty="0">
-                        <a:latin typeface="PingFang SC" charset="0"/>
-                        <a:ea typeface="PingFang SC" charset="0"/>
-                        <a:cs typeface="PingFang SC" charset="0"/>
+                        <a:latin typeface="Microsoft YaHei" charset="0"/>
+                        <a:ea typeface="Microsoft YaHei" charset="0"/>
+                        <a:cs typeface="Microsoft YaHei" charset="0"/>
                       </a:endParaRPr>
                     </a:p>
                   </a:txBody>
@@ -7805,16 +7807,16 @@
                           <a:solidFill>
                             <a:srgbClr val="3B5BFD"/>
                           </a:solidFill>
-                          <a:latin typeface="PingFang SC" pitchFamily="34" charset="0"/>
-                          <a:ea typeface="PingFang SC" pitchFamily="34" charset="-122"/>
-                          <a:cs typeface="PingFang SC" pitchFamily="34" charset="-120"/>
+                          <a:latin typeface="Microsoft YaHei" pitchFamily="34" charset="0"/>
+                          <a:ea typeface="Microsoft YaHei" pitchFamily="34" charset="-122"/>
+                          <a:cs typeface="Microsoft YaHei" pitchFamily="34" charset="-120"/>
                         </a:rPr>
                         <a:t>A2 入口限流</a:t>
                       </a:r>
                       <a:endParaRPr lang="en-US" sz="1150" dirty="0">
-                        <a:latin typeface="PingFang SC" charset="0"/>
-                        <a:ea typeface="PingFang SC" charset="0"/>
-                        <a:cs typeface="PingFang SC" charset="0"/>
+                        <a:latin typeface="Microsoft YaHei" charset="0"/>
+                        <a:ea typeface="Microsoft YaHei" charset="0"/>
+                        <a:cs typeface="Microsoft YaHei" charset="0"/>
                       </a:endParaRPr>
                     </a:p>
                   </a:txBody>
@@ -7873,16 +7875,16 @@
                           <a:solidFill>
                             <a:srgbClr val="1C2333"/>
                           </a:solidFill>
-                          <a:latin typeface="PingFang SC" pitchFamily="34" charset="0"/>
-                          <a:ea typeface="PingFang SC" pitchFamily="34" charset="-122"/>
-                          <a:cs typeface="PingFang SC" pitchFamily="34" charset="-120"/>
+                          <a:latin typeface="Microsoft YaHei" pitchFamily="34" charset="0"/>
+                          <a:ea typeface="Microsoft YaHei" pitchFamily="34" charset="-122"/>
+                          <a:cs typeface="Microsoft YaHei" pitchFamily="34" charset="-120"/>
                         </a:rPr>
                         <a:t>单用户并发突发 15（桶容量 10）</a:t>
                       </a:r>
                       <a:endParaRPr lang="en-US" sz="1150" dirty="0">
-                        <a:latin typeface="PingFang SC" charset="0"/>
-                        <a:ea typeface="PingFang SC" charset="0"/>
-                        <a:cs typeface="PingFang SC" charset="0"/>
+                        <a:latin typeface="Microsoft YaHei" charset="0"/>
+                        <a:ea typeface="Microsoft YaHei" charset="0"/>
+                        <a:cs typeface="Microsoft YaHei" charset="0"/>
                       </a:endParaRPr>
                     </a:p>
                   </a:txBody>
@@ -7941,16 +7943,16 @@
                           <a:solidFill>
                             <a:srgbClr val="12B76A"/>
                           </a:solidFill>
-                          <a:latin typeface="PingFang SC" pitchFamily="34" charset="0"/>
-                          <a:ea typeface="PingFang SC" pitchFamily="34" charset="-122"/>
-                          <a:cs typeface="PingFang SC" pitchFamily="34" charset="-120"/>
+                          <a:latin typeface="Microsoft YaHei" pitchFamily="34" charset="0"/>
+                          <a:ea typeface="Microsoft YaHei" pitchFamily="34" charset="-122"/>
+                          <a:cs typeface="Microsoft YaHei" pitchFamily="34" charset="-120"/>
                         </a:rPr>
                         <a:t>PASS</a:t>
                       </a:r>
                       <a:endParaRPr lang="en-US" sz="1150" dirty="0">
-                        <a:latin typeface="PingFang SC" charset="0"/>
-                        <a:ea typeface="PingFang SC" charset="0"/>
-                        <a:cs typeface="PingFang SC" charset="0"/>
+                        <a:latin typeface="Microsoft YaHei" charset="0"/>
+                        <a:ea typeface="Microsoft YaHei" charset="0"/>
+                        <a:cs typeface="Microsoft YaHei" charset="0"/>
                       </a:endParaRPr>
                     </a:p>
                   </a:txBody>
@@ -8009,16 +8011,16 @@
                           <a:solidFill>
                             <a:srgbClr val="1C2333"/>
                           </a:solidFill>
-                          <a:latin typeface="PingFang SC" pitchFamily="34" charset="0"/>
-                          <a:ea typeface="PingFang SC" pitchFamily="34" charset="-122"/>
-                          <a:cs typeface="PingFang SC" pitchFamily="34" charset="-120"/>
+                          <a:latin typeface="Microsoft YaHei" pitchFamily="34" charset="0"/>
+                          <a:ea typeface="Microsoft YaHei" pitchFamily="34" charset="-122"/>
+                          <a:cs typeface="Microsoft YaHei" pitchFamily="34" charset="-120"/>
                         </a:rPr>
                         <a:t>200×10 + 429×5，超容请求被拒</a:t>
                       </a:r>
                       <a:endParaRPr lang="en-US" sz="1150" dirty="0">
-                        <a:latin typeface="PingFang SC" charset="0"/>
-                        <a:ea typeface="PingFang SC" charset="0"/>
-                        <a:cs typeface="PingFang SC" charset="0"/>
+                        <a:latin typeface="Microsoft YaHei" charset="0"/>
+                        <a:ea typeface="Microsoft YaHei" charset="0"/>
+                        <a:cs typeface="Microsoft YaHei" charset="0"/>
                       </a:endParaRPr>
                     </a:p>
                   </a:txBody>
@@ -8079,16 +8081,16 @@
                           <a:solidFill>
                             <a:srgbClr val="3B5BFD"/>
                           </a:solidFill>
-                          <a:latin typeface="PingFang SC" pitchFamily="34" charset="0"/>
-                          <a:ea typeface="PingFang SC" pitchFamily="34" charset="-122"/>
-                          <a:cs typeface="PingFang SC" pitchFamily="34" charset="-120"/>
+                          <a:latin typeface="Microsoft YaHei" pitchFamily="34" charset="0"/>
+                          <a:ea typeface="Microsoft YaHei" pitchFamily="34" charset="-122"/>
+                          <a:cs typeface="Microsoft YaHei" pitchFamily="34" charset="-120"/>
                         </a:rPr>
                         <a:t>A3 知识热更新</a:t>
                       </a:r>
                       <a:endParaRPr lang="en-US" sz="1150" dirty="0">
-                        <a:latin typeface="PingFang SC" charset="0"/>
-                        <a:ea typeface="PingFang SC" charset="0"/>
-                        <a:cs typeface="PingFang SC" charset="0"/>
+                        <a:latin typeface="Microsoft YaHei" charset="0"/>
+                        <a:ea typeface="Microsoft YaHei" charset="0"/>
+                        <a:cs typeface="Microsoft YaHei" charset="0"/>
                       </a:endParaRPr>
                     </a:p>
                   </a:txBody>
@@ -8147,16 +8149,16 @@
                           <a:solidFill>
                             <a:srgbClr val="1C2333"/>
                           </a:solidFill>
-                          <a:latin typeface="PingFang SC" pitchFamily="34" charset="0"/>
-                          <a:ea typeface="PingFang SC" pitchFamily="34" charset="-122"/>
-                          <a:cs typeface="PingFang SC" pitchFamily="34" charset="-120"/>
+                          <a:latin typeface="Microsoft YaHei" pitchFamily="34" charset="0"/>
+                          <a:ea typeface="Microsoft YaHei" pitchFamily="34" charset="-122"/>
+                          <a:cs typeface="Microsoft YaHei" pitchFamily="34" charset="-120"/>
                         </a:rPr>
                         <a:t>录入即检索，无需重启，验后清理</a:t>
                       </a:r>
                       <a:endParaRPr lang="en-US" sz="1150" dirty="0">
-                        <a:latin typeface="PingFang SC" charset="0"/>
-                        <a:ea typeface="PingFang SC" charset="0"/>
-                        <a:cs typeface="PingFang SC" charset="0"/>
+                        <a:latin typeface="Microsoft YaHei" charset="0"/>
+                        <a:ea typeface="Microsoft YaHei" charset="0"/>
+                        <a:cs typeface="Microsoft YaHei" charset="0"/>
                       </a:endParaRPr>
                     </a:p>
                   </a:txBody>
@@ -8215,16 +8217,16 @@
                           <a:solidFill>
                             <a:srgbClr val="12B76A"/>
                           </a:solidFill>
-                          <a:latin typeface="PingFang SC" pitchFamily="34" charset="0"/>
-                          <a:ea typeface="PingFang SC" pitchFamily="34" charset="-122"/>
-                          <a:cs typeface="PingFang SC" pitchFamily="34" charset="-120"/>
+                          <a:latin typeface="Microsoft YaHei" pitchFamily="34" charset="0"/>
+                          <a:ea typeface="Microsoft YaHei" pitchFamily="34" charset="-122"/>
+                          <a:cs typeface="Microsoft YaHei" pitchFamily="34" charset="-120"/>
                         </a:rPr>
                         <a:t>PASS</a:t>
                       </a:r>
                       <a:endParaRPr lang="en-US" sz="1150" dirty="0">
-                        <a:latin typeface="PingFang SC" charset="0"/>
-                        <a:ea typeface="PingFang SC" charset="0"/>
-                        <a:cs typeface="PingFang SC" charset="0"/>
+                        <a:latin typeface="Microsoft YaHei" charset="0"/>
+                        <a:ea typeface="Microsoft YaHei" charset="0"/>
+                        <a:cs typeface="Microsoft YaHei" charset="0"/>
                       </a:endParaRPr>
                     </a:p>
                   </a:txBody>
@@ -8283,16 +8285,16 @@
                           <a:solidFill>
                             <a:srgbClr val="1C2333"/>
                           </a:solidFill>
-                          <a:latin typeface="PingFang SC" pitchFamily="34" charset="0"/>
-                          <a:ea typeface="PingFang SC" pitchFamily="34" charset="-122"/>
-                          <a:cs typeface="PingFang SC" pitchFamily="34" charset="-120"/>
+                          <a:latin typeface="Microsoft YaHei" pitchFamily="34" charset="0"/>
+                          <a:ea typeface="Microsoft YaHei" pitchFamily="34" charset="-122"/>
+                          <a:cs typeface="Microsoft YaHei" pitchFamily="34" charset="-120"/>
                         </a:rPr>
                         <a:t>索引版本 1→2→3 递增，即时命中并正确回答</a:t>
                       </a:r>
                       <a:endParaRPr lang="en-US" sz="1150" dirty="0">
-                        <a:latin typeface="PingFang SC" charset="0"/>
-                        <a:ea typeface="PingFang SC" charset="0"/>
-                        <a:cs typeface="PingFang SC" charset="0"/>
+                        <a:latin typeface="Microsoft YaHei" charset="0"/>
+                        <a:ea typeface="Microsoft YaHei" charset="0"/>
+                        <a:cs typeface="Microsoft YaHei" charset="0"/>
                       </a:endParaRPr>
                     </a:p>
                   </a:txBody>
@@ -8353,16 +8355,16 @@
                           <a:solidFill>
                             <a:srgbClr val="3B5BFD"/>
                           </a:solidFill>
-                          <a:latin typeface="PingFang SC" pitchFamily="34" charset="0"/>
-                          <a:ea typeface="PingFang SC" pitchFamily="34" charset="-122"/>
-                          <a:cs typeface="PingFang SC" pitchFamily="34" charset="-120"/>
+                          <a:latin typeface="Microsoft YaHei" pitchFamily="34" charset="0"/>
+                          <a:ea typeface="Microsoft YaHei" pitchFamily="34" charset="-122"/>
+                          <a:cs typeface="Microsoft YaHei" pitchFamily="34" charset="-120"/>
                         </a:rPr>
                         <a:t>A4 无知识兑底</a:t>
                       </a:r>
                       <a:endParaRPr lang="en-US" sz="1150" dirty="0">
-                        <a:latin typeface="PingFang SC" charset="0"/>
-                        <a:ea typeface="PingFang SC" charset="0"/>
-                        <a:cs typeface="PingFang SC" charset="0"/>
+                        <a:latin typeface="Microsoft YaHei" charset="0"/>
+                        <a:ea typeface="Microsoft YaHei" charset="0"/>
+                        <a:cs typeface="Microsoft YaHei" charset="0"/>
                       </a:endParaRPr>
                     </a:p>
                   </a:txBody>
@@ -8421,16 +8423,16 @@
                           <a:solidFill>
                             <a:srgbClr val="1C2333"/>
                           </a:solidFill>
-                          <a:latin typeface="PingFang SC" pitchFamily="34" charset="0"/>
-                          <a:ea typeface="PingFang SC" pitchFamily="34" charset="-122"/>
-                          <a:cs typeface="PingFang SC" pitchFamily="34" charset="-120"/>
+                          <a:latin typeface="Microsoft YaHei" pitchFamily="34" charset="0"/>
+                          <a:ea typeface="Microsoft YaHei" pitchFamily="34" charset="-122"/>
+                          <a:cs typeface="Microsoft YaHei" pitchFamily="34" charset="-120"/>
                         </a:rPr>
                         <a:t>无相关知识时不编造</a:t>
                       </a:r>
                       <a:endParaRPr lang="en-US" sz="1150" dirty="0">
-                        <a:latin typeface="PingFang SC" charset="0"/>
-                        <a:ea typeface="PingFang SC" charset="0"/>
-                        <a:cs typeface="PingFang SC" charset="0"/>
+                        <a:latin typeface="Microsoft YaHei" charset="0"/>
+                        <a:ea typeface="Microsoft YaHei" charset="0"/>
+                        <a:cs typeface="Microsoft YaHei" charset="0"/>
                       </a:endParaRPr>
                     </a:p>
                   </a:txBody>
@@ -8489,16 +8491,16 @@
                           <a:solidFill>
                             <a:srgbClr val="12B76A"/>
                           </a:solidFill>
-                          <a:latin typeface="PingFang SC" pitchFamily="34" charset="0"/>
-                          <a:ea typeface="PingFang SC" pitchFamily="34" charset="-122"/>
-                          <a:cs typeface="PingFang SC" pitchFamily="34" charset="-120"/>
+                          <a:latin typeface="Microsoft YaHei" pitchFamily="34" charset="0"/>
+                          <a:ea typeface="Microsoft YaHei" pitchFamily="34" charset="-122"/>
+                          <a:cs typeface="Microsoft YaHei" pitchFamily="34" charset="-120"/>
                         </a:rPr>
                         <a:t>PASS</a:t>
                       </a:r>
                       <a:endParaRPr lang="en-US" sz="1150" dirty="0">
-                        <a:latin typeface="PingFang SC" charset="0"/>
-                        <a:ea typeface="PingFang SC" charset="0"/>
-                        <a:cs typeface="PingFang SC" charset="0"/>
+                        <a:latin typeface="Microsoft YaHei" charset="0"/>
+                        <a:ea typeface="Microsoft YaHei" charset="0"/>
+                        <a:cs typeface="Microsoft YaHei" charset="0"/>
                       </a:endParaRPr>
                     </a:p>
                   </a:txBody>
@@ -8557,16 +8559,16 @@
                           <a:solidFill>
                             <a:srgbClr val="1C2333"/>
                           </a:solidFill>
-                          <a:latin typeface="PingFang SC" pitchFamily="34" charset="0"/>
-                          <a:ea typeface="PingFang SC" pitchFamily="34" charset="-122"/>
-                          <a:cs typeface="PingFang SC" pitchFamily="34" charset="-120"/>
+                          <a:latin typeface="Microsoft YaHei" pitchFamily="34" charset="0"/>
+                          <a:ea typeface="Microsoft YaHei" pitchFamily="34" charset="-122"/>
+                          <a:cs typeface="Microsoft YaHei" pitchFamily="34" charset="-120"/>
                         </a:rPr>
                         <a:t>sources=0，返回引导性回退话术</a:t>
                       </a:r>
                       <a:endParaRPr lang="en-US" sz="1150" dirty="0">
-                        <a:latin typeface="PingFang SC" charset="0"/>
-                        <a:ea typeface="PingFang SC" charset="0"/>
-                        <a:cs typeface="PingFang SC" charset="0"/>
+                        <a:latin typeface="Microsoft YaHei" charset="0"/>
+                        <a:ea typeface="Microsoft YaHei" charset="0"/>
+                        <a:cs typeface="Microsoft YaHei" charset="0"/>
                       </a:endParaRPr>
                     </a:p>
                   </a:txBody>
@@ -8666,9 +8668,9 @@
                 <a:solidFill>
                   <a:srgbClr val="FFFFFF"/>
                 </a:solidFill>
-                <a:latin typeface="PingFang SC" pitchFamily="34" charset="0"/>
-                <a:ea typeface="PingFang SC" pitchFamily="34" charset="-122"/>
-                <a:cs typeface="PingFang SC" pitchFamily="34" charset="-120"/>
+                <a:latin typeface="Microsoft YaHei" pitchFamily="34" charset="0"/>
+                <a:ea typeface="Microsoft YaHei" pitchFamily="34" charset="-122"/>
+                <a:cs typeface="Microsoft YaHei" pitchFamily="34" charset="-120"/>
               </a:rPr>
               <a:t>需求 FR/NFR</a:t>
             </a:r>
@@ -8725,9 +8727,9 @@
                 <a:solidFill>
                   <a:srgbClr val="FFFFFF"/>
                 </a:solidFill>
-                <a:latin typeface="PingFang SC" pitchFamily="34" charset="0"/>
-                <a:ea typeface="PingFang SC" pitchFamily="34" charset="-122"/>
-                <a:cs typeface="PingFang SC" pitchFamily="34" charset="-120"/>
+                <a:latin typeface="Microsoft YaHei" pitchFamily="34" charset="0"/>
+                <a:ea typeface="Microsoft YaHei" pitchFamily="34" charset="-122"/>
+                <a:cs typeface="Microsoft YaHei" pitchFamily="34" charset="-120"/>
               </a:rPr>
               <a:t>质量属性场景</a:t>
             </a:r>
@@ -8784,9 +8786,9 @@
                 <a:solidFill>
                   <a:srgbClr val="FFFFFF"/>
                 </a:solidFill>
-                <a:latin typeface="PingFang SC" pitchFamily="34" charset="0"/>
-                <a:ea typeface="PingFang SC" pitchFamily="34" charset="-122"/>
-                <a:cs typeface="PingFang SC" pitchFamily="34" charset="-120"/>
+                <a:latin typeface="Microsoft YaHei" pitchFamily="34" charset="0"/>
+                <a:ea typeface="Microsoft YaHei" pitchFamily="34" charset="-122"/>
+                <a:cs typeface="Microsoft YaHei" pitchFamily="34" charset="-120"/>
               </a:rPr>
               <a:t>ADR ×7</a:t>
             </a:r>
@@ -8843,9 +8845,9 @@
                 <a:solidFill>
                   <a:srgbClr val="FFFFFF"/>
                 </a:solidFill>
-                <a:latin typeface="PingFang SC" pitchFamily="34" charset="0"/>
-                <a:ea typeface="PingFang SC" pitchFamily="34" charset="-122"/>
-                <a:cs typeface="PingFang SC" pitchFamily="34" charset="-120"/>
+                <a:latin typeface="Microsoft YaHei" pitchFamily="34" charset="0"/>
+                <a:ea typeface="Microsoft YaHei" pitchFamily="34" charset="-122"/>
+                <a:cs typeface="Microsoft YaHei" pitchFamily="34" charset="-120"/>
               </a:rPr>
               <a:t>实现模块</a:t>
             </a:r>
@@ -8902,9 +8904,9 @@
                 <a:solidFill>
                   <a:srgbClr val="FFFFFF"/>
                 </a:solidFill>
-                <a:latin typeface="PingFang SC" pitchFamily="34" charset="0"/>
-                <a:ea typeface="PingFang SC" pitchFamily="34" charset="-122"/>
-                <a:cs typeface="PingFang SC" pitchFamily="34" charset="-120"/>
+                <a:latin typeface="Microsoft YaHei" pitchFamily="34" charset="0"/>
+                <a:ea typeface="Microsoft YaHei" pitchFamily="34" charset="-122"/>
+                <a:cs typeface="Microsoft YaHei" pitchFamily="34" charset="-120"/>
               </a:rPr>
               <a:t>测试/验收脚本</a:t>
             </a:r>
@@ -8961,9 +8963,9 @@
                 <a:solidFill>
                   <a:srgbClr val="FFFFFF"/>
                 </a:solidFill>
-                <a:latin typeface="PingFang SC" pitchFamily="34" charset="0"/>
-                <a:ea typeface="PingFang SC" pitchFamily="34" charset="-122"/>
-                <a:cs typeface="PingFang SC" pitchFamily="34" charset="-120"/>
+                <a:latin typeface="Microsoft YaHei" pitchFamily="34" charset="0"/>
+                <a:ea typeface="Microsoft YaHei" pitchFamily="34" charset="-122"/>
+                <a:cs typeface="Microsoft YaHei" pitchFamily="34" charset="-120"/>
               </a:rPr>
               <a:t>实测证据</a:t>
             </a:r>
@@ -9037,9 +9039,9 @@
                 <a:solidFill>
                   <a:srgbClr val="3B5BFD"/>
                 </a:solidFill>
-                <a:latin typeface="PingFang SC" pitchFamily="34" charset="0"/>
-                <a:ea typeface="PingFang SC" pitchFamily="34" charset="-122"/>
-                <a:cs typeface="PingFang SC" pitchFamily="34" charset="-120"/>
+                <a:latin typeface="Microsoft YaHei" pitchFamily="34" charset="0"/>
+                <a:ea typeface="Microsoft YaHei" pitchFamily="34" charset="-122"/>
+                <a:cs typeface="Microsoft YaHei" pitchFamily="34" charset="-120"/>
               </a:rPr>
               <a:t>证据体系：</a:t>
             </a:r>
@@ -9054,9 +9056,9 @@
                 <a:solidFill>
                   <a:srgbClr val="1C2333"/>
                 </a:solidFill>
-                <a:latin typeface="PingFang SC" pitchFamily="34" charset="0"/>
-                <a:ea typeface="PingFang SC" pitchFamily="34" charset="-122"/>
-                <a:cs typeface="PingFang SC" pitchFamily="34" charset="-120"/>
+                <a:latin typeface="Microsoft YaHei" pitchFamily="34" charset="0"/>
+                <a:ea typeface="Microsoft YaHei" pitchFamily="34" charset="-122"/>
+                <a:cs typeface="Microsoft YaHei" pitchFamily="34" charset="-120"/>
               </a:rPr>
               <a:t>62 条评测集（四路对比）、300+200 性能基准（含 p50/p95/p99）、四项验收 4/4 PASS、60 秒演示录屏 —— 全部由 scripts/ 下可复现脚本产出，任何结论可重跑验证</a:t>
             </a:r>
@@ -9125,9 +9127,9 @@
                 <a:solidFill>
                   <a:srgbClr val="1C2333"/>
                 </a:solidFill>
-                <a:latin typeface="PingFang SC" pitchFamily="34" charset="0"/>
-                <a:ea typeface="PingFang SC" pitchFamily="34" charset="-122"/>
-                <a:cs typeface="PingFang SC" pitchFamily="34" charset="-120"/>
+                <a:latin typeface="Microsoft YaHei" pitchFamily="34" charset="0"/>
+                <a:ea typeface="Microsoft YaHei" pitchFamily="34" charset="-122"/>
+                <a:cs typeface="Microsoft YaHei" pitchFamily="34" charset="-120"/>
               </a:rPr>
               <a:t>安全与稳定性：三道防线</a:t>
             </a:r>
@@ -9164,9 +9166,9 @@
                 <a:solidFill>
                   <a:srgbClr val="6A7390"/>
                 </a:solidFill>
-                <a:latin typeface="PingFang SC" pitchFamily="34" charset="0"/>
-                <a:ea typeface="PingFang SC" pitchFamily="34" charset="-122"/>
-                <a:cs typeface="PingFang SC" pitchFamily="34" charset="-120"/>
+                <a:latin typeface="Microsoft YaHei" pitchFamily="34" charset="0"/>
+                <a:ea typeface="Microsoft YaHei" pitchFamily="34" charset="-122"/>
+                <a:cs typeface="Microsoft YaHei" pitchFamily="34" charset="-120"/>
               </a:rPr>
               <a:t>限流拗流量 · 降级保可用 · 溯源拗幻觉</a:t>
             </a:r>
@@ -9203,9 +9205,9 @@
                 <a:solidFill>
                   <a:srgbClr val="6A7390"/>
                 </a:solidFill>
-                <a:latin typeface="PingFang SC" pitchFamily="34" charset="0"/>
-                <a:ea typeface="PingFang SC" pitchFamily="34" charset="-122"/>
-                <a:cs typeface="PingFang SC" pitchFamily="34" charset="-120"/>
+                <a:latin typeface="Microsoft YaHei" pitchFamily="34" charset="0"/>
+                <a:ea typeface="Microsoft YaHei" pitchFamily="34" charset="-122"/>
+                <a:cs typeface="Microsoft YaHei" pitchFamily="34" charset="-120"/>
               </a:rPr>
               <a:t>15</a:t>
             </a:r>
@@ -9296,9 +9298,9 @@
                 <a:solidFill>
                   <a:srgbClr val="FFFFFF"/>
                 </a:solidFill>
-                <a:latin typeface="PingFang SC" pitchFamily="34" charset="0"/>
-                <a:ea typeface="PingFang SC" pitchFamily="34" charset="-122"/>
-                <a:cs typeface="PingFang SC" pitchFamily="34" charset="-120"/>
+                <a:latin typeface="Microsoft YaHei" pitchFamily="34" charset="0"/>
+                <a:ea typeface="Microsoft YaHei" pitchFamily="34" charset="-122"/>
+                <a:cs typeface="Microsoft YaHei" pitchFamily="34" charset="-120"/>
               </a:rPr>
               <a:t>①</a:t>
             </a:r>
@@ -9335,9 +9337,9 @@
                 <a:solidFill>
                   <a:srgbClr val="1C2333"/>
                 </a:solidFill>
-                <a:latin typeface="PingFang SC" pitchFamily="34" charset="0"/>
-                <a:ea typeface="PingFang SC" pitchFamily="34" charset="-122"/>
-                <a:cs typeface="PingFang SC" pitchFamily="34" charset="-120"/>
+                <a:latin typeface="Microsoft YaHei" pitchFamily="34" charset="0"/>
+                <a:ea typeface="Microsoft YaHei" pitchFamily="34" charset="-122"/>
+                <a:cs typeface="Microsoft YaHei" pitchFamily="34" charset="-120"/>
               </a:rPr>
               <a:t>令牌桶限流</a:t>
             </a:r>
@@ -9377,9 +9379,9 @@
                 <a:solidFill>
                   <a:srgbClr val="6A7390"/>
                 </a:solidFill>
-                <a:latin typeface="PingFang SC" pitchFamily="34" charset="0"/>
-                <a:ea typeface="PingFang SC" pitchFamily="34" charset="-122"/>
-                <a:cs typeface="PingFang SC" pitchFamily="34" charset="-120"/>
+                <a:latin typeface="Microsoft YaHei" pitchFamily="34" charset="0"/>
+                <a:ea typeface="Microsoft YaHei" pitchFamily="34" charset="-122"/>
+                <a:cs typeface="Microsoft YaHei" pitchFamily="34" charset="-120"/>
               </a:rPr>
               <a:t>5 QPS/用户 · 突发 10，超限返回 429；Pydantic 强校验输入长度与内容</a:t>
             </a:r>
@@ -9438,9 +9440,9 @@
                 <a:solidFill>
                   <a:srgbClr val="3B5BFD"/>
                 </a:solidFill>
-                <a:latin typeface="PingFang SC" pitchFamily="34" charset="0"/>
-                <a:ea typeface="PingFang SC" pitchFamily="34" charset="-122"/>
-                <a:cs typeface="PingFang SC" pitchFamily="34" charset="-120"/>
+                <a:latin typeface="Microsoft YaHei" pitchFamily="34" charset="0"/>
+                <a:ea typeface="Microsoft YaHei" pitchFamily="34" charset="-122"/>
+                <a:cs typeface="Microsoft YaHei" pitchFamily="34" charset="-120"/>
               </a:rPr>
               <a:t>演示代砆</a:t>
             </a:r>
@@ -9531,9 +9533,9 @@
                 <a:solidFill>
                   <a:srgbClr val="FFFFFF"/>
                 </a:solidFill>
-                <a:latin typeface="PingFang SC" pitchFamily="34" charset="0"/>
-                <a:ea typeface="PingFang SC" pitchFamily="34" charset="-122"/>
-                <a:cs typeface="PingFang SC" pitchFamily="34" charset="-120"/>
+                <a:latin typeface="Microsoft YaHei" pitchFamily="34" charset="0"/>
+                <a:ea typeface="Microsoft YaHei" pitchFamily="34" charset="-122"/>
+                <a:cs typeface="Microsoft YaHei" pitchFamily="34" charset="-120"/>
               </a:rPr>
               <a:t>②</a:t>
             </a:r>
@@ -9570,9 +9572,9 @@
                 <a:solidFill>
                   <a:srgbClr val="1C2333"/>
                 </a:solidFill>
-                <a:latin typeface="PingFang SC" pitchFamily="34" charset="0"/>
-                <a:ea typeface="PingFang SC" pitchFamily="34" charset="-122"/>
-                <a:cs typeface="PingFang SC" pitchFamily="34" charset="-120"/>
+                <a:latin typeface="Microsoft YaHei" pitchFamily="34" charset="0"/>
+                <a:ea typeface="Microsoft YaHei" pitchFamily="34" charset="-122"/>
+                <a:cs typeface="Microsoft YaHei" pitchFamily="34" charset="-120"/>
               </a:rPr>
               <a:t>生成降级熔断</a:t>
             </a:r>
@@ -9612,9 +9614,9 @@
                 <a:solidFill>
                   <a:srgbClr val="6A7390"/>
                 </a:solidFill>
-                <a:latin typeface="PingFang SC" pitchFamily="34" charset="0"/>
-                <a:ea typeface="PingFang SC" pitchFamily="34" charset="-122"/>
-                <a:cs typeface="PingFang SC" pitchFamily="34" charset="-120"/>
+                <a:latin typeface="Microsoft YaHei" pitchFamily="34" charset="0"/>
+                <a:ea typeface="Microsoft YaHei" pitchFamily="34" charset="-122"/>
+                <a:cs typeface="Microsoft YaHei" pitchFamily="34" charset="-120"/>
               </a:rPr>
               <a:t>云端 GLM 30s 超时；任何异常流内回退本地抽取式生成，服务不中断</a:t>
             </a:r>
@@ -9673,9 +9675,9 @@
                 <a:solidFill>
                   <a:srgbClr val="FF8A3D"/>
                 </a:solidFill>
-                <a:latin typeface="PingFang SC" pitchFamily="34" charset="0"/>
-                <a:ea typeface="PingFang SC" pitchFamily="34" charset="-122"/>
-                <a:cs typeface="PingFang SC" pitchFamily="34" charset="-120"/>
+                <a:latin typeface="Microsoft YaHei" pitchFamily="34" charset="0"/>
+                <a:ea typeface="Microsoft YaHei" pitchFamily="34" charset="-122"/>
+                <a:cs typeface="Microsoft YaHei" pitchFamily="34" charset="-120"/>
               </a:rPr>
               <a:t>检索永远可用</a:t>
             </a:r>
@@ -9766,9 +9768,9 @@
                 <a:solidFill>
                   <a:srgbClr val="FFFFFF"/>
                 </a:solidFill>
-                <a:latin typeface="PingFang SC" pitchFamily="34" charset="0"/>
-                <a:ea typeface="PingFang SC" pitchFamily="34" charset="-122"/>
-                <a:cs typeface="PingFang SC" pitchFamily="34" charset="-120"/>
+                <a:latin typeface="Microsoft YaHei" pitchFamily="34" charset="0"/>
+                <a:ea typeface="Microsoft YaHei" pitchFamily="34" charset="-122"/>
+                <a:cs typeface="Microsoft YaHei" pitchFamily="34" charset="-120"/>
               </a:rPr>
               <a:t>③</a:t>
             </a:r>
@@ -9805,9 +9807,9 @@
                 <a:solidFill>
                   <a:srgbClr val="1C2333"/>
                 </a:solidFill>
-                <a:latin typeface="PingFang SC" pitchFamily="34" charset="0"/>
-                <a:ea typeface="PingFang SC" pitchFamily="34" charset="-122"/>
-                <a:cs typeface="PingFang SC" pitchFamily="34" charset="-120"/>
+                <a:latin typeface="Microsoft YaHei" pitchFamily="34" charset="0"/>
+                <a:ea typeface="Microsoft YaHei" pitchFamily="34" charset="-122"/>
+                <a:cs typeface="Microsoft YaHei" pitchFamily="34" charset="-120"/>
               </a:rPr>
               <a:t>引用溯源拗幻觉</a:t>
             </a:r>
@@ -9847,9 +9849,9 @@
                 <a:solidFill>
                   <a:srgbClr val="6A7390"/>
                 </a:solidFill>
-                <a:latin typeface="PingFang SC" pitchFamily="34" charset="0"/>
-                <a:ea typeface="PingFang SC" pitchFamily="34" charset="-122"/>
-                <a:cs typeface="PingFang SC" pitchFamily="34" charset="-120"/>
+                <a:latin typeface="Microsoft YaHei" pitchFamily="34" charset="0"/>
+                <a:ea typeface="Microsoft YaHei" pitchFamily="34" charset="-122"/>
+                <a:cs typeface="Microsoft YaHei" pitchFamily="34" charset="-120"/>
               </a:rPr>
               <a:t>回答强制标注来源与分类；无命中不编造，回退话术并引导换问法</a:t>
             </a:r>
@@ -9908,9 +9910,9 @@
                 <a:solidFill>
                   <a:srgbClr val="7C4DFF"/>
                 </a:solidFill>
-                <a:latin typeface="PingFang SC" pitchFamily="34" charset="0"/>
-                <a:ea typeface="PingFang SC" pitchFamily="34" charset="-122"/>
-                <a:cs typeface="PingFang SC" pitchFamily="34" charset="-120"/>
+                <a:latin typeface="Microsoft YaHei" pitchFamily="34" charset="0"/>
+                <a:ea typeface="Microsoft YaHei" pitchFamily="34" charset="-122"/>
+                <a:cs typeface="Microsoft YaHei" pitchFamily="34" charset="-120"/>
               </a:rPr>
               <a:t>提示「以官方通知为准」</a:t>
             </a:r>
@@ -9979,9 +9981,9 @@
                 <a:solidFill>
                   <a:srgbClr val="1C2333"/>
                 </a:solidFill>
-                <a:latin typeface="PingFang SC" pitchFamily="34" charset="0"/>
-                <a:ea typeface="PingFang SC" pitchFamily="34" charset="-122"/>
-                <a:cs typeface="PingFang SC" pitchFamily="34" charset="-120"/>
+                <a:latin typeface="Microsoft YaHei" pitchFamily="34" charset="0"/>
+                <a:ea typeface="Microsoft YaHei" pitchFamily="34" charset="-122"/>
+                <a:cs typeface="Microsoft YaHei" pitchFamily="34" charset="-120"/>
               </a:rPr>
               <a:t>部署演进：接口不变，组件可替换</a:t>
             </a:r>
@@ -10018,9 +10020,9 @@
                 <a:solidFill>
                   <a:srgbClr val="6A7390"/>
                 </a:solidFill>
-                <a:latin typeface="PingFang SC" pitchFamily="34" charset="0"/>
-                <a:ea typeface="PingFang SC" pitchFamily="34" charset="-122"/>
-                <a:cs typeface="PingFang SC" pitchFamily="34" charset="-120"/>
+                <a:latin typeface="Microsoft YaHei" pitchFamily="34" charset="0"/>
+                <a:ea typeface="Microsoft YaHei" pitchFamily="34" charset="-122"/>
+                <a:cs typeface="Microsoft YaHei" pitchFamily="34" charset="-120"/>
               </a:rPr>
               <a:t>单机演示 → 生产集群的平滑演进路径</a:t>
             </a:r>
@@ -10057,9 +10059,9 @@
                 <a:solidFill>
                   <a:srgbClr val="6A7390"/>
                 </a:solidFill>
-                <a:latin typeface="PingFang SC" pitchFamily="34" charset="0"/>
-                <a:ea typeface="PingFang SC" pitchFamily="34" charset="-122"/>
-                <a:cs typeface="PingFang SC" pitchFamily="34" charset="-120"/>
+                <a:latin typeface="Microsoft YaHei" pitchFamily="34" charset="0"/>
+                <a:ea typeface="Microsoft YaHei" pitchFamily="34" charset="-122"/>
+                <a:cs typeface="Microsoft YaHei" pitchFamily="34" charset="-120"/>
               </a:rPr>
               <a:t>16</a:t>
             </a:r>
@@ -10152,9 +10154,9 @@
                 <a:solidFill>
                   <a:srgbClr val="1C2333"/>
                 </a:solidFill>
-                <a:latin typeface="PingFang SC" pitchFamily="34" charset="0"/>
-                <a:ea typeface="PingFang SC" pitchFamily="34" charset="-122"/>
-                <a:cs typeface="PingFang SC" pitchFamily="34" charset="-120"/>
+                <a:latin typeface="Microsoft YaHei" pitchFamily="34" charset="0"/>
+                <a:ea typeface="Microsoft YaHei" pitchFamily="34" charset="-122"/>
+                <a:cs typeface="Microsoft YaHei" pitchFamily="34" charset="-120"/>
               </a:rPr>
               <a:t>8 周迭代计划与团队分工</a:t>
             </a:r>
@@ -10191,9 +10193,9 @@
                 <a:solidFill>
                   <a:srgbClr val="6A7390"/>
                 </a:solidFill>
-                <a:latin typeface="PingFang SC" pitchFamily="34" charset="0"/>
-                <a:ea typeface="PingFang SC" pitchFamily="34" charset="-122"/>
-                <a:cs typeface="PingFang SC" pitchFamily="34" charset="-120"/>
+                <a:latin typeface="Microsoft YaHei" pitchFamily="34" charset="0"/>
+                <a:ea typeface="Microsoft YaHei" pitchFamily="34" charset="-122"/>
+                <a:cs typeface="Microsoft YaHei" pitchFamily="34" charset="-120"/>
               </a:rPr>
               <a:t>架构师牵头 · 前后端与数据运营并行 · 测试贯穿全程</a:t>
             </a:r>
@@ -10230,9 +10232,9 @@
                 <a:solidFill>
                   <a:srgbClr val="6A7390"/>
                 </a:solidFill>
-                <a:latin typeface="PingFang SC" pitchFamily="34" charset="0"/>
-                <a:ea typeface="PingFang SC" pitchFamily="34" charset="-122"/>
-                <a:cs typeface="PingFang SC" pitchFamily="34" charset="-120"/>
+                <a:latin typeface="Microsoft YaHei" pitchFamily="34" charset="0"/>
+                <a:ea typeface="Microsoft YaHei" pitchFamily="34" charset="-122"/>
+                <a:cs typeface="Microsoft YaHei" pitchFamily="34" charset="-120"/>
               </a:rPr>
               <a:t>17</a:t>
             </a:r>
@@ -10324,9 +10326,9 @@
                 <a:solidFill>
                   <a:srgbClr val="FFFFFF"/>
                 </a:solidFill>
-                <a:latin typeface="PingFang SC" pitchFamily="34" charset="0"/>
-                <a:ea typeface="PingFang SC" pitchFamily="34" charset="-122"/>
-                <a:cs typeface="PingFang SC" pitchFamily="34" charset="-120"/>
+                <a:latin typeface="Microsoft YaHei" pitchFamily="34" charset="0"/>
+                <a:ea typeface="Microsoft YaHei" pitchFamily="34" charset="-122"/>
+                <a:cs typeface="Microsoft YaHei" pitchFamily="34" charset="-120"/>
               </a:rPr>
               <a:t>1–W2</a:t>
             </a:r>
@@ -10363,9 +10365,9 @@
                 <a:solidFill>
                   <a:srgbClr val="3B5BFD"/>
                 </a:solidFill>
-                <a:latin typeface="PingFang SC" pitchFamily="34" charset="0"/>
-                <a:ea typeface="PingFang SC" pitchFamily="34" charset="-122"/>
-                <a:cs typeface="PingFang SC" pitchFamily="34" charset="-120"/>
+                <a:latin typeface="Microsoft YaHei" pitchFamily="34" charset="0"/>
+                <a:ea typeface="Microsoft YaHei" pitchFamily="34" charset="-122"/>
+                <a:cs typeface="Microsoft YaHei" pitchFamily="34" charset="-120"/>
               </a:rPr>
               <a:t>W1–W2</a:t>
             </a:r>
@@ -10405,9 +10407,9 @@
                 <a:solidFill>
                   <a:srgbClr val="1C2333"/>
                 </a:solidFill>
-                <a:latin typeface="PingFang SC" pitchFamily="34" charset="0"/>
-                <a:ea typeface="PingFang SC" pitchFamily="34" charset="-122"/>
-                <a:cs typeface="PingFang SC" pitchFamily="34" charset="-120"/>
+                <a:latin typeface="Microsoft YaHei" pitchFamily="34" charset="0"/>
+                <a:ea typeface="Microsoft YaHei" pitchFamily="34" charset="-122"/>
+                <a:cs typeface="Microsoft YaHei" pitchFamily="34" charset="-120"/>
               </a:rPr>
               <a:t>调研+需求+架构原型</a:t>
             </a:r>
@@ -10447,9 +10449,9 @@
                 <a:solidFill>
                   <a:srgbClr val="6A7390"/>
                 </a:solidFill>
-                <a:latin typeface="PingFang SC" pitchFamily="34" charset="0"/>
-                <a:ea typeface="PingFang SC" pitchFamily="34" charset="-122"/>
-                <a:cs typeface="PingFang SC" pitchFamily="34" charset="-120"/>
+                <a:latin typeface="Microsoft YaHei" pitchFamily="34" charset="0"/>
+                <a:ea typeface="Microsoft YaHei" pitchFamily="34" charset="-122"/>
+                <a:cs typeface="Microsoft YaHei" pitchFamily="34" charset="-120"/>
               </a:rPr>
               <a:t>质量属性场景·分层图</a:t>
             </a:r>
@@ -10518,9 +10520,9 @@
                 <a:solidFill>
                   <a:srgbClr val="FFFFFF"/>
                 </a:solidFill>
-                <a:latin typeface="PingFang SC" pitchFamily="34" charset="0"/>
-                <a:ea typeface="PingFang SC" pitchFamily="34" charset="-122"/>
-                <a:cs typeface="PingFang SC" pitchFamily="34" charset="-120"/>
+                <a:latin typeface="Microsoft YaHei" pitchFamily="34" charset="0"/>
+                <a:ea typeface="Microsoft YaHei" pitchFamily="34" charset="-122"/>
+                <a:cs typeface="Microsoft YaHei" pitchFamily="34" charset="-120"/>
               </a:rPr>
               <a:t>3–W4</a:t>
             </a:r>
@@ -10557,9 +10559,9 @@
                 <a:solidFill>
                   <a:srgbClr val="3B5BFD"/>
                 </a:solidFill>
-                <a:latin typeface="PingFang SC" pitchFamily="34" charset="0"/>
-                <a:ea typeface="PingFang SC" pitchFamily="34" charset="-122"/>
-                <a:cs typeface="PingFang SC" pitchFamily="34" charset="-120"/>
+                <a:latin typeface="Microsoft YaHei" pitchFamily="34" charset="0"/>
+                <a:ea typeface="Microsoft YaHei" pitchFamily="34" charset="-122"/>
+                <a:cs typeface="Microsoft YaHei" pitchFamily="34" charset="-120"/>
               </a:rPr>
               <a:t>W3–W4</a:t>
             </a:r>
@@ -10599,9 +10601,9 @@
                 <a:solidFill>
                   <a:srgbClr val="1C2333"/>
                 </a:solidFill>
-                <a:latin typeface="PingFang SC" pitchFamily="34" charset="0"/>
-                <a:ea typeface="PingFang SC" pitchFamily="34" charset="-122"/>
-                <a:cs typeface="PingFang SC" pitchFamily="34" charset="-120"/>
+                <a:latin typeface="Microsoft YaHei" pitchFamily="34" charset="0"/>
+                <a:ea typeface="Microsoft YaHei" pitchFamily="34" charset="-122"/>
+                <a:cs typeface="Microsoft YaHei" pitchFamily="34" charset="-120"/>
               </a:rPr>
               <a:t>知识库+混合检索落地</a:t>
             </a:r>
@@ -10641,9 +10643,9 @@
                 <a:solidFill>
                   <a:srgbClr val="6A7390"/>
                 </a:solidFill>
-                <a:latin typeface="PingFang SC" pitchFamily="34" charset="0"/>
-                <a:ea typeface="PingFang SC" pitchFamily="34" charset="-122"/>
-                <a:cs typeface="PingFang SC" pitchFamily="34" charset="-120"/>
+                <a:latin typeface="Microsoft YaHei" pitchFamily="34" charset="0"/>
+                <a:ea typeface="Microsoft YaHei" pitchFamily="34" charset="-122"/>
+                <a:cs typeface="Microsoft YaHei" pitchFamily="34" charset="-120"/>
               </a:rPr>
               <a:t>双通道召回·RRF</a:t>
             </a:r>
@@ -10712,9 +10714,9 @@
                 <a:solidFill>
                   <a:srgbClr val="FFFFFF"/>
                 </a:solidFill>
-                <a:latin typeface="PingFang SC" pitchFamily="34" charset="0"/>
-                <a:ea typeface="PingFang SC" pitchFamily="34" charset="-122"/>
-                <a:cs typeface="PingFang SC" pitchFamily="34" charset="-120"/>
+                <a:latin typeface="Microsoft YaHei" pitchFamily="34" charset="0"/>
+                <a:ea typeface="Microsoft YaHei" pitchFamily="34" charset="-122"/>
+                <a:cs typeface="Microsoft YaHei" pitchFamily="34" charset="-120"/>
               </a:rPr>
               <a:t>5–W6</a:t>
             </a:r>
@@ -10751,9 +10753,9 @@
                 <a:solidFill>
                   <a:srgbClr val="3B5BFD"/>
                 </a:solidFill>
-                <a:latin typeface="PingFang SC" pitchFamily="34" charset="0"/>
-                <a:ea typeface="PingFang SC" pitchFamily="34" charset="-122"/>
-                <a:cs typeface="PingFang SC" pitchFamily="34" charset="-120"/>
+                <a:latin typeface="Microsoft YaHei" pitchFamily="34" charset="0"/>
+                <a:ea typeface="Microsoft YaHei" pitchFamily="34" charset="-122"/>
+                <a:cs typeface="Microsoft YaHei" pitchFamily="34" charset="-120"/>
               </a:rPr>
               <a:t>W5–W6</a:t>
             </a:r>
@@ -10793,9 +10795,9 @@
                 <a:solidFill>
                   <a:srgbClr val="1C2333"/>
                 </a:solidFill>
-                <a:latin typeface="PingFang SC" pitchFamily="34" charset="0"/>
-                <a:ea typeface="PingFang SC" pitchFamily="34" charset="-122"/>
-                <a:cs typeface="PingFang SC" pitchFamily="34" charset="-120"/>
+                <a:latin typeface="Microsoft YaHei" pitchFamily="34" charset="0"/>
+                <a:ea typeface="Microsoft YaHei" pitchFamily="34" charset="-122"/>
+                <a:cs typeface="Microsoft YaHei" pitchFamily="34" charset="-120"/>
               </a:rPr>
               <a:t>前端+生成插件化</a:t>
             </a:r>
@@ -10835,9 +10837,9 @@
                 <a:solidFill>
                   <a:srgbClr val="6A7390"/>
                 </a:solidFill>
-                <a:latin typeface="PingFang SC" pitchFamily="34" charset="0"/>
-                <a:ea typeface="PingFang SC" pitchFamily="34" charset="-122"/>
-                <a:cs typeface="PingFang SC" pitchFamily="34" charset="-120"/>
+                <a:latin typeface="Microsoft YaHei" pitchFamily="34" charset="0"/>
+                <a:ea typeface="Microsoft YaHei" pitchFamily="34" charset="-122"/>
+                <a:cs typeface="Microsoft YaHei" pitchFamily="34" charset="-120"/>
               </a:rPr>
               <a:t>SSE 流式·看板</a:t>
             </a:r>
@@ -10906,9 +10908,9 @@
                 <a:solidFill>
                   <a:srgbClr val="FFFFFF"/>
                 </a:solidFill>
-                <a:latin typeface="PingFang SC" pitchFamily="34" charset="0"/>
-                <a:ea typeface="PingFang SC" pitchFamily="34" charset="-122"/>
-                <a:cs typeface="PingFang SC" pitchFamily="34" charset="-120"/>
+                <a:latin typeface="Microsoft YaHei" pitchFamily="34" charset="0"/>
+                <a:ea typeface="Microsoft YaHei" pitchFamily="34" charset="-122"/>
+                <a:cs typeface="Microsoft YaHei" pitchFamily="34" charset="-120"/>
               </a:rPr>
               <a:t>7</a:t>
             </a:r>
@@ -10945,9 +10947,9 @@
                 <a:solidFill>
                   <a:srgbClr val="3B5BFD"/>
                 </a:solidFill>
-                <a:latin typeface="PingFang SC" pitchFamily="34" charset="0"/>
-                <a:ea typeface="PingFang SC" pitchFamily="34" charset="-122"/>
-                <a:cs typeface="PingFang SC" pitchFamily="34" charset="-120"/>
+                <a:latin typeface="Microsoft YaHei" pitchFamily="34" charset="0"/>
+                <a:ea typeface="Microsoft YaHei" pitchFamily="34" charset="-122"/>
+                <a:cs typeface="Microsoft YaHei" pitchFamily="34" charset="-120"/>
               </a:rPr>
               <a:t>W7</a:t>
             </a:r>
@@ -10987,9 +10989,9 @@
                 <a:solidFill>
                   <a:srgbClr val="1C2333"/>
                 </a:solidFill>
-                <a:latin typeface="PingFang SC" pitchFamily="34" charset="0"/>
-                <a:ea typeface="PingFang SC" pitchFamily="34" charset="-122"/>
-                <a:cs typeface="PingFang SC" pitchFamily="34" charset="-120"/>
+                <a:latin typeface="Microsoft YaHei" pitchFamily="34" charset="0"/>
+                <a:ea typeface="Microsoft YaHei" pitchFamily="34" charset="-122"/>
+                <a:cs typeface="Microsoft YaHei" pitchFamily="34" charset="-120"/>
               </a:rPr>
               <a:t>压测调优+文档 PPT</a:t>
             </a:r>
@@ -11029,9 +11031,9 @@
                 <a:solidFill>
                   <a:srgbClr val="6A7390"/>
                 </a:solidFill>
-                <a:latin typeface="PingFang SC" pitchFamily="34" charset="0"/>
-                <a:ea typeface="PingFang SC" pitchFamily="34" charset="-122"/>
-                <a:cs typeface="PingFang SC" pitchFamily="34" charset="-120"/>
+                <a:latin typeface="Microsoft YaHei" pitchFamily="34" charset="0"/>
+                <a:ea typeface="Microsoft YaHei" pitchFamily="34" charset="-122"/>
+                <a:cs typeface="Microsoft YaHei" pitchFamily="34" charset="-120"/>
               </a:rPr>
               <a:t>评测报告·录屏</a:t>
             </a:r>
@@ -11100,9 +11102,9 @@
                 <a:solidFill>
                   <a:srgbClr val="FFFFFF"/>
                 </a:solidFill>
-                <a:latin typeface="PingFang SC" pitchFamily="34" charset="0"/>
-                <a:ea typeface="PingFang SC" pitchFamily="34" charset="-122"/>
-                <a:cs typeface="PingFang SC" pitchFamily="34" charset="-120"/>
+                <a:latin typeface="Microsoft YaHei" pitchFamily="34" charset="0"/>
+                <a:ea typeface="Microsoft YaHei" pitchFamily="34" charset="-122"/>
+                <a:cs typeface="Microsoft YaHei" pitchFamily="34" charset="-120"/>
               </a:rPr>
               <a:t>8</a:t>
             </a:r>
@@ -11139,9 +11141,9 @@
                 <a:solidFill>
                   <a:srgbClr val="FF8A3D"/>
                 </a:solidFill>
-                <a:latin typeface="PingFang SC" pitchFamily="34" charset="0"/>
-                <a:ea typeface="PingFang SC" pitchFamily="34" charset="-122"/>
-                <a:cs typeface="PingFang SC" pitchFamily="34" charset="-120"/>
+                <a:latin typeface="Microsoft YaHei" pitchFamily="34" charset="0"/>
+                <a:ea typeface="Microsoft YaHei" pitchFamily="34" charset="-122"/>
+                <a:cs typeface="Microsoft YaHei" pitchFamily="34" charset="-120"/>
               </a:rPr>
               <a:t>W8</a:t>
             </a:r>
@@ -11181,9 +11183,9 @@
                 <a:solidFill>
                   <a:srgbClr val="1C2333"/>
                 </a:solidFill>
-                <a:latin typeface="PingFang SC" pitchFamily="34" charset="0"/>
-                <a:ea typeface="PingFang SC" pitchFamily="34" charset="-122"/>
-                <a:cs typeface="PingFang SC" pitchFamily="34" charset="-120"/>
+                <a:latin typeface="Microsoft YaHei" pitchFamily="34" charset="0"/>
+                <a:ea typeface="Microsoft YaHei" pitchFamily="34" charset="-122"/>
+                <a:cs typeface="Microsoft YaHei" pitchFamily="34" charset="-120"/>
               </a:rPr>
               <a:t>答辩演练与交付</a:t>
             </a:r>
@@ -11223,9 +11225,9 @@
                 <a:solidFill>
                   <a:srgbClr val="6A7390"/>
                 </a:solidFill>
-                <a:latin typeface="PingFang SC" pitchFamily="34" charset="0"/>
-                <a:ea typeface="PingFang SC" pitchFamily="34" charset="-122"/>
-                <a:cs typeface="PingFang SC" pitchFamily="34" charset="-120"/>
+                <a:latin typeface="Microsoft YaHei" pitchFamily="34" charset="0"/>
+                <a:ea typeface="Microsoft YaHei" pitchFamily="34" charset="-122"/>
+                <a:cs typeface="Microsoft YaHei" pitchFamily="34" charset="-120"/>
               </a:rPr>
               <a:t>录屏剪辑·演示</a:t>
             </a:r>
@@ -11299,9 +11301,9 @@
                 <a:solidFill>
                   <a:srgbClr val="FF8A3D"/>
                 </a:solidFill>
-                <a:latin typeface="PingFang SC" pitchFamily="34" charset="0"/>
-                <a:ea typeface="PingFang SC" pitchFamily="34" charset="-122"/>
-                <a:cs typeface="PingFang SC" pitchFamily="34" charset="-120"/>
+                <a:latin typeface="Microsoft YaHei" pitchFamily="34" charset="0"/>
+                <a:ea typeface="Microsoft YaHei" pitchFamily="34" charset="-122"/>
+                <a:cs typeface="Microsoft YaHei" pitchFamily="34" charset="-120"/>
               </a:rPr>
               <a:t>角色分工：</a:t>
             </a:r>
@@ -11316,9 +11318,9 @@
                 <a:solidFill>
                   <a:srgbClr val="C9D2F5"/>
                 </a:solidFill>
-                <a:latin typeface="PingFang SC" pitchFamily="34" charset="0"/>
-                <a:ea typeface="PingFang SC" pitchFamily="34" charset="-122"/>
-                <a:cs typeface="PingFang SC" pitchFamily="34" charset="-120"/>
+                <a:latin typeface="Microsoft YaHei" pitchFamily="34" charset="0"/>
+                <a:ea typeface="Microsoft YaHei" pitchFamily="34" charset="-122"/>
+                <a:cs typeface="Microsoft YaHei" pitchFamily="34" charset="-120"/>
               </a:rPr>
               <a:t>王若璋（组长/架构：架构与 ADR、检索引擎、测试验收）· 何俐（后端/数据：生成与 Provider、摄取与热更新、评测集）· 郭祚梁（前端/材料：三视图、流式溯源、文档与答辩材料）</a:t>
             </a:r>
@@ -11431,9 +11433,9 @@
                 <a:solidFill>
                   <a:srgbClr val="FFFFFF"/>
                 </a:solidFill>
-                <a:latin typeface="PingFang SC" pitchFamily="34" charset="0"/>
-                <a:ea typeface="PingFang SC" pitchFamily="34" charset="-122"/>
-                <a:cs typeface="PingFang SC" pitchFamily="34" charset="-120"/>
+                <a:latin typeface="Microsoft YaHei" pitchFamily="34" charset="0"/>
+                <a:ea typeface="Microsoft YaHei" pitchFamily="34" charset="-122"/>
+                <a:cs typeface="Microsoft YaHei" pitchFamily="34" charset="-120"/>
               </a:rPr>
               <a:t>总结与展望</a:t>
             </a:r>
@@ -11499,9 +11501,9 @@
                 <a:solidFill>
                   <a:srgbClr val="AFBCF0"/>
                 </a:solidFill>
-                <a:latin typeface="PingFang SC" pitchFamily="34" charset="0"/>
-                <a:ea typeface="PingFang SC" pitchFamily="34" charset="-122"/>
-                <a:cs typeface="PingFang SC" pitchFamily="34" charset="-120"/>
+                <a:latin typeface="Microsoft YaHei" pitchFamily="34" charset="0"/>
+                <a:ea typeface="Microsoft YaHei" pitchFamily="34" charset="-122"/>
+                <a:cs typeface="Microsoft YaHei" pitchFamily="34" charset="-120"/>
               </a:rPr>
               <a:t>双模生成架构</a:t>
             </a:r>
@@ -11541,9 +11543,9 @@
                 <a:solidFill>
                   <a:srgbClr val="C9D2F5"/>
                 </a:solidFill>
-                <a:latin typeface="PingFang SC" pitchFamily="34" charset="0"/>
-                <a:ea typeface="PingFang SC" pitchFamily="34" charset="-122"/>
-                <a:cs typeface="PingFang SC" pitchFamily="34" charset="-120"/>
+                <a:latin typeface="Microsoft YaHei" pitchFamily="34" charset="0"/>
+                <a:ea typeface="Microsoft YaHei" pitchFamily="34" charset="-122"/>
+                <a:cs typeface="Microsoft YaHei" pitchFamily="34" charset="-120"/>
               </a:rPr>
               <a:t>本地抽取式与云端 GLM 共享同一 RAG 链路，离线可演示、故障自降级</a:t>
             </a:r>
@@ -11609,9 +11611,9 @@
                 <a:solidFill>
                   <a:srgbClr val="AFBCF0"/>
                 </a:solidFill>
-                <a:latin typeface="PingFang SC" pitchFamily="34" charset="0"/>
-                <a:ea typeface="PingFang SC" pitchFamily="34" charset="-122"/>
-                <a:cs typeface="PingFang SC" pitchFamily="34" charset="-120"/>
+                <a:latin typeface="Microsoft YaHei" pitchFamily="34" charset="0"/>
+                <a:ea typeface="Microsoft YaHei" pitchFamily="34" charset="-122"/>
+                <a:cs typeface="Microsoft YaHei" pitchFamily="34" charset="-120"/>
               </a:rPr>
               <a:t>检索可观察</a:t>
             </a:r>
@@ -11651,9 +11653,9 @@
                 <a:solidFill>
                   <a:srgbClr val="C9D2F5"/>
                 </a:solidFill>
-                <a:latin typeface="PingFang SC" pitchFamily="34" charset="0"/>
-                <a:ea typeface="PingFang SC" pitchFamily="34" charset="-122"/>
-                <a:cs typeface="PingFang SC" pitchFamily="34" charset="-120"/>
+                <a:latin typeface="Microsoft YaHei" pitchFamily="34" charset="0"/>
+                <a:ea typeface="Microsoft YaHei" pitchFamily="34" charset="-122"/>
+                <a:cs typeface="Microsoft YaHei" pitchFamily="34" charset="-120"/>
               </a:rPr>
               <a:t>双通道排名与重排分数同步暴露给前端与调试接口，过程可解释</a:t>
             </a:r>
@@ -11719,9 +11721,9 @@
                 <a:solidFill>
                   <a:srgbClr val="AFBCF0"/>
                 </a:solidFill>
-                <a:latin typeface="PingFang SC" pitchFamily="34" charset="0"/>
-                <a:ea typeface="PingFang SC" pitchFamily="34" charset="-122"/>
-                <a:cs typeface="PingFang SC" pitchFamily="34" charset="-120"/>
+                <a:latin typeface="Microsoft YaHei" pitchFamily="34" charset="0"/>
+                <a:ea typeface="Microsoft YaHei" pitchFamily="34" charset="-122"/>
+                <a:cs typeface="Microsoft YaHei" pitchFamily="34" charset="-120"/>
               </a:rPr>
               <a:t>知识热更新闭环</a:t>
             </a:r>
@@ -11761,9 +11763,9 @@
                 <a:solidFill>
                   <a:srgbClr val="C9D2F5"/>
                 </a:solidFill>
-                <a:latin typeface="PingFang SC" pitchFamily="34" charset="0"/>
-                <a:ea typeface="PingFang SC" pitchFamily="34" charset="-122"/>
-                <a:cs typeface="PingFang SC" pitchFamily="34" charset="-120"/>
+                <a:latin typeface="Microsoft YaHei" pitchFamily="34" charset="0"/>
+                <a:ea typeface="Microsoft YaHei" pitchFamily="34" charset="-122"/>
+                <a:cs typeface="Microsoft YaHei" pitchFamily="34" charset="-120"/>
               </a:rPr>
               <a:t>录入即建索引无需重启，同义词运营使 Hit@3 +5pp</a:t>
             </a:r>
@@ -11829,9 +11831,9 @@
                 <a:solidFill>
                   <a:srgbClr val="AFBCF0"/>
                 </a:solidFill>
-                <a:latin typeface="PingFang SC" pitchFamily="34" charset="0"/>
-                <a:ea typeface="PingFang SC" pitchFamily="34" charset="-122"/>
-                <a:cs typeface="PingFang SC" pitchFamily="34" charset="-120"/>
+                <a:latin typeface="Microsoft YaHei" pitchFamily="34" charset="0"/>
+                <a:ea typeface="Microsoft YaHei" pitchFamily="34" charset="-122"/>
+                <a:cs typeface="Microsoft YaHei" pitchFamily="34" charset="-120"/>
               </a:rPr>
               <a:t>演进型架构</a:t>
             </a:r>
@@ -11871,9 +11873,9 @@
                 <a:solidFill>
                   <a:srgbClr val="C9D2F5"/>
                 </a:solidFill>
-                <a:latin typeface="PingFang SC" pitchFamily="34" charset="0"/>
-                <a:ea typeface="PingFang SC" pitchFamily="34" charset="-122"/>
-                <a:cs typeface="PingFang SC" pitchFamily="34" charset="-120"/>
+                <a:latin typeface="Microsoft YaHei" pitchFamily="34" charset="0"/>
+                <a:ea typeface="Microsoft YaHei" pitchFamily="34" charset="-122"/>
+                <a:cs typeface="Microsoft YaHei" pitchFamily="34" charset="-120"/>
               </a:rPr>
               <a:t>单机演示与生产集群共享接口，每步替换都是可评分的决策</a:t>
             </a:r>
@@ -11910,9 +11912,9 @@
                 <a:solidFill>
                   <a:srgbClr val="8B97C9"/>
                 </a:solidFill>
-                <a:latin typeface="PingFang SC" pitchFamily="34" charset="0"/>
-                <a:ea typeface="PingFang SC" pitchFamily="34" charset="-122"/>
-                <a:cs typeface="PingFang SC" pitchFamily="34" charset="-120"/>
+                <a:latin typeface="Microsoft YaHei" pitchFamily="34" charset="0"/>
+                <a:ea typeface="Microsoft YaHei" pitchFamily="34" charset="-122"/>
+                <a:cs typeface="Microsoft YaHei" pitchFamily="34" charset="-120"/>
               </a:rPr>
               <a:t>下一步：语义向量 + Cross-Encoder 重排 · 统一身份认证 · 知识源自动采集 · 持续评测</a:t>
             </a:r>
@@ -11949,9 +11951,9 @@
                 <a:solidFill>
                   <a:srgbClr val="FFFFFF"/>
                 </a:solidFill>
-                <a:latin typeface="PingFang SC" pitchFamily="34" charset="0"/>
-                <a:ea typeface="PingFang SC" pitchFamily="34" charset="-122"/>
-                <a:cs typeface="PingFang SC" pitchFamily="34" charset="-120"/>
+                <a:latin typeface="Microsoft YaHei" pitchFamily="34" charset="0"/>
+                <a:ea typeface="Microsoft YaHei" pitchFamily="34" charset="-122"/>
+                <a:cs typeface="Microsoft YaHei" pitchFamily="34" charset="-120"/>
               </a:rPr>
               <a:t>欢迎提问 · 谢谢！</a:t>
             </a:r>
@@ -12020,9 +12022,9 @@
                 <a:solidFill>
                   <a:srgbClr val="1C2333"/>
                 </a:solidFill>
-                <a:latin typeface="PingFang SC" pitchFamily="34" charset="0"/>
-                <a:ea typeface="PingFang SC" pitchFamily="34" charset="-122"/>
-                <a:cs typeface="PingFang SC" pitchFamily="34" charset="-120"/>
+                <a:latin typeface="Microsoft YaHei" pitchFamily="34" charset="0"/>
+                <a:ea typeface="Microsoft YaHei" pitchFamily="34" charset="-122"/>
+                <a:cs typeface="Microsoft YaHei" pitchFamily="34" charset="-120"/>
               </a:rPr>
               <a:t>汇报提纲</a:t>
             </a:r>
@@ -12059,9 +12061,9 @@
                 <a:solidFill>
                   <a:srgbClr val="6A7390"/>
                 </a:solidFill>
-                <a:latin typeface="PingFang SC" pitchFamily="34" charset="0"/>
-                <a:ea typeface="PingFang SC" pitchFamily="34" charset="-122"/>
-                <a:cs typeface="PingFang SC" pitchFamily="34" charset="-120"/>
+                <a:latin typeface="Microsoft YaHei" pitchFamily="34" charset="0"/>
+                <a:ea typeface="Microsoft YaHei" pitchFamily="34" charset="-122"/>
+                <a:cs typeface="Microsoft YaHei" pitchFamily="34" charset="-120"/>
               </a:rPr>
               <a:t>从问题到架构再到验证，四个环节展开</a:t>
             </a:r>
@@ -12098,9 +12100,9 @@
                 <a:solidFill>
                   <a:srgbClr val="6A7390"/>
                 </a:solidFill>
-                <a:latin typeface="PingFang SC" pitchFamily="34" charset="0"/>
-                <a:ea typeface="PingFang SC" pitchFamily="34" charset="-122"/>
-                <a:cs typeface="PingFang SC" pitchFamily="34" charset="-120"/>
+                <a:latin typeface="Microsoft YaHei" pitchFamily="34" charset="0"/>
+                <a:ea typeface="Microsoft YaHei" pitchFamily="34" charset="-122"/>
+                <a:cs typeface="Microsoft YaHei" pitchFamily="34" charset="-120"/>
               </a:rPr>
               <a:t>2</a:t>
             </a:r>
@@ -12171,9 +12173,9 @@
                 <a:solidFill>
                   <a:srgbClr val="3B5BFD"/>
                 </a:solidFill>
-                <a:latin typeface="PingFang SC" pitchFamily="34" charset="0"/>
-                <a:ea typeface="PingFang SC" pitchFamily="34" charset="-122"/>
-                <a:cs typeface="PingFang SC" pitchFamily="34" charset="-120"/>
+                <a:latin typeface="Microsoft YaHei" pitchFamily="34" charset="0"/>
+                <a:ea typeface="Microsoft YaHei" pitchFamily="34" charset="-122"/>
+                <a:cs typeface="Microsoft YaHei" pitchFamily="34" charset="-120"/>
               </a:rPr>
               <a:t>01</a:t>
             </a:r>
@@ -12210,9 +12212,9 @@
                 <a:solidFill>
                   <a:srgbClr val="1C2333"/>
                 </a:solidFill>
-                <a:latin typeface="PingFang SC" pitchFamily="34" charset="0"/>
-                <a:ea typeface="PingFang SC" pitchFamily="34" charset="-122"/>
-                <a:cs typeface="PingFang SC" pitchFamily="34" charset="-120"/>
+                <a:latin typeface="Microsoft YaHei" pitchFamily="34" charset="0"/>
+                <a:ea typeface="Microsoft YaHei" pitchFamily="34" charset="-122"/>
+                <a:cs typeface="Microsoft YaHei" pitchFamily="34" charset="-120"/>
               </a:rPr>
               <a:t>背景与需求</a:t>
             </a:r>
@@ -12249,9 +12251,9 @@
                 <a:solidFill>
                   <a:srgbClr val="6A7390"/>
                 </a:solidFill>
-                <a:latin typeface="PingFang SC" pitchFamily="34" charset="0"/>
-                <a:ea typeface="PingFang SC" pitchFamily="34" charset="-122"/>
-                <a:cs typeface="PingFang SC" pitchFamily="34" charset="-120"/>
+                <a:latin typeface="Microsoft YaHei" pitchFamily="34" charset="0"/>
+                <a:ea typeface="Microsoft YaHei" pitchFamily="34" charset="-122"/>
+                <a:cs typeface="Microsoft YaHei" pitchFamily="34" charset="-120"/>
               </a:rPr>
               <a:t>痛点调研 · 质量属性场景 · 约束条件</a:t>
             </a:r>
@@ -12322,9 +12324,9 @@
                 <a:solidFill>
                   <a:srgbClr val="7C4DFF"/>
                 </a:solidFill>
-                <a:latin typeface="PingFang SC" pitchFamily="34" charset="0"/>
-                <a:ea typeface="PingFang SC" pitchFamily="34" charset="-122"/>
-                <a:cs typeface="PingFang SC" pitchFamily="34" charset="-120"/>
+                <a:latin typeface="Microsoft YaHei" pitchFamily="34" charset="0"/>
+                <a:ea typeface="Microsoft YaHei" pitchFamily="34" charset="-122"/>
+                <a:cs typeface="Microsoft YaHei" pitchFamily="34" charset="-120"/>
               </a:rPr>
               <a:t>02</a:t>
             </a:r>
@@ -12361,9 +12363,9 @@
                 <a:solidFill>
                   <a:srgbClr val="1C2333"/>
                 </a:solidFill>
-                <a:latin typeface="PingFang SC" pitchFamily="34" charset="0"/>
-                <a:ea typeface="PingFang SC" pitchFamily="34" charset="-122"/>
-                <a:cs typeface="PingFang SC" pitchFamily="34" charset="-120"/>
+                <a:latin typeface="Microsoft YaHei" pitchFamily="34" charset="0"/>
+                <a:ea typeface="Microsoft YaHei" pitchFamily="34" charset="-122"/>
+                <a:cs typeface="Microsoft YaHei" pitchFamily="34" charset="-120"/>
               </a:rPr>
               <a:t>架构设计</a:t>
             </a:r>
@@ -12400,9 +12402,9 @@
                 <a:solidFill>
                   <a:srgbClr val="6A7390"/>
                 </a:solidFill>
-                <a:latin typeface="PingFang SC" pitchFamily="34" charset="0"/>
-                <a:ea typeface="PingFang SC" pitchFamily="34" charset="-122"/>
-                <a:cs typeface="PingFang SC" pitchFamily="34" charset="-120"/>
+                <a:latin typeface="Microsoft YaHei" pitchFamily="34" charset="0"/>
+                <a:ea typeface="Microsoft YaHei" pitchFamily="34" charset="-122"/>
+                <a:cs typeface="Microsoft YaHei" pitchFamily="34" charset="-120"/>
               </a:rPr>
               <a:t>五层分层 · RAG 核心链路 · 6 项关键决策 ADR</a:t>
             </a:r>
@@ -12473,9 +12475,9 @@
                 <a:solidFill>
                   <a:srgbClr val="3B5BFD"/>
                 </a:solidFill>
-                <a:latin typeface="PingFang SC" pitchFamily="34" charset="0"/>
-                <a:ea typeface="PingFang SC" pitchFamily="34" charset="-122"/>
-                <a:cs typeface="PingFang SC" pitchFamily="34" charset="-120"/>
+                <a:latin typeface="Microsoft YaHei" pitchFamily="34" charset="0"/>
+                <a:ea typeface="Microsoft YaHei" pitchFamily="34" charset="-122"/>
+                <a:cs typeface="Microsoft YaHei" pitchFamily="34" charset="-120"/>
               </a:rPr>
               <a:t>03</a:t>
             </a:r>
@@ -12512,9 +12514,9 @@
                 <a:solidFill>
                   <a:srgbClr val="1C2333"/>
                 </a:solidFill>
-                <a:latin typeface="PingFang SC" pitchFamily="34" charset="0"/>
-                <a:ea typeface="PingFang SC" pitchFamily="34" charset="-122"/>
-                <a:cs typeface="PingFang SC" pitchFamily="34" charset="-120"/>
+                <a:latin typeface="Microsoft YaHei" pitchFamily="34" charset="0"/>
+                <a:ea typeface="Microsoft YaHei" pitchFamily="34" charset="-122"/>
+                <a:cs typeface="Microsoft YaHei" pitchFamily="34" charset="-120"/>
               </a:rPr>
               <a:t>实现与验证</a:t>
             </a:r>
@@ -12551,9 +12553,9 @@
                 <a:solidFill>
                   <a:srgbClr val="6A7390"/>
                 </a:solidFill>
-                <a:latin typeface="PingFang SC" pitchFamily="34" charset="0"/>
-                <a:ea typeface="PingFang SC" pitchFamily="34" charset="-122"/>
-                <a:cs typeface="PingFang SC" pitchFamily="34" charset="-120"/>
+                <a:latin typeface="Microsoft YaHei" pitchFamily="34" charset="0"/>
+                <a:ea typeface="Microsoft YaHei" pitchFamily="34" charset="-122"/>
+                <a:cs typeface="Microsoft YaHei" pitchFamily="34" charset="-120"/>
               </a:rPr>
               <a:t>可运行系统 · 检索评测 · 性能压测 · 演示录屏</a:t>
             </a:r>
@@ -12624,9 +12626,9 @@
                 <a:solidFill>
                   <a:srgbClr val="7C4DFF"/>
                 </a:solidFill>
-                <a:latin typeface="PingFang SC" pitchFamily="34" charset="0"/>
-                <a:ea typeface="PingFang SC" pitchFamily="34" charset="-122"/>
-                <a:cs typeface="PingFang SC" pitchFamily="34" charset="-120"/>
+                <a:latin typeface="Microsoft YaHei" pitchFamily="34" charset="0"/>
+                <a:ea typeface="Microsoft YaHei" pitchFamily="34" charset="-122"/>
+                <a:cs typeface="Microsoft YaHei" pitchFamily="34" charset="-120"/>
               </a:rPr>
               <a:t>04</a:t>
             </a:r>
@@ -12663,9 +12665,9 @@
                 <a:solidFill>
                   <a:srgbClr val="1C2333"/>
                 </a:solidFill>
-                <a:latin typeface="PingFang SC" pitchFamily="34" charset="0"/>
-                <a:ea typeface="PingFang SC" pitchFamily="34" charset="-122"/>
-                <a:cs typeface="PingFang SC" pitchFamily="34" charset="-120"/>
+                <a:latin typeface="Microsoft YaHei" pitchFamily="34" charset="0"/>
+                <a:ea typeface="Microsoft YaHei" pitchFamily="34" charset="-122"/>
+                <a:cs typeface="Microsoft YaHei" pitchFamily="34" charset="-120"/>
               </a:rPr>
               <a:t>演进与总结</a:t>
             </a:r>
@@ -12702,9 +12704,9 @@
                 <a:solidFill>
                   <a:srgbClr val="6A7390"/>
                 </a:solidFill>
-                <a:latin typeface="PingFang SC" pitchFamily="34" charset="0"/>
-                <a:ea typeface="PingFang SC" pitchFamily="34" charset="-122"/>
-                <a:cs typeface="PingFang SC" pitchFamily="34" charset="-120"/>
+                <a:latin typeface="Microsoft YaHei" pitchFamily="34" charset="0"/>
+                <a:ea typeface="Microsoft YaHei" pitchFamily="34" charset="-122"/>
+                <a:cs typeface="Microsoft YaHei" pitchFamily="34" charset="-120"/>
               </a:rPr>
               <a:t>单机→生产演进 · 8 周计划 · 创新点</a:t>
             </a:r>
@@ -12773,9 +12775,9 @@
                 <a:solidFill>
                   <a:srgbClr val="1C2333"/>
                 </a:solidFill>
-                <a:latin typeface="PingFang SC" pitchFamily="34" charset="0"/>
-                <a:ea typeface="PingFang SC" pitchFamily="34" charset="-122"/>
-                <a:cs typeface="PingFang SC" pitchFamily="34" charset="-120"/>
+                <a:latin typeface="Microsoft YaHei" pitchFamily="34" charset="0"/>
+                <a:ea typeface="Microsoft YaHei" pitchFamily="34" charset="-122"/>
+                <a:cs typeface="Microsoft YaHei" pitchFamily="34" charset="-120"/>
               </a:rPr>
               <a:t>背景：校园咨询的三个痛点</a:t>
             </a:r>
@@ -12812,9 +12814,9 @@
                 <a:solidFill>
                   <a:srgbClr val="6A7390"/>
                 </a:solidFill>
-                <a:latin typeface="PingFang SC" pitchFamily="34" charset="0"/>
-                <a:ea typeface="PingFang SC" pitchFamily="34" charset="-122"/>
-                <a:cs typeface="PingFang SC" pitchFamily="34" charset="-120"/>
+                <a:latin typeface="Microsoft YaHei" pitchFamily="34" charset="0"/>
+                <a:ea typeface="Microsoft YaHei" pitchFamily="34" charset="-122"/>
+                <a:cs typeface="Microsoft YaHei" pitchFamily="34" charset="-120"/>
               </a:rPr>
               <a:t>调研结论驱动选题：高频、分散、无口径</a:t>
             </a:r>
@@ -12851,9 +12853,9 @@
                 <a:solidFill>
                   <a:srgbClr val="6A7390"/>
                 </a:solidFill>
-                <a:latin typeface="PingFang SC" pitchFamily="34" charset="0"/>
-                <a:ea typeface="PingFang SC" pitchFamily="34" charset="-122"/>
-                <a:cs typeface="PingFang SC" pitchFamily="34" charset="-120"/>
+                <a:latin typeface="Microsoft YaHei" pitchFamily="34" charset="0"/>
+                <a:ea typeface="Microsoft YaHei" pitchFamily="34" charset="-122"/>
+                <a:cs typeface="Microsoft YaHei" pitchFamily="34" charset="-120"/>
               </a:rPr>
               <a:t>3</a:t>
             </a:r>
@@ -12924,9 +12926,9 @@
                 <a:solidFill>
                   <a:srgbClr val="3B5BFD"/>
                 </a:solidFill>
-                <a:latin typeface="PingFang SC" pitchFamily="34" charset="0"/>
-                <a:ea typeface="PingFang SC" pitchFamily="34" charset="-122"/>
-                <a:cs typeface="PingFang SC" pitchFamily="34" charset="-120"/>
+                <a:latin typeface="Microsoft YaHei" pitchFamily="34" charset="0"/>
+                <a:ea typeface="Microsoft YaHei" pitchFamily="34" charset="-122"/>
+                <a:cs typeface="Microsoft YaHei" pitchFamily="34" charset="-120"/>
               </a:rPr>
               <a:t>分散</a:t>
             </a:r>
@@ -12966,9 +12968,9 @@
                 <a:solidFill>
                   <a:srgbClr val="1C2333"/>
                 </a:solidFill>
-                <a:latin typeface="PingFang SC" pitchFamily="34" charset="0"/>
-                <a:ea typeface="PingFang SC" pitchFamily="34" charset="-122"/>
-                <a:cs typeface="PingFang SC" pitchFamily="34" charset="-120"/>
+                <a:latin typeface="Microsoft YaHei" pitchFamily="34" charset="0"/>
+                <a:ea typeface="Microsoft YaHei" pitchFamily="34" charset="-122"/>
+                <a:cs typeface="Microsoft YaHei" pitchFamily="34" charset="-120"/>
               </a:rPr>
               <a:t>规章分属不同部门网站，学生难以定位信息来源</a:t>
             </a:r>
@@ -13027,9 +13029,9 @@
                 <a:solidFill>
                   <a:srgbClr val="6A7390"/>
                 </a:solidFill>
-                <a:latin typeface="PingFang SC" pitchFamily="34" charset="0"/>
-                <a:ea typeface="PingFang SC" pitchFamily="34" charset="-122"/>
-                <a:cs typeface="PingFang SC" pitchFamily="34" charset="-120"/>
+                <a:latin typeface="Microsoft YaHei" pitchFamily="34" charset="0"/>
+                <a:ea typeface="Microsoft YaHei" pitchFamily="34" charset="-122"/>
+                <a:cs typeface="Microsoft YaHei" pitchFamily="34" charset="-120"/>
               </a:rPr>
               <a:t>选课/奖助/宿舍/就业 各自为政</a:t>
             </a:r>
@@ -13100,9 +13102,9 @@
                 <a:solidFill>
                   <a:srgbClr val="FF8A3D"/>
                 </a:solidFill>
-                <a:latin typeface="PingFang SC" pitchFamily="34" charset="0"/>
-                <a:ea typeface="PingFang SC" pitchFamily="34" charset="-122"/>
-                <a:cs typeface="PingFang SC" pitchFamily="34" charset="-120"/>
+                <a:latin typeface="Microsoft YaHei" pitchFamily="34" charset="0"/>
+                <a:ea typeface="Microsoft YaHei" pitchFamily="34" charset="-122"/>
+                <a:cs typeface="Microsoft YaHei" pitchFamily="34" charset="-120"/>
               </a:rPr>
               <a:t>低效</a:t>
             </a:r>
@@ -13142,9 +13144,9 @@
                 <a:solidFill>
                   <a:srgbClr val="1C2333"/>
                 </a:solidFill>
-                <a:latin typeface="PingFang SC" pitchFamily="34" charset="0"/>
-                <a:ea typeface="PingFang SC" pitchFamily="34" charset="-122"/>
-                <a:cs typeface="PingFang SC" pitchFamily="34" charset="-120"/>
+                <a:latin typeface="Microsoft YaHei" pitchFamily="34" charset="0"/>
+                <a:ea typeface="Microsoft YaHei" pitchFamily="34" charset="-122"/>
+                <a:cs typeface="Microsoft YaHei" pitchFamily="34" charset="-120"/>
               </a:rPr>
               <a:t>人工咨询受工作时间限制，晚间与假期无法响应</a:t>
             </a:r>
@@ -13203,9 +13205,9 @@
                 <a:solidFill>
                   <a:srgbClr val="6A7390"/>
                 </a:solidFill>
-                <a:latin typeface="PingFang SC" pitchFamily="34" charset="0"/>
-                <a:ea typeface="PingFang SC" pitchFamily="34" charset="-122"/>
-                <a:cs typeface="PingFang SC" pitchFamily="34" charset="-120"/>
+                <a:latin typeface="Microsoft YaHei" pitchFamily="34" charset="0"/>
+                <a:ea typeface="Microsoft YaHei" pitchFamily="34" charset="-122"/>
+                <a:cs typeface="Microsoft YaHei" pitchFamily="34" charset="-120"/>
               </a:rPr>
               <a:t>辅导员下班后无人回应</a:t>
             </a:r>
@@ -13276,9 +13278,9 @@
                 <a:solidFill>
                   <a:srgbClr val="3B5BFD"/>
                 </a:solidFill>
-                <a:latin typeface="PingFang SC" pitchFamily="34" charset="0"/>
-                <a:ea typeface="PingFang SC" pitchFamily="34" charset="-122"/>
-                <a:cs typeface="PingFang SC" pitchFamily="34" charset="-120"/>
+                <a:latin typeface="Microsoft YaHei" pitchFamily="34" charset="0"/>
+                <a:ea typeface="Microsoft YaHei" pitchFamily="34" charset="-122"/>
+                <a:cs typeface="Microsoft YaHei" pitchFamily="34" charset="-120"/>
               </a:rPr>
               <a:t>无溯源</a:t>
             </a:r>
@@ -13318,9 +13320,9 @@
                 <a:solidFill>
                   <a:srgbClr val="1C2333"/>
                 </a:solidFill>
-                <a:latin typeface="PingFang SC" pitchFamily="34" charset="0"/>
-                <a:ea typeface="PingFang SC" pitchFamily="34" charset="-122"/>
-                <a:cs typeface="PingFang SC" pitchFamily="34" charset="-120"/>
+                <a:latin typeface="Microsoft YaHei" pitchFamily="34" charset="0"/>
+                <a:ea typeface="Microsoft YaHei" pitchFamily="34" charset="-122"/>
+                <a:cs typeface="Microsoft YaHei" pitchFamily="34" charset="-120"/>
               </a:rPr>
               <a:t>同一问题不同渠道答案不一，缺乏权威口径</a:t>
             </a:r>
@@ -13379,9 +13381,9 @@
                 <a:solidFill>
                   <a:srgbClr val="6A7390"/>
                 </a:solidFill>
-                <a:latin typeface="PingFang SC" pitchFamily="34" charset="0"/>
-                <a:ea typeface="PingFang SC" pitchFamily="34" charset="-122"/>
-                <a:cs typeface="PingFang SC" pitchFamily="34" charset="-120"/>
+                <a:latin typeface="Microsoft YaHei" pitchFamily="34" charset="0"/>
+                <a:ea typeface="Microsoft YaHei" pitchFamily="34" charset="-122"/>
+                <a:cs typeface="Microsoft YaHei" pitchFamily="34" charset="-120"/>
               </a:rPr>
               <a:t>网络回答无来源标注</a:t>
             </a:r>
@@ -13452,9 +13454,9 @@
                 <a:solidFill>
                   <a:srgbClr val="FF8A3D"/>
                 </a:solidFill>
-                <a:latin typeface="PingFang SC" pitchFamily="34" charset="0"/>
-                <a:ea typeface="PingFang SC" pitchFamily="34" charset="-122"/>
-                <a:cs typeface="PingFang SC" pitchFamily="34" charset="-120"/>
+                <a:latin typeface="Microsoft YaHei" pitchFamily="34" charset="0"/>
+                <a:ea typeface="Microsoft YaHei" pitchFamily="34" charset="-122"/>
+                <a:cs typeface="Microsoft YaHei" pitchFamily="34" charset="-120"/>
               </a:rPr>
               <a:t>选题思路</a:t>
             </a:r>
@@ -13497,9 +13499,9 @@
                 <a:solidFill>
                   <a:srgbClr val="FFFFFF"/>
                 </a:solidFill>
-                <a:latin typeface="PingFang SC" pitchFamily="34" charset="0"/>
-                <a:ea typeface="PingFang SC" pitchFamily="34" charset="-122"/>
-                <a:cs typeface="PingFang SC" pitchFamily="34" charset="-120"/>
+                <a:latin typeface="Microsoft YaHei" pitchFamily="34" charset="0"/>
+                <a:ea typeface="Microsoft YaHei" pitchFamily="34" charset="-122"/>
+                <a:cs typeface="Microsoft YaHei" pitchFamily="34" charset="-120"/>
               </a:rPr>
               <a:t>为什么是 AI + RAG？</a:t>
             </a:r>
@@ -13517,9 +13519,9 @@
                 <a:solidFill>
                   <a:srgbClr val="C9D2F5"/>
                 </a:solidFill>
-                <a:latin typeface="PingFang SC" pitchFamily="34" charset="0"/>
-                <a:ea typeface="PingFang SC" pitchFamily="34" charset="-122"/>
-                <a:cs typeface="PingFang SC" pitchFamily="34" charset="-120"/>
+                <a:latin typeface="Microsoft YaHei" pitchFamily="34" charset="0"/>
+                <a:ea typeface="Microsoft YaHei" pitchFamily="34" charset="-122"/>
+                <a:cs typeface="Microsoft YaHei" pitchFamily="34" charset="-120"/>
               </a:rPr>
               <a:t>—— 大模型直接回答会幻觉，而校园信息要求准确可溯源。RAG 先检索再生成，把知识库作为回答的唯一事实来源。</a:t>
             </a:r>
@@ -13588,9 +13590,9 @@
                 <a:solidFill>
                   <a:srgbClr val="1C2333"/>
                 </a:solidFill>
-                <a:latin typeface="PingFang SC" pitchFamily="34" charset="0"/>
-                <a:ea typeface="PingFang SC" pitchFamily="34" charset="-122"/>
-                <a:cs typeface="PingFang SC" pitchFamily="34" charset="-120"/>
+                <a:latin typeface="Microsoft YaHei" pitchFamily="34" charset="0"/>
+                <a:ea typeface="Microsoft YaHei" pitchFamily="34" charset="-122"/>
+                <a:cs typeface="Microsoft YaHei" pitchFamily="34" charset="-120"/>
               </a:rPr>
               <a:t>需求分析：六元组质量属性场景</a:t>
             </a:r>
@@ -13627,9 +13629,9 @@
                 <a:solidFill>
                   <a:srgbClr val="6A7390"/>
                 </a:solidFill>
-                <a:latin typeface="PingFang SC" pitchFamily="34" charset="0"/>
-                <a:ea typeface="PingFang SC" pitchFamily="34" charset="-122"/>
-                <a:cs typeface="PingFang SC" pitchFamily="34" charset="-120"/>
+                <a:latin typeface="Microsoft YaHei" pitchFamily="34" charset="0"/>
+                <a:ea typeface="Microsoft YaHei" pitchFamily="34" charset="-122"/>
+                <a:cs typeface="Microsoft YaHei" pitchFamily="34" charset="-120"/>
               </a:rPr>
               <a:t>每个质量属性都有可验证的量化目标，并映射到架构层次</a:t>
             </a:r>
@@ -13666,9 +13668,9 @@
                 <a:solidFill>
                   <a:srgbClr val="6A7390"/>
                 </a:solidFill>
-                <a:latin typeface="PingFang SC" pitchFamily="34" charset="0"/>
-                <a:ea typeface="PingFang SC" pitchFamily="34" charset="-122"/>
-                <a:cs typeface="PingFang SC" pitchFamily="34" charset="-120"/>
+                <a:latin typeface="Microsoft YaHei" pitchFamily="34" charset="0"/>
+                <a:ea typeface="Microsoft YaHei" pitchFamily="34" charset="-122"/>
+                <a:cs typeface="Microsoft YaHei" pitchFamily="34" charset="-120"/>
               </a:rPr>
               <a:t>4</a:t>
             </a:r>
@@ -13718,16 +13720,16 @@
                           <a:solidFill>
                             <a:srgbClr val="FFFFFF"/>
                           </a:solidFill>
-                          <a:latin typeface="PingFang SC" pitchFamily="34" charset="0"/>
-                          <a:ea typeface="PingFang SC" pitchFamily="34" charset="-122"/>
-                          <a:cs typeface="PingFang SC" pitchFamily="34" charset="-120"/>
+                          <a:latin typeface="Microsoft YaHei" pitchFamily="34" charset="0"/>
+                          <a:ea typeface="Microsoft YaHei" pitchFamily="34" charset="-122"/>
+                          <a:cs typeface="Microsoft YaHei" pitchFamily="34" charset="-120"/>
                         </a:rPr>
                         <a:t>属性</a:t>
                       </a:r>
                       <a:endParaRPr lang="en-US" sz="1250" dirty="0">
-                        <a:latin typeface="PingFang SC" charset="0"/>
-                        <a:ea typeface="PingFang SC" charset="0"/>
-                        <a:cs typeface="PingFang SC" charset="0"/>
+                        <a:latin typeface="Microsoft YaHei" charset="0"/>
+                        <a:ea typeface="Microsoft YaHei" charset="0"/>
+                        <a:cs typeface="Microsoft YaHei" charset="0"/>
                       </a:endParaRPr>
                     </a:p>
                   </a:txBody>
@@ -13786,16 +13788,16 @@
                           <a:solidFill>
                             <a:srgbClr val="FFFFFF"/>
                           </a:solidFill>
-                          <a:latin typeface="PingFang SC" pitchFamily="34" charset="0"/>
-                          <a:ea typeface="PingFang SC" pitchFamily="34" charset="-122"/>
-                          <a:cs typeface="PingFang SC" pitchFamily="34" charset="-120"/>
+                          <a:latin typeface="Microsoft YaHei" pitchFamily="34" charset="0"/>
+                          <a:ea typeface="Microsoft YaHei" pitchFamily="34" charset="-122"/>
+                          <a:cs typeface="Microsoft YaHei" pitchFamily="34" charset="-120"/>
                         </a:rPr>
                         <a:t>关键场景（刺激源 → 响应）</a:t>
                       </a:r>
                       <a:endParaRPr lang="en-US" sz="1250" dirty="0">
-                        <a:latin typeface="PingFang SC" charset="0"/>
-                        <a:ea typeface="PingFang SC" charset="0"/>
-                        <a:cs typeface="PingFang SC" charset="0"/>
+                        <a:latin typeface="Microsoft YaHei" charset="0"/>
+                        <a:ea typeface="Microsoft YaHei" charset="0"/>
+                        <a:cs typeface="Microsoft YaHei" charset="0"/>
                       </a:endParaRPr>
                     </a:p>
                   </a:txBody>
@@ -13854,16 +13856,16 @@
                           <a:solidFill>
                             <a:srgbClr val="FFFFFF"/>
                           </a:solidFill>
-                          <a:latin typeface="PingFang SC" pitchFamily="34" charset="0"/>
-                          <a:ea typeface="PingFang SC" pitchFamily="34" charset="-122"/>
-                          <a:cs typeface="PingFang SC" pitchFamily="34" charset="-120"/>
+                          <a:latin typeface="Microsoft YaHei" pitchFamily="34" charset="0"/>
+                          <a:ea typeface="Microsoft YaHei" pitchFamily="34" charset="-122"/>
+                          <a:cs typeface="Microsoft YaHei" pitchFamily="34" charset="-120"/>
                         </a:rPr>
                         <a:t>量化目标</a:t>
                       </a:r>
                       <a:endParaRPr lang="en-US" sz="1250" dirty="0">
-                        <a:latin typeface="PingFang SC" charset="0"/>
-                        <a:ea typeface="PingFang SC" charset="0"/>
-                        <a:cs typeface="PingFang SC" charset="0"/>
+                        <a:latin typeface="Microsoft YaHei" charset="0"/>
+                        <a:ea typeface="Microsoft YaHei" charset="0"/>
+                        <a:cs typeface="Microsoft YaHei" charset="0"/>
                       </a:endParaRPr>
                     </a:p>
                   </a:txBody>
@@ -13922,16 +13924,16 @@
                           <a:solidFill>
                             <a:srgbClr val="FFFFFF"/>
                           </a:solidFill>
-                          <a:latin typeface="PingFang SC" pitchFamily="34" charset="0"/>
-                          <a:ea typeface="PingFang SC" pitchFamily="34" charset="-122"/>
-                          <a:cs typeface="PingFang SC" pitchFamily="34" charset="-120"/>
+                          <a:latin typeface="Microsoft YaHei" pitchFamily="34" charset="0"/>
+                          <a:ea typeface="Microsoft YaHei" pitchFamily="34" charset="-122"/>
+                          <a:cs typeface="Microsoft YaHei" pitchFamily="34" charset="-120"/>
                         </a:rPr>
                         <a:t>落点层次</a:t>
                       </a:r>
                       <a:endParaRPr lang="en-US" sz="1250" dirty="0">
-                        <a:latin typeface="PingFang SC" charset="0"/>
-                        <a:ea typeface="PingFang SC" charset="0"/>
-                        <a:cs typeface="PingFang SC" charset="0"/>
+                        <a:latin typeface="Microsoft YaHei" charset="0"/>
+                        <a:ea typeface="Microsoft YaHei" charset="0"/>
+                        <a:cs typeface="Microsoft YaHei" charset="0"/>
                       </a:endParaRPr>
                     </a:p>
                   </a:txBody>
@@ -13992,16 +13994,16 @@
                           <a:solidFill>
                             <a:srgbClr val="3B5BFD"/>
                           </a:solidFill>
-                          <a:latin typeface="PingFang SC" pitchFamily="34" charset="0"/>
-                          <a:ea typeface="PingFang SC" pitchFamily="34" charset="-122"/>
-                          <a:cs typeface="PingFang SC" pitchFamily="34" charset="-120"/>
+                          <a:latin typeface="Microsoft YaHei" pitchFamily="34" charset="0"/>
+                          <a:ea typeface="Microsoft YaHei" pitchFamily="34" charset="-122"/>
+                          <a:cs typeface="Microsoft YaHei" pitchFamily="34" charset="-120"/>
                         </a:rPr>
                         <a:t>性能</a:t>
                       </a:r>
                       <a:endParaRPr lang="en-US" sz="1150" dirty="0">
-                        <a:latin typeface="PingFang SC" charset="0"/>
-                        <a:ea typeface="PingFang SC" charset="0"/>
-                        <a:cs typeface="PingFang SC" charset="0"/>
+                        <a:latin typeface="Microsoft YaHei" charset="0"/>
+                        <a:ea typeface="Microsoft YaHei" charset="0"/>
+                        <a:cs typeface="Microsoft YaHei" charset="0"/>
                       </a:endParaRPr>
                     </a:p>
                   </a:txBody>
@@ -14060,16 +14062,16 @@
                           <a:solidFill>
                             <a:srgbClr val="1C2333"/>
                           </a:solidFill>
-                          <a:latin typeface="PingFang SC" pitchFamily="34" charset="0"/>
-                          <a:ea typeface="PingFang SC" pitchFamily="34" charset="-122"/>
-                          <a:cs typeface="PingFang SC" pitchFamily="34" charset="-120"/>
+                          <a:latin typeface="Microsoft YaHei" pitchFamily="34" charset="0"/>
+                          <a:ea typeface="Microsoft YaHei" pitchFamily="34" charset="-122"/>
+                          <a:cs typeface="Microsoft YaHei" pitchFamily="34" charset="-120"/>
                         </a:rPr>
                         <a:t>奖助申报季并发 5 倍峰值，响应不阪塔</a:t>
                       </a:r>
                       <a:endParaRPr lang="en-US" sz="1150" dirty="0">
-                        <a:latin typeface="PingFang SC" charset="0"/>
-                        <a:ea typeface="PingFang SC" charset="0"/>
-                        <a:cs typeface="PingFang SC" charset="0"/>
+                        <a:latin typeface="Microsoft YaHei" charset="0"/>
+                        <a:ea typeface="Microsoft YaHei" charset="0"/>
+                        <a:cs typeface="Microsoft YaHei" charset="0"/>
                       </a:endParaRPr>
                     </a:p>
                   </a:txBody>
@@ -14128,16 +14130,16 @@
                           <a:solidFill>
                             <a:srgbClr val="1C2333"/>
                           </a:solidFill>
-                          <a:latin typeface="PingFang SC" pitchFamily="34" charset="0"/>
-                          <a:ea typeface="PingFang SC" pitchFamily="34" charset="-122"/>
-                          <a:cs typeface="PingFang SC" pitchFamily="34" charset="-120"/>
+                          <a:latin typeface="Microsoft YaHei" pitchFamily="34" charset="0"/>
+                          <a:ea typeface="Microsoft YaHei" pitchFamily="34" charset="-122"/>
+                          <a:cs typeface="Microsoft YaHei" pitchFamily="34" charset="-120"/>
                         </a:rPr>
                         <a:t>首字 &lt; 1s · 检索 P95 &lt; 50ms</a:t>
                       </a:r>
                       <a:endParaRPr lang="en-US" sz="1150" dirty="0">
-                        <a:latin typeface="PingFang SC" charset="0"/>
-                        <a:ea typeface="PingFang SC" charset="0"/>
-                        <a:cs typeface="PingFang SC" charset="0"/>
+                        <a:latin typeface="Microsoft YaHei" charset="0"/>
+                        <a:ea typeface="Microsoft YaHei" charset="0"/>
+                        <a:cs typeface="Microsoft YaHei" charset="0"/>
                       </a:endParaRPr>
                     </a:p>
                   </a:txBody>
@@ -14196,16 +14198,16 @@
                           <a:solidFill>
                             <a:srgbClr val="1C2333"/>
                           </a:solidFill>
-                          <a:latin typeface="PingFang SC" pitchFamily="34" charset="0"/>
-                          <a:ea typeface="PingFang SC" pitchFamily="34" charset="-122"/>
-                          <a:cs typeface="PingFang SC" pitchFamily="34" charset="-120"/>
+                          <a:latin typeface="Microsoft YaHei" pitchFamily="34" charset="0"/>
+                          <a:ea typeface="Microsoft YaHei" pitchFamily="34" charset="-122"/>
+                          <a:cs typeface="Microsoft YaHei" pitchFamily="34" charset="-120"/>
                         </a:rPr>
                         <a:t>RAG 引擎层</a:t>
                       </a:r>
                       <a:endParaRPr lang="en-US" sz="1150" dirty="0">
-                        <a:latin typeface="PingFang SC" charset="0"/>
-                        <a:ea typeface="PingFang SC" charset="0"/>
-                        <a:cs typeface="PingFang SC" charset="0"/>
+                        <a:latin typeface="Microsoft YaHei" charset="0"/>
+                        <a:ea typeface="Microsoft YaHei" charset="0"/>
+                        <a:cs typeface="Microsoft YaHei" charset="0"/>
                       </a:endParaRPr>
                     </a:p>
                   </a:txBody>
@@ -14266,16 +14268,16 @@
                           <a:solidFill>
                             <a:srgbClr val="3B5BFD"/>
                           </a:solidFill>
-                          <a:latin typeface="PingFang SC" pitchFamily="34" charset="0"/>
-                          <a:ea typeface="PingFang SC" pitchFamily="34" charset="-122"/>
-                          <a:cs typeface="PingFang SC" pitchFamily="34" charset="-120"/>
+                          <a:latin typeface="Microsoft YaHei" pitchFamily="34" charset="0"/>
+                          <a:ea typeface="Microsoft YaHei" pitchFamily="34" charset="-122"/>
+                          <a:cs typeface="Microsoft YaHei" pitchFamily="34" charset="-120"/>
                         </a:rPr>
                         <a:t>可用性</a:t>
                       </a:r>
                       <a:endParaRPr lang="en-US" sz="1150" dirty="0">
-                        <a:latin typeface="PingFang SC" charset="0"/>
-                        <a:ea typeface="PingFang SC" charset="0"/>
-                        <a:cs typeface="PingFang SC" charset="0"/>
+                        <a:latin typeface="Microsoft YaHei" charset="0"/>
+                        <a:ea typeface="Microsoft YaHei" charset="0"/>
+                        <a:cs typeface="Microsoft YaHei" charset="0"/>
                       </a:endParaRPr>
                     </a:p>
                   </a:txBody>
@@ -14334,16 +14336,16 @@
                           <a:solidFill>
                             <a:srgbClr val="1C2333"/>
                           </a:solidFill>
-                          <a:latin typeface="PingFang SC" pitchFamily="34" charset="0"/>
-                          <a:ea typeface="PingFang SC" pitchFamily="34" charset="-122"/>
-                          <a:cs typeface="PingFang SC" pitchFamily="34" charset="-120"/>
+                          <a:latin typeface="Microsoft YaHei" pitchFamily="34" charset="0"/>
+                          <a:ea typeface="Microsoft YaHei" pitchFamily="34" charset="-122"/>
+                          <a:cs typeface="Microsoft YaHei" pitchFamily="34" charset="-120"/>
                         </a:rPr>
                         <a:t>云端 LLM 超时/故障时自动降级继续服务</a:t>
                       </a:r>
                       <a:endParaRPr lang="en-US" sz="1150" dirty="0">
-                        <a:latin typeface="PingFang SC" charset="0"/>
-                        <a:ea typeface="PingFang SC" charset="0"/>
-                        <a:cs typeface="PingFang SC" charset="0"/>
+                        <a:latin typeface="Microsoft YaHei" charset="0"/>
+                        <a:ea typeface="Microsoft YaHei" charset="0"/>
+                        <a:cs typeface="Microsoft YaHei" charset="0"/>
                       </a:endParaRPr>
                     </a:p>
                   </a:txBody>
@@ -14402,16 +14404,16 @@
                           <a:solidFill>
                             <a:srgbClr val="1C2333"/>
                           </a:solidFill>
-                          <a:latin typeface="PingFang SC" pitchFamily="34" charset="0"/>
-                          <a:ea typeface="PingFang SC" pitchFamily="34" charset="-122"/>
-                          <a:cs typeface="PingFang SC" pitchFamily="34" charset="-120"/>
+                          <a:latin typeface="Microsoft YaHei" pitchFamily="34" charset="0"/>
+                          <a:ea typeface="Microsoft YaHei" pitchFamily="34" charset="-122"/>
+                          <a:cs typeface="Microsoft YaHei" pitchFamily="34" charset="-120"/>
                         </a:rPr>
                         <a:t>降级零人工 · 可用性 ≥ 99.5%</a:t>
                       </a:r>
                       <a:endParaRPr lang="en-US" sz="1150" dirty="0">
-                        <a:latin typeface="PingFang SC" charset="0"/>
-                        <a:ea typeface="PingFang SC" charset="0"/>
-                        <a:cs typeface="PingFang SC" charset="0"/>
+                        <a:latin typeface="Microsoft YaHei" charset="0"/>
+                        <a:ea typeface="Microsoft YaHei" charset="0"/>
+                        <a:cs typeface="Microsoft YaHei" charset="0"/>
                       </a:endParaRPr>
                     </a:p>
                   </a:txBody>
@@ -14470,16 +14472,16 @@
                           <a:solidFill>
                             <a:srgbClr val="1C2333"/>
                           </a:solidFill>
-                          <a:latin typeface="PingFang SC" pitchFamily="34" charset="0"/>
-                          <a:ea typeface="PingFang SC" pitchFamily="34" charset="-122"/>
-                          <a:cs typeface="PingFang SC" pitchFamily="34" charset="-120"/>
+                          <a:latin typeface="Microsoft YaHei" pitchFamily="34" charset="0"/>
+                          <a:ea typeface="Microsoft YaHei" pitchFamily="34" charset="-122"/>
+                          <a:cs typeface="Microsoft YaHei" pitchFamily="34" charset="-120"/>
                         </a:rPr>
                         <a:t>生成 Provider</a:t>
                       </a:r>
                       <a:endParaRPr lang="en-US" sz="1150" dirty="0">
-                        <a:latin typeface="PingFang SC" charset="0"/>
-                        <a:ea typeface="PingFang SC" charset="0"/>
-                        <a:cs typeface="PingFang SC" charset="0"/>
+                        <a:latin typeface="Microsoft YaHei" charset="0"/>
+                        <a:ea typeface="Microsoft YaHei" charset="0"/>
+                        <a:cs typeface="Microsoft YaHei" charset="0"/>
                       </a:endParaRPr>
                     </a:p>
                   </a:txBody>
@@ -14540,16 +14542,16 @@
                           <a:solidFill>
                             <a:srgbClr val="3B5BFD"/>
                           </a:solidFill>
-                          <a:latin typeface="PingFang SC" pitchFamily="34" charset="0"/>
-                          <a:ea typeface="PingFang SC" pitchFamily="34" charset="-122"/>
-                          <a:cs typeface="PingFang SC" pitchFamily="34" charset="-120"/>
+                          <a:latin typeface="Microsoft YaHei" pitchFamily="34" charset="0"/>
+                          <a:ea typeface="Microsoft YaHei" pitchFamily="34" charset="-122"/>
+                          <a:cs typeface="Microsoft YaHei" pitchFamily="34" charset="-120"/>
                         </a:rPr>
                         <a:t>可修改性</a:t>
                       </a:r>
                       <a:endParaRPr lang="en-US" sz="1150" dirty="0">
-                        <a:latin typeface="PingFang SC" charset="0"/>
-                        <a:ea typeface="PingFang SC" charset="0"/>
-                        <a:cs typeface="PingFang SC" charset="0"/>
+                        <a:latin typeface="Microsoft YaHei" charset="0"/>
+                        <a:ea typeface="Microsoft YaHei" charset="0"/>
+                        <a:cs typeface="Microsoft YaHei" charset="0"/>
                       </a:endParaRPr>
                     </a:p>
                   </a:txBody>
@@ -14608,16 +14610,16 @@
                           <a:solidFill>
                             <a:srgbClr val="1C2333"/>
                           </a:solidFill>
-                          <a:latin typeface="PingFang SC" pitchFamily="34" charset="0"/>
-                          <a:ea typeface="PingFang SC" pitchFamily="34" charset="-122"/>
-                          <a:cs typeface="PingFang SC" pitchFamily="34" charset="-120"/>
+                          <a:latin typeface="Microsoft YaHei" pitchFamily="34" charset="0"/>
+                          <a:ea typeface="Microsoft YaHei" pitchFamily="34" charset="-122"/>
+                          <a:cs typeface="Microsoft YaHei" pitchFamily="34" charset="-120"/>
                         </a:rPr>
                         <a:t>知识新增/修正后新知识立即生效</a:t>
                       </a:r>
                       <a:endParaRPr lang="en-US" sz="1150" dirty="0">
-                        <a:latin typeface="PingFang SC" charset="0"/>
-                        <a:ea typeface="PingFang SC" charset="0"/>
-                        <a:cs typeface="PingFang SC" charset="0"/>
+                        <a:latin typeface="Microsoft YaHei" charset="0"/>
+                        <a:ea typeface="Microsoft YaHei" charset="0"/>
+                        <a:cs typeface="Microsoft YaHei" charset="0"/>
                       </a:endParaRPr>
                     </a:p>
                   </a:txBody>
@@ -14676,16 +14678,16 @@
                           <a:solidFill>
                             <a:srgbClr val="1C2333"/>
                           </a:solidFill>
-                          <a:latin typeface="PingFang SC" pitchFamily="34" charset="0"/>
-                          <a:ea typeface="PingFang SC" pitchFamily="34" charset="-122"/>
-                          <a:cs typeface="PingFang SC" pitchFamily="34" charset="-120"/>
+                          <a:latin typeface="Microsoft YaHei" pitchFamily="34" charset="0"/>
+                          <a:ea typeface="Microsoft YaHei" pitchFamily="34" charset="-122"/>
+                          <a:cs typeface="Microsoft YaHei" pitchFamily="34" charset="-120"/>
                         </a:rPr>
                         <a:t>索引热更新 &lt; 5s 无需重启</a:t>
                       </a:r>
                       <a:endParaRPr lang="en-US" sz="1150" dirty="0">
-                        <a:latin typeface="PingFang SC" charset="0"/>
-                        <a:ea typeface="PingFang SC" charset="0"/>
-                        <a:cs typeface="PingFang SC" charset="0"/>
+                        <a:latin typeface="Microsoft YaHei" charset="0"/>
+                        <a:ea typeface="Microsoft YaHei" charset="0"/>
+                        <a:cs typeface="Microsoft YaHei" charset="0"/>
                       </a:endParaRPr>
                     </a:p>
                   </a:txBody>
@@ -14744,16 +14746,16 @@
                           <a:solidFill>
                             <a:srgbClr val="1C2333"/>
                           </a:solidFill>
-                          <a:latin typeface="PingFang SC" pitchFamily="34" charset="0"/>
-                          <a:ea typeface="PingFang SC" pitchFamily="34" charset="-122"/>
-                          <a:cs typeface="PingFang SC" pitchFamily="34" charset="-120"/>
+                          <a:latin typeface="Microsoft YaHei" pitchFamily="34" charset="0"/>
+                          <a:ea typeface="Microsoft YaHei" pitchFamily="34" charset="-122"/>
+                          <a:cs typeface="Microsoft YaHei" pitchFamily="34" charset="-120"/>
                         </a:rPr>
                         <a:t>摄取+索引</a:t>
                       </a:r>
                       <a:endParaRPr lang="en-US" sz="1150" dirty="0">
-                        <a:latin typeface="PingFang SC" charset="0"/>
-                        <a:ea typeface="PingFang SC" charset="0"/>
-                        <a:cs typeface="PingFang SC" charset="0"/>
+                        <a:latin typeface="Microsoft YaHei" charset="0"/>
+                        <a:ea typeface="Microsoft YaHei" charset="0"/>
+                        <a:cs typeface="Microsoft YaHei" charset="0"/>
                       </a:endParaRPr>
                     </a:p>
                   </a:txBody>
@@ -14814,16 +14816,16 @@
                           <a:solidFill>
                             <a:srgbClr val="3B5BFD"/>
                           </a:solidFill>
-                          <a:latin typeface="PingFang SC" pitchFamily="34" charset="0"/>
-                          <a:ea typeface="PingFang SC" pitchFamily="34" charset="-122"/>
-                          <a:cs typeface="PingFang SC" pitchFamily="34" charset="-120"/>
+                          <a:latin typeface="Microsoft YaHei" pitchFamily="34" charset="0"/>
+                          <a:ea typeface="Microsoft YaHei" pitchFamily="34" charset="-122"/>
+                          <a:cs typeface="Microsoft YaHei" pitchFamily="34" charset="-120"/>
                         </a:rPr>
                         <a:t>可扩展性</a:t>
                       </a:r>
                       <a:endParaRPr lang="en-US" sz="1150" dirty="0">
-                        <a:latin typeface="PingFang SC" charset="0"/>
-                        <a:ea typeface="PingFang SC" charset="0"/>
-                        <a:cs typeface="PingFang SC" charset="0"/>
+                        <a:latin typeface="Microsoft YaHei" charset="0"/>
+                        <a:ea typeface="Microsoft YaHei" charset="0"/>
+                        <a:cs typeface="Microsoft YaHei" charset="0"/>
                       </a:endParaRPr>
                     </a:p>
                   </a:txBody>
@@ -14882,16 +14884,16 @@
                           <a:solidFill>
                             <a:srgbClr val="1C2333"/>
                           </a:solidFill>
-                          <a:latin typeface="PingFang SC" pitchFamily="34" charset="0"/>
-                          <a:ea typeface="PingFang SC" pitchFamily="34" charset="-122"/>
-                          <a:cs typeface="PingFang SC" pitchFamily="34" charset="-120"/>
+                          <a:latin typeface="Microsoft YaHei" pitchFamily="34" charset="0"/>
+                          <a:ea typeface="Microsoft YaHei" pitchFamily="34" charset="-122"/>
+                          <a:cs typeface="Microsoft YaHei" pitchFamily="34" charset="-120"/>
                         </a:rPr>
                         <a:t>用户增长靠加副本而非重构</a:t>
                       </a:r>
                       <a:endParaRPr lang="en-US" sz="1150" dirty="0">
-                        <a:latin typeface="PingFang SC" charset="0"/>
-                        <a:ea typeface="PingFang SC" charset="0"/>
-                        <a:cs typeface="PingFang SC" charset="0"/>
+                        <a:latin typeface="Microsoft YaHei" charset="0"/>
+                        <a:ea typeface="Microsoft YaHei" charset="0"/>
+                        <a:cs typeface="Microsoft YaHei" charset="0"/>
                       </a:endParaRPr>
                     </a:p>
                   </a:txBody>
@@ -14950,16 +14952,16 @@
                           <a:solidFill>
                             <a:srgbClr val="1C2333"/>
                           </a:solidFill>
-                          <a:latin typeface="PingFang SC" pitchFamily="34" charset="0"/>
-                          <a:ea typeface="PingFang SC" pitchFamily="34" charset="-122"/>
-                          <a:cs typeface="PingFang SC" pitchFamily="34" charset="-120"/>
+                          <a:latin typeface="Microsoft YaHei" pitchFamily="34" charset="0"/>
+                          <a:ea typeface="Microsoft YaHei" pitchFamily="34" charset="-122"/>
+                          <a:cs typeface="Microsoft YaHei" pitchFamily="34" charset="-120"/>
                         </a:rPr>
                         <a:t>应用无状态 · N 副本负载均衡</a:t>
                       </a:r>
                       <a:endParaRPr lang="en-US" sz="1150" dirty="0">
-                        <a:latin typeface="PingFang SC" charset="0"/>
-                        <a:ea typeface="PingFang SC" charset="0"/>
-                        <a:cs typeface="PingFang SC" charset="0"/>
+                        <a:latin typeface="Microsoft YaHei" charset="0"/>
+                        <a:ea typeface="Microsoft YaHei" charset="0"/>
+                        <a:cs typeface="Microsoft YaHei" charset="0"/>
                       </a:endParaRPr>
                     </a:p>
                   </a:txBody>
@@ -15018,16 +15020,16 @@
                           <a:solidFill>
                             <a:srgbClr val="1C2333"/>
                           </a:solidFill>
-                          <a:latin typeface="PingFang SC" pitchFamily="34" charset="0"/>
-                          <a:ea typeface="PingFang SC" pitchFamily="34" charset="-122"/>
-                          <a:cs typeface="PingFang SC" pitchFamily="34" charset="-120"/>
+                          <a:latin typeface="Microsoft YaHei" pitchFamily="34" charset="0"/>
+                          <a:ea typeface="Microsoft YaHei" pitchFamily="34" charset="-122"/>
+                          <a:cs typeface="Microsoft YaHei" pitchFamily="34" charset="-120"/>
                         </a:rPr>
                         <a:t>应用服务层</a:t>
                       </a:r>
                       <a:endParaRPr lang="en-US" sz="1150" dirty="0">
-                        <a:latin typeface="PingFang SC" charset="0"/>
-                        <a:ea typeface="PingFang SC" charset="0"/>
-                        <a:cs typeface="PingFang SC" charset="0"/>
+                        <a:latin typeface="Microsoft YaHei" charset="0"/>
+                        <a:ea typeface="Microsoft YaHei" charset="0"/>
+                        <a:cs typeface="Microsoft YaHei" charset="0"/>
                       </a:endParaRPr>
                     </a:p>
                   </a:txBody>
@@ -15088,16 +15090,16 @@
                           <a:solidFill>
                             <a:srgbClr val="3B5BFD"/>
                           </a:solidFill>
-                          <a:latin typeface="PingFang SC" pitchFamily="34" charset="0"/>
-                          <a:ea typeface="PingFang SC" pitchFamily="34" charset="-122"/>
-                          <a:cs typeface="PingFang SC" pitchFamily="34" charset="-120"/>
+                          <a:latin typeface="Microsoft YaHei" pitchFamily="34" charset="0"/>
+                          <a:ea typeface="Microsoft YaHei" pitchFamily="34" charset="-122"/>
+                          <a:cs typeface="Microsoft YaHei" pitchFamily="34" charset="-120"/>
                         </a:rPr>
                         <a:t>安全性</a:t>
                       </a:r>
                       <a:endParaRPr lang="en-US" sz="1150" dirty="0">
-                        <a:latin typeface="PingFang SC" charset="0"/>
-                        <a:ea typeface="PingFang SC" charset="0"/>
-                        <a:cs typeface="PingFang SC" charset="0"/>
+                        <a:latin typeface="Microsoft YaHei" charset="0"/>
+                        <a:ea typeface="Microsoft YaHei" charset="0"/>
+                        <a:cs typeface="Microsoft YaHei" charset="0"/>
                       </a:endParaRPr>
                     </a:p>
                   </a:txBody>
@@ -15156,16 +15158,16 @@
                           <a:solidFill>
                             <a:srgbClr val="1C2333"/>
                           </a:solidFill>
-                          <a:latin typeface="PingFang SC" pitchFamily="34" charset="0"/>
-                          <a:ea typeface="PingFang SC" pitchFamily="34" charset="-122"/>
-                          <a:cs typeface="PingFang SC" pitchFamily="34" charset="-120"/>
+                          <a:latin typeface="Microsoft YaHei" pitchFamily="34" charset="0"/>
+                          <a:ea typeface="Microsoft YaHei" pitchFamily="34" charset="-122"/>
+                          <a:cs typeface="Microsoft YaHei" pitchFamily="34" charset="-120"/>
                         </a:rPr>
                         <a:t>单用户高频请求不拖垮服务</a:t>
                       </a:r>
                       <a:endParaRPr lang="en-US" sz="1150" dirty="0">
-                        <a:latin typeface="PingFang SC" charset="0"/>
-                        <a:ea typeface="PingFang SC" charset="0"/>
-                        <a:cs typeface="PingFang SC" charset="0"/>
+                        <a:latin typeface="Microsoft YaHei" charset="0"/>
+                        <a:ea typeface="Microsoft YaHei" charset="0"/>
+                        <a:cs typeface="Microsoft YaHei" charset="0"/>
                       </a:endParaRPr>
                     </a:p>
                   </a:txBody>
@@ -15224,16 +15226,16 @@
                           <a:solidFill>
                             <a:srgbClr val="1C2333"/>
                           </a:solidFill>
-                          <a:latin typeface="PingFang SC" pitchFamily="34" charset="0"/>
-                          <a:ea typeface="PingFang SC" pitchFamily="34" charset="-122"/>
-                          <a:cs typeface="PingFang SC" pitchFamily="34" charset="-120"/>
+                          <a:latin typeface="Microsoft YaHei" pitchFamily="34" charset="0"/>
+                          <a:ea typeface="Microsoft YaHei" pitchFamily="34" charset="-122"/>
+                          <a:cs typeface="Microsoft YaHei" pitchFamily="34" charset="-120"/>
                         </a:rPr>
                         <a:t>令牌桶 5 QPS/用户 · 超限 429</a:t>
                       </a:r>
                       <a:endParaRPr lang="en-US" sz="1150" dirty="0">
-                        <a:latin typeface="PingFang SC" charset="0"/>
-                        <a:ea typeface="PingFang SC" charset="0"/>
-                        <a:cs typeface="PingFang SC" charset="0"/>
+                        <a:latin typeface="Microsoft YaHei" charset="0"/>
+                        <a:ea typeface="Microsoft YaHei" charset="0"/>
+                        <a:cs typeface="Microsoft YaHei" charset="0"/>
                       </a:endParaRPr>
                     </a:p>
                   </a:txBody>
@@ -15292,16 +15294,16 @@
                           <a:solidFill>
                             <a:srgbClr val="1C2333"/>
                           </a:solidFill>
-                          <a:latin typeface="PingFang SC" pitchFamily="34" charset="0"/>
-                          <a:ea typeface="PingFang SC" pitchFamily="34" charset="-122"/>
-                          <a:cs typeface="PingFang SC" pitchFamily="34" charset="-120"/>
+                          <a:latin typeface="Microsoft YaHei" pitchFamily="34" charset="0"/>
+                          <a:ea typeface="Microsoft YaHei" pitchFamily="34" charset="-122"/>
+                          <a:cs typeface="Microsoft YaHei" pitchFamily="34" charset="-120"/>
                         </a:rPr>
                         <a:t>网关边界层</a:t>
                       </a:r>
                       <a:endParaRPr lang="en-US" sz="1150" dirty="0">
-                        <a:latin typeface="PingFang SC" charset="0"/>
-                        <a:ea typeface="PingFang SC" charset="0"/>
-                        <a:cs typeface="PingFang SC" charset="0"/>
+                        <a:latin typeface="Microsoft YaHei" charset="0"/>
+                        <a:ea typeface="Microsoft YaHei" charset="0"/>
+                        <a:cs typeface="Microsoft YaHei" charset="0"/>
                       </a:endParaRPr>
                     </a:p>
                   </a:txBody>
@@ -15381,9 +15383,9 @@
                 <a:solidFill>
                   <a:srgbClr val="6A7390"/>
                 </a:solidFill>
-                <a:latin typeface="PingFang SC" pitchFamily="34" charset="0"/>
-                <a:ea typeface="PingFang SC" pitchFamily="34" charset="-122"/>
-                <a:cs typeface="PingFang SC" pitchFamily="34" charset="-120"/>
+                <a:latin typeface="Microsoft YaHei" pitchFamily="34" charset="0"/>
+                <a:ea typeface="Microsoft YaHei" pitchFamily="34" charset="-122"/>
+                <a:cs typeface="Microsoft YaHei" pitchFamily="34" charset="-120"/>
               </a:rPr>
               <a:t>约束条件：8 周工期 · 3 人团队 · 零预算演示 · 回答必须可溯源不编造</a:t>
             </a:r>
@@ -15452,9 +15454,9 @@
                 <a:solidFill>
                   <a:srgbClr val="1C2333"/>
                 </a:solidFill>
-                <a:latin typeface="PingFang SC" pitchFamily="34" charset="0"/>
-                <a:ea typeface="PingFang SC" pitchFamily="34" charset="-122"/>
-                <a:cs typeface="PingFang SC" pitchFamily="34" charset="-120"/>
+                <a:latin typeface="Microsoft YaHei" pitchFamily="34" charset="0"/>
+                <a:ea typeface="Microsoft YaHei" pitchFamily="34" charset="-122"/>
+                <a:cs typeface="Microsoft YaHei" pitchFamily="34" charset="-120"/>
               </a:rPr>
               <a:t>总体架构：五层分层 + 模块化单体</a:t>
             </a:r>
@@ -15491,9 +15493,9 @@
                 <a:solidFill>
                   <a:srgbClr val="6A7390"/>
                 </a:solidFill>
-                <a:latin typeface="PingFang SC" pitchFamily="34" charset="0"/>
-                <a:ea typeface="PingFang SC" pitchFamily="34" charset="-122"/>
-                <a:cs typeface="PingFang SC" pitchFamily="34" charset="-120"/>
+                <a:latin typeface="Microsoft YaHei" pitchFamily="34" charset="0"/>
+                <a:ea typeface="Microsoft YaHei" pitchFamily="34" charset="-122"/>
+                <a:cs typeface="Microsoft YaHei" pitchFamily="34" charset="-120"/>
               </a:rPr>
               <a:t>接入 → 网关边界 → 应用服务 → RAG 引擎 → 数据；模块间仅接口依赖，预留服务化边界</a:t>
             </a:r>
@@ -15530,9 +15532,9 @@
                 <a:solidFill>
                   <a:srgbClr val="6A7390"/>
                 </a:solidFill>
-                <a:latin typeface="PingFang SC" pitchFamily="34" charset="0"/>
-                <a:ea typeface="PingFang SC" pitchFamily="34" charset="-122"/>
-                <a:cs typeface="PingFang SC" pitchFamily="34" charset="-120"/>
+                <a:latin typeface="Microsoft YaHei" pitchFamily="34" charset="0"/>
+                <a:ea typeface="Microsoft YaHei" pitchFamily="34" charset="-122"/>
+                <a:cs typeface="Microsoft YaHei" pitchFamily="34" charset="-120"/>
               </a:rPr>
               <a:t>5</a:t>
             </a:r>
@@ -15625,9 +15627,9 @@
                 <a:solidFill>
                   <a:srgbClr val="1C2333"/>
                 </a:solidFill>
-                <a:latin typeface="PingFang SC" pitchFamily="34" charset="0"/>
-                <a:ea typeface="PingFang SC" pitchFamily="34" charset="-122"/>
-                <a:cs typeface="PingFang SC" pitchFamily="34" charset="-120"/>
+                <a:latin typeface="Microsoft YaHei" pitchFamily="34" charset="0"/>
+                <a:ea typeface="Microsoft YaHei" pitchFamily="34" charset="-122"/>
+                <a:cs typeface="Microsoft YaHei" pitchFamily="34" charset="-120"/>
               </a:rPr>
               <a:t>RAG 核心链路：检索 → 融合 → 重排 → 流式生成</a:t>
             </a:r>
@@ -15664,9 +15666,9 @@
                 <a:solidFill>
                   <a:srgbClr val="6A7390"/>
                 </a:solidFill>
-                <a:latin typeface="PingFang SC" pitchFamily="34" charset="0"/>
-                <a:ea typeface="PingFang SC" pitchFamily="34" charset="-122"/>
-                <a:cs typeface="PingFang SC" pitchFamily="34" charset="-120"/>
+                <a:latin typeface="Microsoft YaHei" pitchFamily="34" charset="0"/>
+                <a:ea typeface="Microsoft YaHei" pitchFamily="34" charset="-122"/>
+                <a:cs typeface="Microsoft YaHei" pitchFamily="34" charset="-120"/>
               </a:rPr>
               <a:t>SSE 事件流：meta（先推引用来源）→ delta（token 流）→ done（落库）</a:t>
             </a:r>
@@ -15703,9 +15705,9 @@
                 <a:solidFill>
                   <a:srgbClr val="6A7390"/>
                 </a:solidFill>
-                <a:latin typeface="PingFang SC" pitchFamily="34" charset="0"/>
-                <a:ea typeface="PingFang SC" pitchFamily="34" charset="-122"/>
-                <a:cs typeface="PingFang SC" pitchFamily="34" charset="-120"/>
+                <a:latin typeface="Microsoft YaHei" pitchFamily="34" charset="0"/>
+                <a:ea typeface="Microsoft YaHei" pitchFamily="34" charset="-122"/>
+                <a:cs typeface="Microsoft YaHei" pitchFamily="34" charset="-120"/>
               </a:rPr>
               <a:t>6</a:t>
             </a:r>
@@ -15798,9 +15800,9 @@
                 <a:solidFill>
                   <a:srgbClr val="1C2333"/>
                 </a:solidFill>
-                <a:latin typeface="PingFang SC" pitchFamily="34" charset="0"/>
-                <a:ea typeface="PingFang SC" pitchFamily="34" charset="-122"/>
-                <a:cs typeface="PingFang SC" pitchFamily="34" charset="-120"/>
+                <a:latin typeface="Microsoft YaHei" pitchFamily="34" charset="0"/>
+                <a:ea typeface="Microsoft YaHei" pitchFamily="34" charset="-122"/>
+                <a:cs typeface="Microsoft YaHei" pitchFamily="34" charset="-120"/>
               </a:rPr>
               <a:t>混合检索：为什么要两条通道</a:t>
             </a:r>
@@ -15837,9 +15839,9 @@
                 <a:solidFill>
                   <a:srgbClr val="6A7390"/>
                 </a:solidFill>
-                <a:latin typeface="PingFang SC" pitchFamily="34" charset="0"/>
-                <a:ea typeface="PingFang SC" pitchFamily="34" charset="-122"/>
-                <a:cs typeface="PingFang SC" pitchFamily="34" charset="-120"/>
+                <a:latin typeface="Microsoft YaHei" pitchFamily="34" charset="0"/>
+                <a:ea typeface="Microsoft YaHei" pitchFamily="34" charset="-122"/>
+                <a:cs typeface="Microsoft YaHei" pitchFamily="34" charset="-120"/>
               </a:rPr>
               <a:t>单 BM25 不懂同义改写，向量通道现为 TF-IDF 词袋（离线如实标注），云端语义向量 Provider 已实现待接入</a:t>
             </a:r>
@@ -15876,9 +15878,9 @@
                 <a:solidFill>
                   <a:srgbClr val="6A7390"/>
                 </a:solidFill>
-                <a:latin typeface="PingFang SC" pitchFamily="34" charset="0"/>
-                <a:ea typeface="PingFang SC" pitchFamily="34" charset="-122"/>
-                <a:cs typeface="PingFang SC" pitchFamily="34" charset="-120"/>
+                <a:latin typeface="Microsoft YaHei" pitchFamily="34" charset="0"/>
+                <a:ea typeface="Microsoft YaHei" pitchFamily="34" charset="-122"/>
+                <a:cs typeface="Microsoft YaHei" pitchFamily="34" charset="-120"/>
               </a:rPr>
               <a:t>7</a:t>
             </a:r>
@@ -15944,9 +15946,9 @@
                 <a:solidFill>
                   <a:srgbClr val="FFFFFF"/>
                 </a:solidFill>
-                <a:latin typeface="PingFang SC" pitchFamily="34" charset="0"/>
-                <a:ea typeface="PingFang SC" pitchFamily="34" charset="-122"/>
-                <a:cs typeface="PingFang SC" pitchFamily="34" charset="-120"/>
+                <a:latin typeface="Microsoft YaHei" pitchFamily="34" charset="0"/>
+                <a:ea typeface="Microsoft YaHei" pitchFamily="34" charset="-122"/>
+                <a:cs typeface="Microsoft YaHei" pitchFamily="34" charset="-120"/>
               </a:rPr>
               <a:t>学生提问</a:t>
             </a:r>
@@ -15983,9 +15985,9 @@
                 <a:solidFill>
                   <a:srgbClr val="C9D2F5"/>
                 </a:solidFill>
-                <a:latin typeface="PingFang SC" pitchFamily="34" charset="0"/>
-                <a:ea typeface="PingFang SC" pitchFamily="34" charset="-122"/>
-                <a:cs typeface="PingFang SC" pitchFamily="34" charset="-120"/>
+                <a:latin typeface="Microsoft YaHei" pitchFamily="34" charset="0"/>
+                <a:ea typeface="Microsoft YaHei" pitchFamily="34" charset="-122"/>
+                <a:cs typeface="Microsoft YaHei" pitchFamily="34" charset="-120"/>
               </a:rPr>
               <a:t>「饭卡找不到了」</a:t>
             </a:r>
@@ -16051,9 +16053,9 @@
                 <a:solidFill>
                   <a:srgbClr val="FFFFFF"/>
                 </a:solidFill>
-                <a:latin typeface="PingFang SC" pitchFamily="34" charset="0"/>
-                <a:ea typeface="PingFang SC" pitchFamily="34" charset="-122"/>
-                <a:cs typeface="PingFang SC" pitchFamily="34" charset="-120"/>
+                <a:latin typeface="Microsoft YaHei" pitchFamily="34" charset="0"/>
+                <a:ea typeface="Microsoft YaHei" pitchFamily="34" charset="-122"/>
+                <a:cs typeface="Microsoft YaHei" pitchFamily="34" charset="-120"/>
               </a:rPr>
               <a:t>BM25 稀疏通道</a:t>
             </a:r>
@@ -16090,9 +16092,9 @@
                 <a:solidFill>
                   <a:srgbClr val="E7EBFF"/>
                 </a:solidFill>
-                <a:latin typeface="PingFang SC" pitchFamily="34" charset="0"/>
-                <a:ea typeface="PingFang SC" pitchFamily="34" charset="-122"/>
-                <a:cs typeface="PingFang SC" pitchFamily="34" charset="-120"/>
+                <a:latin typeface="Microsoft YaHei" pitchFamily="34" charset="0"/>
+                <a:ea typeface="Microsoft YaHei" pitchFamily="34" charset="-122"/>
+                <a:cs typeface="Microsoft YaHei" pitchFamily="34" charset="-120"/>
               </a:rPr>
               <a:t>关键词精确匹配</a:t>
             </a:r>
@@ -16158,9 +16160,9 @@
                 <a:solidFill>
                   <a:srgbClr val="FFFFFF"/>
                 </a:solidFill>
-                <a:latin typeface="PingFang SC" pitchFamily="34" charset="0"/>
-                <a:ea typeface="PingFang SC" pitchFamily="34" charset="-122"/>
-                <a:cs typeface="PingFang SC" pitchFamily="34" charset="-120"/>
+                <a:latin typeface="Microsoft YaHei" pitchFamily="34" charset="0"/>
+                <a:ea typeface="Microsoft YaHei" pitchFamily="34" charset="-122"/>
+                <a:cs typeface="Microsoft YaHei" pitchFamily="34" charset="-120"/>
               </a:rPr>
               <a:t>TF-IDF 向量通道</a:t>
             </a:r>
@@ -16197,9 +16199,9 @@
                 <a:solidFill>
                   <a:srgbClr val="E7EBFF"/>
                 </a:solidFill>
-                <a:latin typeface="PingFang SC" pitchFamily="34" charset="0"/>
-                <a:ea typeface="PingFang SC" pitchFamily="34" charset="-122"/>
-                <a:cs typeface="PingFang SC" pitchFamily="34" charset="-120"/>
+                <a:latin typeface="Microsoft YaHei" pitchFamily="34" charset="0"/>
+                <a:ea typeface="Microsoft YaHei" pitchFamily="34" charset="-122"/>
+                <a:cs typeface="Microsoft YaHei" pitchFamily="34" charset="-120"/>
               </a:rPr>
               <a:t>离线词袋 · 可插拔语义向量</a:t>
             </a:r>
@@ -16265,9 +16267,9 @@
                 <a:solidFill>
                   <a:srgbClr val="FFFFFF"/>
                 </a:solidFill>
-                <a:latin typeface="PingFang SC" pitchFamily="34" charset="0"/>
-                <a:ea typeface="PingFang SC" pitchFamily="34" charset="-122"/>
-                <a:cs typeface="PingFang SC" pitchFamily="34" charset="-120"/>
+                <a:latin typeface="Microsoft YaHei" pitchFamily="34" charset="0"/>
+                <a:ea typeface="Microsoft YaHei" pitchFamily="34" charset="-122"/>
+                <a:cs typeface="Microsoft YaHei" pitchFamily="34" charset="-120"/>
               </a:rPr>
               <a:t>RRF 融合</a:t>
             </a:r>
@@ -16304,9 +16306,9 @@
                 <a:solidFill>
                   <a:srgbClr val="FFF3E8"/>
                 </a:solidFill>
-                <a:latin typeface="PingFang SC" pitchFamily="34" charset="0"/>
-                <a:ea typeface="PingFang SC" pitchFamily="34" charset="-122"/>
-                <a:cs typeface="PingFang SC" pitchFamily="34" charset="-120"/>
+                <a:latin typeface="Microsoft YaHei" pitchFamily="34" charset="0"/>
+                <a:ea typeface="Microsoft YaHei" pitchFamily="34" charset="-122"/>
+                <a:cs typeface="Microsoft YaHei" pitchFamily="34" charset="-120"/>
               </a:rPr>
               <a:t>按排名融合 k=60</a:t>
             </a:r>
@@ -16372,9 +16374,9 @@
                 <a:solidFill>
                   <a:srgbClr val="FFFFFF"/>
                 </a:solidFill>
-                <a:latin typeface="PingFang SC" pitchFamily="34" charset="0"/>
-                <a:ea typeface="PingFang SC" pitchFamily="34" charset="-122"/>
-                <a:cs typeface="PingFang SC" pitchFamily="34" charset="-120"/>
+                <a:latin typeface="Microsoft YaHei" pitchFamily="34" charset="0"/>
+                <a:ea typeface="Microsoft YaHei" pitchFamily="34" charset="-122"/>
+                <a:cs typeface="Microsoft YaHei" pitchFamily="34" charset="-120"/>
               </a:rPr>
               <a:t>重排序(可选开关)</a:t>
             </a:r>
@@ -16411,9 +16413,9 @@
                 <a:solidFill>
                   <a:srgbClr val="FFF3E8"/>
                 </a:solidFill>
-                <a:latin typeface="PingFang SC" pitchFamily="34" charset="0"/>
-                <a:ea typeface="PingFang SC" pitchFamily="34" charset="-122"/>
-                <a:cs typeface="PingFang SC" pitchFamily="34" charset="-120"/>
+                <a:latin typeface="Microsoft YaHei" pitchFamily="34" charset="0"/>
+                <a:ea typeface="Microsoft YaHei" pitchFamily="34" charset="-122"/>
+                <a:cs typeface="Microsoft YaHei" pitchFamily="34" charset="-120"/>
               </a:rPr>
               <a:t>默认关闭 RERANK_ENABLED</a:t>
             </a:r>
@@ -16597,9 +16599,9 @@
                 <a:solidFill>
                   <a:srgbClr val="3B5BFD"/>
                 </a:solidFill>
-                <a:latin typeface="PingFang SC" pitchFamily="34" charset="0"/>
-                <a:ea typeface="PingFang SC" pitchFamily="34" charset="-122"/>
-                <a:cs typeface="PingFang SC" pitchFamily="34" charset="-120"/>
+                <a:latin typeface="Microsoft YaHei" pitchFamily="34" charset="0"/>
+                <a:ea typeface="Microsoft YaHei" pitchFamily="34" charset="-122"/>
+                <a:cs typeface="Microsoft YaHei" pitchFamily="34" charset="-120"/>
               </a:rPr>
               <a:t>生成 Provider</a:t>
             </a:r>
@@ -16639,9 +16641,9 @@
                 <a:solidFill>
                   <a:srgbClr val="1C2333"/>
                 </a:solidFill>
-                <a:latin typeface="PingFang SC" pitchFamily="34" charset="0"/>
-                <a:ea typeface="PingFang SC" pitchFamily="34" charset="-122"/>
-                <a:cs typeface="PingFang SC" pitchFamily="34" charset="-120"/>
+                <a:latin typeface="Microsoft YaHei" pitchFamily="34" charset="0"/>
+                <a:ea typeface="Microsoft YaHei" pitchFamily="34" charset="-122"/>
+                <a:cs typeface="Microsoft YaHei" pitchFamily="34" charset="-120"/>
               </a:rPr>
               <a:t>本地抽取式 ∥ 云端 GLM</a:t>
             </a:r>
@@ -16659,9 +16661,9 @@
                 <a:solidFill>
                   <a:srgbClr val="1C2333"/>
                 </a:solidFill>
-                <a:latin typeface="PingFang SC" pitchFamily="34" charset="0"/>
-                <a:ea typeface="PingFang SC" pitchFamily="34" charset="-122"/>
-                <a:cs typeface="PingFang SC" pitchFamily="34" charset="-120"/>
+                <a:latin typeface="Microsoft YaHei" pitchFamily="34" charset="0"/>
+                <a:ea typeface="Microsoft YaHei" pitchFamily="34" charset="-122"/>
+                <a:cs typeface="Microsoft YaHei" pitchFamily="34" charset="-120"/>
               </a:rPr>
               <a:t>插件化双模</a:t>
             </a:r>
@@ -16679,9 +16681,9 @@
                 <a:solidFill>
                   <a:srgbClr val="1C2333"/>
                 </a:solidFill>
-                <a:latin typeface="PingFang SC" pitchFamily="34" charset="0"/>
-                <a:ea typeface="PingFang SC" pitchFamily="34" charset="-122"/>
-                <a:cs typeface="PingFang SC" pitchFamily="34" charset="-120"/>
+                <a:latin typeface="Microsoft YaHei" pitchFamily="34" charset="0"/>
+                <a:ea typeface="Microsoft YaHei" pitchFamily="34" charset="-122"/>
+                <a:cs typeface="Microsoft YaHei" pitchFamily="34" charset="-120"/>
               </a:rPr>
               <a:t>故障自动降级</a:t>
             </a:r>
@@ -16779,9 +16781,9 @@
                 <a:solidFill>
                   <a:srgbClr val="3B5BFD"/>
                 </a:solidFill>
-                <a:latin typeface="PingFang SC" pitchFamily="34" charset="0"/>
-                <a:ea typeface="PingFang SC" pitchFamily="34" charset="-122"/>
-                <a:cs typeface="PingFang SC" pitchFamily="34" charset="-120"/>
+                <a:latin typeface="Microsoft YaHei" pitchFamily="34" charset="0"/>
+                <a:ea typeface="Microsoft YaHei" pitchFamily="34" charset="-122"/>
+                <a:cs typeface="Microsoft YaHei" pitchFamily="34" charset="-120"/>
               </a:rPr>
               <a:t>可观察性设计：</a:t>
             </a:r>
@@ -16796,9 +16798,9 @@
                 <a:solidFill>
                   <a:srgbClr val="1C2333"/>
                 </a:solidFill>
-                <a:latin typeface="PingFang SC" pitchFamily="34" charset="0"/>
-                <a:ea typeface="PingFang SC" pitchFamily="34" charset="-122"/>
-                <a:cs typeface="PingFang SC" pitchFamily="34" charset="-120"/>
+                <a:latin typeface="Microsoft YaHei" pitchFamily="34" charset="0"/>
+                <a:ea typeface="Microsoft YaHei" pitchFamily="34" charset="-122"/>
+                <a:cs typeface="Microsoft YaHei" pitchFamily="34" charset="-120"/>
               </a:rPr>
               <a:t>调试接口与前端引用卡片同步暴露双通道排名与融合分数 —— 检索过程可解释、可课件化、可调参（如右图：BM25#1 · VEC#1 · 85%）</a:t>
             </a:r>
@@ -16867,9 +16869,9 @@
                 <a:solidFill>
                   <a:srgbClr val="1C2333"/>
                 </a:solidFill>
-                <a:latin typeface="PingFang SC" pitchFamily="34" charset="0"/>
-                <a:ea typeface="PingFang SC" pitchFamily="34" charset="-122"/>
-                <a:cs typeface="PingFang SC" pitchFamily="34" charset="-120"/>
+                <a:latin typeface="Microsoft YaHei" pitchFamily="34" charset="0"/>
+                <a:ea typeface="Microsoft YaHei" pitchFamily="34" charset="-122"/>
+                <a:cs typeface="Microsoft YaHei" pitchFamily="34" charset="-120"/>
               </a:rPr>
               <a:t>关键架构决策（ADR 摘要）</a:t>
             </a:r>
@@ -16906,9 +16908,9 @@
                 <a:solidFill>
                   <a:srgbClr val="6A7390"/>
                 </a:solidFill>
-                <a:latin typeface="PingFang SC" pitchFamily="34" charset="0"/>
-                <a:ea typeface="PingFang SC" pitchFamily="34" charset="-122"/>
-                <a:cs typeface="PingFang SC" pitchFamily="34" charset="-120"/>
+                <a:latin typeface="Microsoft YaHei" pitchFamily="34" charset="0"/>
+                <a:ea typeface="Microsoft YaHei" pitchFamily="34" charset="-122"/>
+                <a:cs typeface="Microsoft YaHei" pitchFamily="34" charset="-120"/>
               </a:rPr>
               <a:t>每个决策都有被否决的备选方案与理由</a:t>
             </a:r>
@@ -16945,9 +16947,9 @@
                 <a:solidFill>
                   <a:srgbClr val="6A7390"/>
                 </a:solidFill>
-                <a:latin typeface="PingFang SC" pitchFamily="34" charset="0"/>
-                <a:ea typeface="PingFang SC" pitchFamily="34" charset="-122"/>
-                <a:cs typeface="PingFang SC" pitchFamily="34" charset="-120"/>
+                <a:latin typeface="Microsoft YaHei" pitchFamily="34" charset="0"/>
+                <a:ea typeface="Microsoft YaHei" pitchFamily="34" charset="-122"/>
+                <a:cs typeface="Microsoft YaHei" pitchFamily="34" charset="-120"/>
               </a:rPr>
               <a:t>8</a:t>
             </a:r>
@@ -17021,9 +17023,9 @@
                 <a:solidFill>
                   <a:srgbClr val="3B5BFD"/>
                 </a:solidFill>
-                <a:latin typeface="PingFang SC" pitchFamily="34" charset="0"/>
-                <a:ea typeface="PingFang SC" pitchFamily="34" charset="-122"/>
-                <a:cs typeface="PingFang SC" pitchFamily="34" charset="-120"/>
+                <a:latin typeface="Microsoft YaHei" pitchFamily="34" charset="0"/>
+                <a:ea typeface="Microsoft YaHei" pitchFamily="34" charset="-122"/>
+                <a:cs typeface="Microsoft YaHei" pitchFamily="34" charset="-120"/>
               </a:rPr>
               <a:t>ADR-1 模块化单体起步</a:t>
             </a:r>
@@ -17063,9 +17065,9 @@
                 <a:solidFill>
                   <a:srgbClr val="1C2333"/>
                 </a:solidFill>
-                <a:latin typeface="PingFang SC" pitchFamily="34" charset="0"/>
-                <a:ea typeface="PingFang SC" pitchFamily="34" charset="-122"/>
-                <a:cs typeface="PingFang SC" pitchFamily="34" charset="-120"/>
+                <a:latin typeface="Microsoft YaHei" pitchFamily="34" charset="0"/>
+                <a:ea typeface="Microsoft YaHei" pitchFamily="34" charset="-122"/>
+                <a:cs typeface="Microsoft YaHei" pitchFamily="34" charset="-120"/>
               </a:rPr>
               <a:t>否决微服务全家桶（8 周工期不容许）与纯分层（拆分代价高），保留服务化边界</a:t>
             </a:r>
@@ -17139,9 +17141,9 @@
                 <a:solidFill>
                   <a:srgbClr val="3B5BFD"/>
                 </a:solidFill>
-                <a:latin typeface="PingFang SC" pitchFamily="34" charset="0"/>
-                <a:ea typeface="PingFang SC" pitchFamily="34" charset="-122"/>
-                <a:cs typeface="PingFang SC" pitchFamily="34" charset="-120"/>
+                <a:latin typeface="Microsoft YaHei" pitchFamily="34" charset="0"/>
+                <a:ea typeface="Microsoft YaHei" pitchFamily="34" charset="-122"/>
+                <a:cs typeface="Microsoft YaHei" pitchFamily="34" charset="-120"/>
               </a:rPr>
               <a:t>ADR-2 混合检索默认 RRF</a:t>
             </a:r>
@@ -17181,9 +17183,9 @@
                 <a:solidFill>
                   <a:srgbClr val="1C2333"/>
                 </a:solidFill>
-                <a:latin typeface="PingFang SC" pitchFamily="34" charset="0"/>
-                <a:ea typeface="PingFang SC" pitchFamily="34" charset="-122"/>
-                <a:cs typeface="PingFang SC" pitchFamily="34" charset="-120"/>
+                <a:latin typeface="Microsoft YaHei" pitchFamily="34" charset="0"/>
+                <a:ea typeface="Microsoft YaHei" pitchFamily="34" charset="-122"/>
+                <a:cs typeface="Microsoft YaHei" pitchFamily="34" charset="-120"/>
               </a:rPr>
               <a:t>否决单一通道；重排实测无收益降为开关；向量现态 TF-IDF（ADR-7）</a:t>
             </a:r>
@@ -17257,9 +17259,9 @@
                 <a:solidFill>
                   <a:srgbClr val="3B5BFD"/>
                 </a:solidFill>
-                <a:latin typeface="PingFang SC" pitchFamily="34" charset="0"/>
-                <a:ea typeface="PingFang SC" pitchFamily="34" charset="-122"/>
-                <a:cs typeface="PingFang SC" pitchFamily="34" charset="-120"/>
+                <a:latin typeface="Microsoft YaHei" pitchFamily="34" charset="0"/>
+                <a:ea typeface="Microsoft YaHei" pitchFamily="34" charset="-122"/>
+                <a:cs typeface="Microsoft YaHei" pitchFamily="34" charset="-120"/>
               </a:rPr>
               <a:t>ADR-3 SSE 承载流式回答</a:t>
             </a:r>
@@ -17299,9 +17301,9 @@
                 <a:solidFill>
                   <a:srgbClr val="1C2333"/>
                 </a:solidFill>
-                <a:latin typeface="PingFang SC" pitchFamily="34" charset="0"/>
-                <a:ea typeface="PingFang SC" pitchFamily="34" charset="-122"/>
-                <a:cs typeface="PingFang SC" pitchFamily="34" charset="-120"/>
+                <a:latin typeface="Microsoft YaHei" pitchFamily="34" charset="0"/>
+                <a:ea typeface="Microsoft YaHei" pitchFamily="34" charset="-122"/>
+                <a:cs typeface="Microsoft YaHei" pitchFamily="34" charset="-120"/>
               </a:rPr>
               <a:t>否决 WebSocket：单向推送场景更轻量、对网关友好；WS 留待后续双向场景</a:t>
             </a:r>
@@ -17375,9 +17377,9 @@
                 <a:solidFill>
                   <a:srgbClr val="3B5BFD"/>
                 </a:solidFill>
-                <a:latin typeface="PingFang SC" pitchFamily="34" charset="0"/>
-                <a:ea typeface="PingFang SC" pitchFamily="34" charset="-122"/>
-                <a:cs typeface="PingFang SC" pitchFamily="34" charset="-120"/>
+                <a:latin typeface="Microsoft YaHei" pitchFamily="34" charset="0"/>
+                <a:ea typeface="Microsoft YaHei" pitchFamily="34" charset="-122"/>
+                <a:cs typeface="Microsoft YaHei" pitchFamily="34" charset="-120"/>
               </a:rPr>
               <a:t>ADR-4 生成 Provider 插件化</a:t>
             </a:r>
@@ -17417,9 +17419,9 @@
                 <a:solidFill>
                   <a:srgbClr val="1C2333"/>
                 </a:solidFill>
-                <a:latin typeface="PingFang SC" pitchFamily="34" charset="0"/>
-                <a:ea typeface="PingFang SC" pitchFamily="34" charset="-122"/>
-                <a:cs typeface="PingFang SC" pitchFamily="34" charset="-120"/>
+                <a:latin typeface="Microsoft YaHei" pitchFamily="34" charset="0"/>
+                <a:ea typeface="Microsoft YaHei" pitchFamily="34" charset="-122"/>
+                <a:cs typeface="Microsoft YaHei" pitchFamily="34" charset="-120"/>
               </a:rPr>
               <a:t>否决强依赖云端 LLM：演示可离线跑，云端故障自动降级不中断</a:t>
             </a:r>
@@ -17493,9 +17495,9 @@
                 <a:solidFill>
                   <a:srgbClr val="3B5BFD"/>
                 </a:solidFill>
-                <a:latin typeface="PingFang SC" pitchFamily="34" charset="0"/>
-                <a:ea typeface="PingFang SC" pitchFamily="34" charset="-122"/>
-                <a:cs typeface="PingFang SC" pitchFamily="34" charset="-120"/>
+                <a:latin typeface="Microsoft YaHei" pitchFamily="34" charset="0"/>
+                <a:ea typeface="Microsoft YaHei" pitchFamily="34" charset="-122"/>
+                <a:cs typeface="Microsoft YaHei" pitchFamily="34" charset="-120"/>
               </a:rPr>
               <a:t>ADR-5 内存索引+热重建</a:t>
             </a:r>
@@ -17535,9 +17537,9 @@
                 <a:solidFill>
                   <a:srgbClr val="1C2333"/>
                 </a:solidFill>
-                <a:latin typeface="PingFang SC" pitchFamily="34" charset="0"/>
-                <a:ea typeface="PingFang SC" pitchFamily="34" charset="-122"/>
-                <a:cs typeface="PingFang SC" pitchFamily="34" charset="-120"/>
+                <a:latin typeface="Microsoft YaHei" pitchFamily="34" charset="0"/>
+                <a:ea typeface="Microsoft YaHei" pitchFamily="34" charset="-122"/>
+                <a:cs typeface="Microsoft YaHei" pitchFamily="34" charset="-120"/>
               </a:rPr>
               <a:t>否决每请求重建索引；万级 chunk 内存足够，超出再迁向量库</a:t>
             </a:r>
@@ -17611,9 +17613,9 @@
                 <a:solidFill>
                   <a:srgbClr val="3B5BFD"/>
                 </a:solidFill>
-                <a:latin typeface="PingFang SC" pitchFamily="34" charset="0"/>
-                <a:ea typeface="PingFang SC" pitchFamily="34" charset="-122"/>
-                <a:cs typeface="PingFang SC" pitchFamily="34" charset="-120"/>
+                <a:latin typeface="Microsoft YaHei" pitchFamily="34" charset="0"/>
+                <a:ea typeface="Microsoft YaHei" pitchFamily="34" charset="-122"/>
+                <a:cs typeface="Microsoft YaHei" pitchFamily="34" charset="-120"/>
               </a:rPr>
               <a:t>ADR-6 令牌桶入口限流</a:t>
             </a:r>
@@ -17653,9 +17655,9 @@
                 <a:solidFill>
                   <a:srgbClr val="1C2333"/>
                 </a:solidFill>
-                <a:latin typeface="PingFang SC" pitchFamily="34" charset="0"/>
-                <a:ea typeface="PingFang SC" pitchFamily="34" charset="-122"/>
-                <a:cs typeface="PingFang SC" pitchFamily="34" charset="-120"/>
+                <a:latin typeface="Microsoft YaHei" pitchFamily="34" charset="0"/>
+                <a:ea typeface="Microsoft YaHei" pitchFamily="34" charset="-122"/>
+                <a:cs typeface="Microsoft YaHei" pitchFamily="34" charset="-120"/>
               </a:rPr>
               <a:t>演示代砆无统一身份；协议兼容，生产换 Redis 滑动窗口</a:t>
             </a:r>
@@ -17724,9 +17726,9 @@
                 <a:solidFill>
                   <a:srgbClr val="1C2333"/>
                 </a:solidFill>
-                <a:latin typeface="PingFang SC" pitchFamily="34" charset="0"/>
-                <a:ea typeface="PingFang SC" pitchFamily="34" charset="-122"/>
-                <a:cs typeface="PingFang SC" pitchFamily="34" charset="-120"/>
+                <a:latin typeface="Microsoft YaHei" pitchFamily="34" charset="0"/>
+                <a:ea typeface="Microsoft YaHei" pitchFamily="34" charset="-122"/>
+                <a:cs typeface="Microsoft YaHei" pitchFamily="34" charset="-120"/>
               </a:rPr>
               <a:t>技术选型：关键维度对比</a:t>
             </a:r>
@@ -17763,9 +17765,9 @@
                 <a:solidFill>
                   <a:srgbClr val="6A7390"/>
                 </a:solidFill>
-                <a:latin typeface="PingFang SC" pitchFamily="34" charset="0"/>
-                <a:ea typeface="PingFang SC" pitchFamily="34" charset="-122"/>
-                <a:cs typeface="PingFang SC" pitchFamily="34" charset="-120"/>
+                <a:latin typeface="Microsoft YaHei" pitchFamily="34" charset="0"/>
+                <a:ea typeface="Microsoft YaHei" pitchFamily="34" charset="-122"/>
+                <a:cs typeface="Microsoft YaHei" pitchFamily="34" charset="-120"/>
               </a:rPr>
               <a:t>选型依据：工期约束 · 离线可跑 · 接口不变的演进能力</a:t>
             </a:r>
@@ -17802,9 +17804,9 @@
                 <a:solidFill>
                   <a:srgbClr val="6A7390"/>
                 </a:solidFill>
-                <a:latin typeface="PingFang SC" pitchFamily="34" charset="0"/>
-                <a:ea typeface="PingFang SC" pitchFamily="34" charset="-122"/>
-                <a:cs typeface="PingFang SC" pitchFamily="34" charset="-120"/>
+                <a:latin typeface="Microsoft YaHei" pitchFamily="34" charset="0"/>
+                <a:ea typeface="Microsoft YaHei" pitchFamily="34" charset="-122"/>
+                <a:cs typeface="Microsoft YaHei" pitchFamily="34" charset="-120"/>
               </a:rPr>
               <a:t>9</a:t>
             </a:r>
@@ -17854,16 +17856,16 @@
                           <a:solidFill>
                             <a:srgbClr val="FFFFFF"/>
                           </a:solidFill>
-                          <a:latin typeface="PingFang SC" pitchFamily="34" charset="0"/>
-                          <a:ea typeface="PingFang SC" pitchFamily="34" charset="-122"/>
-                          <a:cs typeface="PingFang SC" pitchFamily="34" charset="-120"/>
+                          <a:latin typeface="Microsoft YaHei" pitchFamily="34" charset="0"/>
+                          <a:ea typeface="Microsoft YaHei" pitchFamily="34" charset="-122"/>
+                          <a:cs typeface="Microsoft YaHei" pitchFamily="34" charset="-120"/>
                         </a:rPr>
                         <a:t>维度</a:t>
                       </a:r>
                       <a:endParaRPr lang="en-US" sz="1250" dirty="0">
-                        <a:latin typeface="PingFang SC" charset="0"/>
-                        <a:ea typeface="PingFang SC" charset="0"/>
-                        <a:cs typeface="PingFang SC" charset="0"/>
+                        <a:latin typeface="Microsoft YaHei" charset="0"/>
+                        <a:ea typeface="Microsoft YaHei" charset="0"/>
+                        <a:cs typeface="Microsoft YaHei" charset="0"/>
                       </a:endParaRPr>
                     </a:p>
                   </a:txBody>
@@ -17922,16 +17924,16 @@
                           <a:solidFill>
                             <a:srgbClr val="FFFFFF"/>
                           </a:solidFill>
-                          <a:latin typeface="PingFang SC" pitchFamily="34" charset="0"/>
-                          <a:ea typeface="PingFang SC" pitchFamily="34" charset="-122"/>
-                          <a:cs typeface="PingFang SC" pitchFamily="34" charset="-120"/>
+                          <a:latin typeface="Microsoft YaHei" pitchFamily="34" charset="0"/>
+                          <a:ea typeface="Microsoft YaHei" pitchFamily="34" charset="-122"/>
+                          <a:cs typeface="Microsoft YaHei" pitchFamily="34" charset="-120"/>
                         </a:rPr>
                         <a:t>选型</a:t>
                       </a:r>
                       <a:endParaRPr lang="en-US" sz="1250" dirty="0">
-                        <a:latin typeface="PingFang SC" charset="0"/>
-                        <a:ea typeface="PingFang SC" charset="0"/>
-                        <a:cs typeface="PingFang SC" charset="0"/>
+                        <a:latin typeface="Microsoft YaHei" charset="0"/>
+                        <a:ea typeface="Microsoft YaHei" charset="0"/>
+                        <a:cs typeface="Microsoft YaHei" charset="0"/>
                       </a:endParaRPr>
                     </a:p>
                   </a:txBody>
@@ -17990,16 +17992,16 @@
                           <a:solidFill>
                             <a:srgbClr val="FFFFFF"/>
                           </a:solidFill>
-                          <a:latin typeface="PingFang SC" pitchFamily="34" charset="0"/>
-                          <a:ea typeface="PingFang SC" pitchFamily="34" charset="-122"/>
-                          <a:cs typeface="PingFang SC" pitchFamily="34" charset="-120"/>
+                          <a:latin typeface="Microsoft YaHei" pitchFamily="34" charset="0"/>
+                          <a:ea typeface="Microsoft YaHei" pitchFamily="34" charset="-122"/>
+                          <a:cs typeface="Microsoft YaHei" pitchFamily="34" charset="-120"/>
                         </a:rPr>
                         <a:t>备选方案</a:t>
                       </a:r>
                       <a:endParaRPr lang="en-US" sz="1250" dirty="0">
-                        <a:latin typeface="PingFang SC" charset="0"/>
-                        <a:ea typeface="PingFang SC" charset="0"/>
-                        <a:cs typeface="PingFang SC" charset="0"/>
+                        <a:latin typeface="Microsoft YaHei" charset="0"/>
+                        <a:ea typeface="Microsoft YaHei" charset="0"/>
+                        <a:cs typeface="Microsoft YaHei" charset="0"/>
                       </a:endParaRPr>
                     </a:p>
                   </a:txBody>
@@ -18058,16 +18060,16 @@
                           <a:solidFill>
                             <a:srgbClr val="FFFFFF"/>
                           </a:solidFill>
-                          <a:latin typeface="PingFang SC" pitchFamily="34" charset="0"/>
-                          <a:ea typeface="PingFang SC" pitchFamily="34" charset="-122"/>
-                          <a:cs typeface="PingFang SC" pitchFamily="34" charset="-120"/>
+                          <a:latin typeface="Microsoft YaHei" pitchFamily="34" charset="0"/>
+                          <a:ea typeface="Microsoft YaHei" pitchFamily="34" charset="-122"/>
+                          <a:cs typeface="Microsoft YaHei" pitchFamily="34" charset="-120"/>
                         </a:rPr>
                         <a:t>决定性理由</a:t>
                       </a:r>
                       <a:endParaRPr lang="en-US" sz="1250" dirty="0">
-                        <a:latin typeface="PingFang SC" charset="0"/>
-                        <a:ea typeface="PingFang SC" charset="0"/>
-                        <a:cs typeface="PingFang SC" charset="0"/>
+                        <a:latin typeface="Microsoft YaHei" charset="0"/>
+                        <a:ea typeface="Microsoft YaHei" charset="0"/>
+                        <a:cs typeface="Microsoft YaHei" charset="0"/>
                       </a:endParaRPr>
                     </a:p>
                   </a:txBody>
@@ -18128,16 +18130,16 @@
                           <a:solidFill>
                             <a:srgbClr val="1C2333"/>
                           </a:solidFill>
-                          <a:latin typeface="PingFang SC" pitchFamily="34" charset="0"/>
-                          <a:ea typeface="PingFang SC" pitchFamily="34" charset="-122"/>
-                          <a:cs typeface="PingFang SC" pitchFamily="34" charset="-120"/>
+                          <a:latin typeface="Microsoft YaHei" pitchFamily="34" charset="0"/>
+                          <a:ea typeface="Microsoft YaHei" pitchFamily="34" charset="-122"/>
+                          <a:cs typeface="Microsoft YaHei" pitchFamily="34" charset="-120"/>
                         </a:rPr>
                         <a:t>Web 框架</a:t>
                       </a:r>
                       <a:endParaRPr lang="en-US" sz="1200" dirty="0">
-                        <a:latin typeface="PingFang SC" charset="0"/>
-                        <a:ea typeface="PingFang SC" charset="0"/>
-                        <a:cs typeface="PingFang SC" charset="0"/>
+                        <a:latin typeface="Microsoft YaHei" charset="0"/>
+                        <a:ea typeface="Microsoft YaHei" charset="0"/>
+                        <a:cs typeface="Microsoft YaHei" charset="0"/>
                       </a:endParaRPr>
                     </a:p>
                   </a:txBody>
@@ -18196,16 +18198,16 @@
                           <a:solidFill>
                             <a:srgbClr val="3B5BFD"/>
                           </a:solidFill>
-                          <a:latin typeface="PingFang SC" pitchFamily="34" charset="0"/>
-                          <a:ea typeface="PingFang SC" pitchFamily="34" charset="-122"/>
-                          <a:cs typeface="PingFang SC" pitchFamily="34" charset="-120"/>
+                          <a:latin typeface="Microsoft YaHei" pitchFamily="34" charset="0"/>
+                          <a:ea typeface="Microsoft YaHei" pitchFamily="34" charset="-122"/>
+                          <a:cs typeface="Microsoft YaHei" pitchFamily="34" charset="-120"/>
                         </a:rPr>
                         <a:t>FastAPI + 原生 JS SPA</a:t>
                       </a:r>
                       <a:endParaRPr lang="en-US" sz="1200" dirty="0">
-                        <a:latin typeface="PingFang SC" charset="0"/>
-                        <a:ea typeface="PingFang SC" charset="0"/>
-                        <a:cs typeface="PingFang SC" charset="0"/>
+                        <a:latin typeface="Microsoft YaHei" charset="0"/>
+                        <a:ea typeface="Microsoft YaHei" charset="0"/>
+                        <a:cs typeface="Microsoft YaHei" charset="0"/>
                       </a:endParaRPr>
                     </a:p>
                   </a:txBody>
@@ -18264,16 +18266,16 @@
                           <a:solidFill>
                             <a:srgbClr val="6A7390"/>
                           </a:solidFill>
-                          <a:latin typeface="PingFang SC" pitchFamily="34" charset="0"/>
-                          <a:ea typeface="PingFang SC" pitchFamily="34" charset="-122"/>
-                          <a:cs typeface="PingFang SC" pitchFamily="34" charset="-120"/>
+                          <a:latin typeface="Microsoft YaHei" pitchFamily="34" charset="0"/>
+                          <a:ea typeface="Microsoft YaHei" pitchFamily="34" charset="-122"/>
+                          <a:cs typeface="Microsoft YaHei" pitchFamily="34" charset="-120"/>
                         </a:rPr>
                         <a:t>Django / Spring Cloud</a:t>
                       </a:r>
                       <a:endParaRPr lang="en-US" sz="1200" dirty="0">
-                        <a:latin typeface="PingFang SC" charset="0"/>
-                        <a:ea typeface="PingFang SC" charset="0"/>
-                        <a:cs typeface="PingFang SC" charset="0"/>
+                        <a:latin typeface="Microsoft YaHei" charset="0"/>
+                        <a:ea typeface="Microsoft YaHei" charset="0"/>
+                        <a:cs typeface="Microsoft YaHei" charset="0"/>
                       </a:endParaRPr>
                     </a:p>
                   </a:txBody>
@@ -18332,16 +18334,16 @@
                           <a:solidFill>
                             <a:srgbClr val="6A7390"/>
                           </a:solidFill>
-                          <a:latin typeface="PingFang SC" pitchFamily="34" charset="0"/>
-                          <a:ea typeface="PingFang SC" pitchFamily="34" charset="-122"/>
-                          <a:cs typeface="PingFang SC" pitchFamily="34" charset="-120"/>
+                          <a:latin typeface="Microsoft YaHei" pitchFamily="34" charset="0"/>
+                          <a:ea typeface="Microsoft YaHei" pitchFamily="34" charset="-122"/>
+                          <a:cs typeface="Microsoft YaHei" pitchFamily="34" charset="-120"/>
                         </a:rPr>
                         <a:t>SSE/async 原生支持，零构建前端</a:t>
                       </a:r>
                       <a:endParaRPr lang="en-US" sz="1200" dirty="0">
-                        <a:latin typeface="PingFang SC" charset="0"/>
-                        <a:ea typeface="PingFang SC" charset="0"/>
-                        <a:cs typeface="PingFang SC" charset="0"/>
+                        <a:latin typeface="Microsoft YaHei" charset="0"/>
+                        <a:ea typeface="Microsoft YaHei" charset="0"/>
+                        <a:cs typeface="Microsoft YaHei" charset="0"/>
                       </a:endParaRPr>
                     </a:p>
                   </a:txBody>
@@ -18402,16 +18404,16 @@
                           <a:solidFill>
                             <a:srgbClr val="1C2333"/>
                           </a:solidFill>
-                          <a:latin typeface="PingFang SC" pitchFamily="34" charset="0"/>
-                          <a:ea typeface="PingFang SC" pitchFamily="34" charset="-122"/>
-                          <a:cs typeface="PingFang SC" pitchFamily="34" charset="-120"/>
+                          <a:latin typeface="Microsoft YaHei" pitchFamily="34" charset="0"/>
+                          <a:ea typeface="Microsoft YaHei" pitchFamily="34" charset="-122"/>
+                          <a:cs typeface="Microsoft YaHei" pitchFamily="34" charset="-120"/>
                         </a:rPr>
                         <a:t>检索架构</a:t>
                       </a:r>
                       <a:endParaRPr lang="en-US" sz="1200" dirty="0">
-                        <a:latin typeface="PingFang SC" charset="0"/>
-                        <a:ea typeface="PingFang SC" charset="0"/>
-                        <a:cs typeface="PingFang SC" charset="0"/>
+                        <a:latin typeface="Microsoft YaHei" charset="0"/>
+                        <a:ea typeface="Microsoft YaHei" charset="0"/>
+                        <a:cs typeface="Microsoft YaHei" charset="0"/>
                       </a:endParaRPr>
                     </a:p>
                   </a:txBody>
@@ -18470,16 +18472,16 @@
                           <a:solidFill>
                             <a:srgbClr val="3B5BFD"/>
                           </a:solidFill>
-                          <a:latin typeface="PingFang SC" pitchFamily="34" charset="0"/>
-                          <a:ea typeface="PingFang SC" pitchFamily="34" charset="-122"/>
-                          <a:cs typeface="PingFang SC" pitchFamily="34" charset="-120"/>
+                          <a:latin typeface="Microsoft YaHei" pitchFamily="34" charset="0"/>
+                          <a:ea typeface="Microsoft YaHei" pitchFamily="34" charset="-122"/>
+                          <a:cs typeface="Microsoft YaHei" pitchFamily="34" charset="-120"/>
                         </a:rPr>
                         <a:t>自实现 BM25+TF-IDF 向量</a:t>
                       </a:r>
                       <a:endParaRPr lang="en-US" sz="1200" dirty="0">
-                        <a:latin typeface="PingFang SC" charset="0"/>
-                        <a:ea typeface="PingFang SC" charset="0"/>
-                        <a:cs typeface="PingFang SC" charset="0"/>
+                        <a:latin typeface="Microsoft YaHei" charset="0"/>
+                        <a:ea typeface="Microsoft YaHei" charset="0"/>
+                        <a:cs typeface="Microsoft YaHei" charset="0"/>
                       </a:endParaRPr>
                     </a:p>
                   </a:txBody>
@@ -18538,16 +18540,16 @@
                           <a:solidFill>
                             <a:srgbClr val="6A7390"/>
                           </a:solidFill>
-                          <a:latin typeface="PingFang SC" pitchFamily="34" charset="0"/>
-                          <a:ea typeface="PingFang SC" pitchFamily="34" charset="-122"/>
-                          <a:cs typeface="PingFang SC" pitchFamily="34" charset="-120"/>
+                          <a:latin typeface="Microsoft YaHei" pitchFamily="34" charset="0"/>
+                          <a:ea typeface="Microsoft YaHei" pitchFamily="34" charset="-122"/>
+                          <a:cs typeface="Microsoft YaHei" pitchFamily="34" charset="-120"/>
                         </a:rPr>
                         <a:t>Elasticsearch / Milvus</a:t>
                       </a:r>
                       <a:endParaRPr lang="en-US" sz="1200" dirty="0">
-                        <a:latin typeface="PingFang SC" charset="0"/>
-                        <a:ea typeface="PingFang SC" charset="0"/>
-                        <a:cs typeface="PingFang SC" charset="0"/>
+                        <a:latin typeface="Microsoft YaHei" charset="0"/>
+                        <a:ea typeface="Microsoft YaHei" charset="0"/>
+                        <a:cs typeface="Microsoft YaHei" charset="0"/>
                       </a:endParaRPr>
                     </a:p>
                   </a:txBody>
@@ -18606,16 +18608,16 @@
                           <a:solidFill>
                             <a:srgbClr val="6A7390"/>
                           </a:solidFill>
-                          <a:latin typeface="PingFang SC" pitchFamily="34" charset="0"/>
-                          <a:ea typeface="PingFang SC" pitchFamily="34" charset="-122"/>
-                          <a:cs typeface="PingFang SC" pitchFamily="34" charset="-120"/>
+                          <a:latin typeface="Microsoft YaHei" pitchFamily="34" charset="0"/>
+                          <a:ea typeface="Microsoft YaHei" pitchFamily="34" charset="-122"/>
+                          <a:cs typeface="Microsoft YaHei" pitchFamily="34" charset="-120"/>
                         </a:rPr>
                         <a:t>零依赖演示；接口已预留升级位</a:t>
                       </a:r>
                       <a:endParaRPr lang="en-US" sz="1200" dirty="0">
-                        <a:latin typeface="PingFang SC" charset="0"/>
-                        <a:ea typeface="PingFang SC" charset="0"/>
-                        <a:cs typeface="PingFang SC" charset="0"/>
+                        <a:latin typeface="Microsoft YaHei" charset="0"/>
+                        <a:ea typeface="Microsoft YaHei" charset="0"/>
+                        <a:cs typeface="Microsoft YaHei" charset="0"/>
                       </a:endParaRPr>
                     </a:p>
                   </a:txBody>
@@ -18676,16 +18678,16 @@
                           <a:solidFill>
                             <a:srgbClr val="1C2333"/>
                           </a:solidFill>
-                          <a:latin typeface="PingFang SC" pitchFamily="34" charset="0"/>
-                          <a:ea typeface="PingFang SC" pitchFamily="34" charset="-122"/>
-                          <a:cs typeface="PingFang SC" pitchFamily="34" charset="-120"/>
+                          <a:latin typeface="Microsoft YaHei" pitchFamily="34" charset="0"/>
+                          <a:ea typeface="Microsoft YaHei" pitchFamily="34" charset="-122"/>
+                          <a:cs typeface="Microsoft YaHei" pitchFamily="34" charset="-120"/>
                         </a:rPr>
                         <a:t>LLM 接入</a:t>
                       </a:r>
                       <a:endParaRPr lang="en-US" sz="1200" dirty="0">
-                        <a:latin typeface="PingFang SC" charset="0"/>
-                        <a:ea typeface="PingFang SC" charset="0"/>
-                        <a:cs typeface="PingFang SC" charset="0"/>
+                        <a:latin typeface="Microsoft YaHei" charset="0"/>
+                        <a:ea typeface="Microsoft YaHei" charset="0"/>
+                        <a:cs typeface="Microsoft YaHei" charset="0"/>
                       </a:endParaRPr>
                     </a:p>
                   </a:txBody>
@@ -18744,16 +18746,16 @@
                           <a:solidFill>
                             <a:srgbClr val="3B5BFD"/>
                           </a:solidFill>
-                          <a:latin typeface="PingFang SC" pitchFamily="34" charset="0"/>
-                          <a:ea typeface="PingFang SC" pitchFamily="34" charset="-122"/>
-                          <a:cs typeface="PingFang SC" pitchFamily="34" charset="-120"/>
+                          <a:latin typeface="Microsoft YaHei" pitchFamily="34" charset="0"/>
+                          <a:ea typeface="Microsoft YaHei" pitchFamily="34" charset="-122"/>
+                          <a:cs typeface="Microsoft YaHei" pitchFamily="34" charset="-120"/>
                         </a:rPr>
                         <a:t>智谱 GLM(openai 兼容)</a:t>
                       </a:r>
                       <a:endParaRPr lang="en-US" sz="1200" dirty="0">
-                        <a:latin typeface="PingFang SC" charset="0"/>
-                        <a:ea typeface="PingFang SC" charset="0"/>
-                        <a:cs typeface="PingFang SC" charset="0"/>
+                        <a:latin typeface="Microsoft YaHei" charset="0"/>
+                        <a:ea typeface="Microsoft YaHei" charset="0"/>
+                        <a:cs typeface="Microsoft YaHei" charset="0"/>
                       </a:endParaRPr>
                     </a:p>
                   </a:txBody>
@@ -18812,16 +18814,16 @@
                           <a:solidFill>
                             <a:srgbClr val="6A7390"/>
                           </a:solidFill>
-                          <a:latin typeface="PingFang SC" pitchFamily="34" charset="0"/>
-                          <a:ea typeface="PingFang SC" pitchFamily="34" charset="-122"/>
-                          <a:cs typeface="PingFang SC" pitchFamily="34" charset="-120"/>
+                          <a:latin typeface="Microsoft YaHei" pitchFamily="34" charset="0"/>
+                          <a:ea typeface="Microsoft YaHei" pitchFamily="34" charset="-122"/>
+                          <a:cs typeface="Microsoft YaHei" pitchFamily="34" charset="-120"/>
                         </a:rPr>
                         <a:t>自部开源模型</a:t>
                       </a:r>
                       <a:endParaRPr lang="en-US" sz="1200" dirty="0">
-                        <a:latin typeface="PingFang SC" charset="0"/>
-                        <a:ea typeface="PingFang SC" charset="0"/>
-                        <a:cs typeface="PingFang SC" charset="0"/>
+                        <a:latin typeface="Microsoft YaHei" charset="0"/>
+                        <a:ea typeface="Microsoft YaHei" charset="0"/>
+                        <a:cs typeface="Microsoft YaHei" charset="0"/>
                       </a:endParaRPr>
                     </a:p>
                   </a:txBody>
@@ -18880,16 +18882,16 @@
                           <a:solidFill>
                             <a:srgbClr val="6A7390"/>
                           </a:solidFill>
-                          <a:latin typeface="PingFang SC" pitchFamily="34" charset="0"/>
-                          <a:ea typeface="PingFang SC" pitchFamily="34" charset="-122"/>
-                          <a:cs typeface="PingFang SC" pitchFamily="34" charset="-120"/>
+                          <a:latin typeface="Microsoft YaHei" pitchFamily="34" charset="0"/>
+                          <a:ea typeface="Microsoft YaHei" pitchFamily="34" charset="-122"/>
+                          <a:cs typeface="Microsoft YaHei" pitchFamily="34" charset="-120"/>
                         </a:rPr>
                         <a:t>标准协议可平滑替换供应商</a:t>
                       </a:r>
                       <a:endParaRPr lang="en-US" sz="1200" dirty="0">
-                        <a:latin typeface="PingFang SC" charset="0"/>
-                        <a:ea typeface="PingFang SC" charset="0"/>
-                        <a:cs typeface="PingFang SC" charset="0"/>
+                        <a:latin typeface="Microsoft YaHei" charset="0"/>
+                        <a:ea typeface="Microsoft YaHei" charset="0"/>
+                        <a:cs typeface="Microsoft YaHei" charset="0"/>
                       </a:endParaRPr>
                     </a:p>
                   </a:txBody>
@@ -18950,16 +18952,16 @@
                           <a:solidFill>
                             <a:srgbClr val="1C2333"/>
                           </a:solidFill>
-                          <a:latin typeface="PingFang SC" pitchFamily="34" charset="0"/>
-                          <a:ea typeface="PingFang SC" pitchFamily="34" charset="-122"/>
-                          <a:cs typeface="PingFang SC" pitchFamily="34" charset="-120"/>
+                          <a:latin typeface="Microsoft YaHei" pitchFamily="34" charset="0"/>
+                          <a:ea typeface="Microsoft YaHei" pitchFamily="34" charset="-122"/>
+                          <a:cs typeface="Microsoft YaHei" pitchFamily="34" charset="-120"/>
                         </a:rPr>
                         <a:t>业务存储</a:t>
                       </a:r>
                       <a:endParaRPr lang="en-US" sz="1200" dirty="0">
-                        <a:latin typeface="PingFang SC" charset="0"/>
-                        <a:ea typeface="PingFang SC" charset="0"/>
-                        <a:cs typeface="PingFang SC" charset="0"/>
+                        <a:latin typeface="Microsoft YaHei" charset="0"/>
+                        <a:ea typeface="Microsoft YaHei" charset="0"/>
+                        <a:cs typeface="Microsoft YaHei" charset="0"/>
                       </a:endParaRPr>
                     </a:p>
                   </a:txBody>
@@ -19018,16 +19020,16 @@
                           <a:solidFill>
                             <a:srgbClr val="3B5BFD"/>
                           </a:solidFill>
-                          <a:latin typeface="PingFang SC" pitchFamily="34" charset="0"/>
-                          <a:ea typeface="PingFang SC" pitchFamily="34" charset="-122"/>
-                          <a:cs typeface="PingFang SC" pitchFamily="34" charset="-120"/>
+                          <a:latin typeface="Microsoft YaHei" pitchFamily="34" charset="0"/>
+                          <a:ea typeface="Microsoft YaHei" pitchFamily="34" charset="-122"/>
+                          <a:cs typeface="Microsoft YaHei" pitchFamily="34" charset="-120"/>
                         </a:rPr>
                         <a:t>SQLite(WAL)</a:t>
                       </a:r>
                       <a:endParaRPr lang="en-US" sz="1200" dirty="0">
-                        <a:latin typeface="PingFang SC" charset="0"/>
-                        <a:ea typeface="PingFang SC" charset="0"/>
-                        <a:cs typeface="PingFang SC" charset="0"/>
+                        <a:latin typeface="Microsoft YaHei" charset="0"/>
+                        <a:ea typeface="Microsoft YaHei" charset="0"/>
+                        <a:cs typeface="Microsoft YaHei" charset="0"/>
                       </a:endParaRPr>
                     </a:p>
                   </a:txBody>
@@ -19086,16 +19088,16 @@
                           <a:solidFill>
                             <a:srgbClr val="6A7390"/>
                           </a:solidFill>
-                          <a:latin typeface="PingFang SC" pitchFamily="34" charset="0"/>
-                          <a:ea typeface="PingFang SC" pitchFamily="34" charset="-122"/>
-                          <a:cs typeface="PingFang SC" pitchFamily="34" charset="-120"/>
+                          <a:latin typeface="Microsoft YaHei" pitchFamily="34" charset="0"/>
+                          <a:ea typeface="Microsoft YaHei" pitchFamily="34" charset="-122"/>
+                          <a:cs typeface="Microsoft YaHei" pitchFamily="34" charset="-120"/>
                         </a:rPr>
                         <a:t>PostgreSQL / MySQL</a:t>
                       </a:r>
                       <a:endParaRPr lang="en-US" sz="1200" dirty="0">
-                        <a:latin typeface="PingFang SC" charset="0"/>
-                        <a:ea typeface="PingFang SC" charset="0"/>
-                        <a:cs typeface="PingFang SC" charset="0"/>
+                        <a:latin typeface="Microsoft YaHei" charset="0"/>
+                        <a:ea typeface="Microsoft YaHei" charset="0"/>
+                        <a:cs typeface="Microsoft YaHei" charset="0"/>
                       </a:endParaRPr>
                     </a:p>
                   </a:txBody>
@@ -19154,16 +19156,16 @@
                           <a:solidFill>
                             <a:srgbClr val="6A7390"/>
                           </a:solidFill>
-                          <a:latin typeface="PingFang SC" pitchFamily="34" charset="0"/>
-                          <a:ea typeface="PingFang SC" pitchFamily="34" charset="-122"/>
-                          <a:cs typeface="PingFang SC" pitchFamily="34" charset="-120"/>
+                          <a:latin typeface="Microsoft YaHei" pitchFamily="34" charset="0"/>
+                          <a:ea typeface="Microsoft YaHei" pitchFamily="34" charset="-122"/>
+                          <a:cs typeface="Microsoft YaHei" pitchFamily="34" charset="-120"/>
                         </a:rPr>
                         <a:t>单文件备份；仓储层接口不变直接平移</a:t>
                       </a:r>
                       <a:endParaRPr lang="en-US" sz="1200" dirty="0">
-                        <a:latin typeface="PingFang SC" charset="0"/>
-                        <a:ea typeface="PingFang SC" charset="0"/>
-                        <a:cs typeface="PingFang SC" charset="0"/>
+                        <a:latin typeface="Microsoft YaHei" charset="0"/>
+                        <a:ea typeface="Microsoft YaHei" charset="0"/>
+                        <a:cs typeface="Microsoft YaHei" charset="0"/>
                       </a:endParaRPr>
                     </a:p>
                   </a:txBody>
@@ -19224,16 +19226,16 @@
                           <a:solidFill>
                             <a:srgbClr val="1C2333"/>
                           </a:solidFill>
-                          <a:latin typeface="PingFang SC" pitchFamily="34" charset="0"/>
-                          <a:ea typeface="PingFang SC" pitchFamily="34" charset="-122"/>
-                          <a:cs typeface="PingFang SC" pitchFamily="34" charset="-120"/>
+                          <a:latin typeface="Microsoft YaHei" pitchFamily="34" charset="0"/>
+                          <a:ea typeface="Microsoft YaHei" pitchFamily="34" charset="-122"/>
+                          <a:cs typeface="Microsoft YaHei" pitchFamily="34" charset="-120"/>
                         </a:rPr>
                         <a:t>流式协议</a:t>
                       </a:r>
                       <a:endParaRPr lang="en-US" sz="1200" dirty="0">
-                        <a:latin typeface="PingFang SC" charset="0"/>
-                        <a:ea typeface="PingFang SC" charset="0"/>
-                        <a:cs typeface="PingFang SC" charset="0"/>
+                        <a:latin typeface="Microsoft YaHei" charset="0"/>
+                        <a:ea typeface="Microsoft YaHei" charset="0"/>
+                        <a:cs typeface="Microsoft YaHei" charset="0"/>
                       </a:endParaRPr>
                     </a:p>
                   </a:txBody>
@@ -19292,16 +19294,16 @@
                           <a:solidFill>
                             <a:srgbClr val="3B5BFD"/>
                           </a:solidFill>
-                          <a:latin typeface="PingFang SC" pitchFamily="34" charset="0"/>
-                          <a:ea typeface="PingFang SC" pitchFamily="34" charset="-122"/>
-                          <a:cs typeface="PingFang SC" pitchFamily="34" charset="-120"/>
+                          <a:latin typeface="Microsoft YaHei" pitchFamily="34" charset="0"/>
+                          <a:ea typeface="Microsoft YaHei" pitchFamily="34" charset="-122"/>
+                          <a:cs typeface="Microsoft YaHei" pitchFamily="34" charset="-120"/>
                         </a:rPr>
                         <a:t>SSE</a:t>
                       </a:r>
                       <a:endParaRPr lang="en-US" sz="1200" dirty="0">
-                        <a:latin typeface="PingFang SC" charset="0"/>
-                        <a:ea typeface="PingFang SC" charset="0"/>
-                        <a:cs typeface="PingFang SC" charset="0"/>
+                        <a:latin typeface="Microsoft YaHei" charset="0"/>
+                        <a:ea typeface="Microsoft YaHei" charset="0"/>
+                        <a:cs typeface="Microsoft YaHei" charset="0"/>
                       </a:endParaRPr>
                     </a:p>
                   </a:txBody>
@@ -19360,16 +19362,16 @@
                           <a:solidFill>
                             <a:srgbClr val="6A7390"/>
                           </a:solidFill>
-                          <a:latin typeface="PingFang SC" pitchFamily="34" charset="0"/>
-                          <a:ea typeface="PingFang SC" pitchFamily="34" charset="-122"/>
-                          <a:cs typeface="PingFang SC" pitchFamily="34" charset="-120"/>
+                          <a:latin typeface="Microsoft YaHei" pitchFamily="34" charset="0"/>
+                          <a:ea typeface="Microsoft YaHei" pitchFamily="34" charset="-122"/>
+                          <a:cs typeface="Microsoft YaHei" pitchFamily="34" charset="-120"/>
                         </a:rPr>
                         <a:t>WebSocket / 轮询</a:t>
                       </a:r>
                       <a:endParaRPr lang="en-US" sz="1200" dirty="0">
-                        <a:latin typeface="PingFang SC" charset="0"/>
-                        <a:ea typeface="PingFang SC" charset="0"/>
-                        <a:cs typeface="PingFang SC" charset="0"/>
+                        <a:latin typeface="Microsoft YaHei" charset="0"/>
+                        <a:ea typeface="Microsoft YaHei" charset="0"/>
+                        <a:cs typeface="Microsoft YaHei" charset="0"/>
                       </a:endParaRPr>
                     </a:p>
                   </a:txBody>
@@ -19428,16 +19430,16 @@
                           <a:solidFill>
                             <a:srgbClr val="6A7390"/>
                           </a:solidFill>
-                          <a:latin typeface="PingFang SC" pitchFamily="34" charset="0"/>
-                          <a:ea typeface="PingFang SC" pitchFamily="34" charset="-122"/>
-                          <a:cs typeface="PingFang SC" pitchFamily="34" charset="-120"/>
+                          <a:latin typeface="Microsoft YaHei" pitchFamily="34" charset="0"/>
+                          <a:ea typeface="Microsoft YaHei" pitchFamily="34" charset="-122"/>
+                          <a:cs typeface="Microsoft YaHei" pitchFamily="34" charset="-120"/>
                         </a:rPr>
                         <a:t>单向推送足够，网关友好且实现简单</a:t>
                       </a:r>
                       <a:endParaRPr lang="en-US" sz="1200" dirty="0">
-                        <a:latin typeface="PingFang SC" charset="0"/>
-                        <a:ea typeface="PingFang SC" charset="0"/>
-                        <a:cs typeface="PingFang SC" charset="0"/>
+                        <a:latin typeface="Microsoft YaHei" charset="0"/>
+                        <a:ea typeface="Microsoft YaHei" charset="0"/>
+                        <a:cs typeface="Microsoft YaHei" charset="0"/>
                       </a:endParaRPr>
                     </a:p>
                   </a:txBody>
@@ -19498,16 +19500,16 @@
                           <a:solidFill>
                             <a:srgbClr val="1C2333"/>
                           </a:solidFill>
-                          <a:latin typeface="PingFang SC" pitchFamily="34" charset="0"/>
-                          <a:ea typeface="PingFang SC" pitchFamily="34" charset="-122"/>
-                          <a:cs typeface="PingFang SC" pitchFamily="34" charset="-120"/>
+                          <a:latin typeface="Microsoft YaHei" pitchFamily="34" charset="0"/>
+                          <a:ea typeface="Microsoft YaHei" pitchFamily="34" charset="-122"/>
+                          <a:cs typeface="Microsoft YaHei" pitchFamily="34" charset="-120"/>
                         </a:rPr>
                         <a:t>Embedding</a:t>
                       </a:r>
                       <a:endParaRPr lang="en-US" sz="1200" dirty="0">
-                        <a:latin typeface="PingFang SC" charset="0"/>
-                        <a:ea typeface="PingFang SC" charset="0"/>
-                        <a:cs typeface="PingFang SC" charset="0"/>
+                        <a:latin typeface="Microsoft YaHei" charset="0"/>
+                        <a:ea typeface="Microsoft YaHei" charset="0"/>
+                        <a:cs typeface="Microsoft YaHei" charset="0"/>
                       </a:endParaRPr>
                     </a:p>
                   </a:txBody>
@@ -19566,16 +19568,16 @@
                           <a:solidFill>
                             <a:srgbClr val="3B5BFD"/>
                           </a:solidFill>
-                          <a:latin typeface="PingFang SC" pitchFamily="34" charset="0"/>
-                          <a:ea typeface="PingFang SC" pitchFamily="34" charset="-122"/>
-                          <a:cs typeface="PingFang SC" pitchFamily="34" charset="-120"/>
+                          <a:latin typeface="Microsoft YaHei" pitchFamily="34" charset="0"/>
+                          <a:ea typeface="Microsoft YaHei" pitchFamily="34" charset="-122"/>
+                          <a:cs typeface="Microsoft YaHei" pitchFamily="34" charset="-120"/>
                         </a:rPr>
                         <a:t>TF-IDF 离线 + 云端 Provider 已实现</a:t>
                       </a:r>
                       <a:endParaRPr lang="en-US" sz="1200" dirty="0">
-                        <a:latin typeface="PingFang SC" charset="0"/>
-                        <a:ea typeface="PingFang SC" charset="0"/>
-                        <a:cs typeface="PingFang SC" charset="0"/>
+                        <a:latin typeface="Microsoft YaHei" charset="0"/>
+                        <a:ea typeface="Microsoft YaHei" charset="0"/>
+                        <a:cs typeface="Microsoft YaHei" charset="0"/>
                       </a:endParaRPr>
                     </a:p>
                   </a:txBody>
@@ -19634,16 +19636,16 @@
                           <a:solidFill>
                             <a:srgbClr val="6A7390"/>
                           </a:solidFill>
-                          <a:latin typeface="PingFang SC" pitchFamily="34" charset="0"/>
-                          <a:ea typeface="PingFang SC" pitchFamily="34" charset="-122"/>
-                          <a:cs typeface="PingFang SC" pitchFamily="34" charset="-120"/>
+                          <a:latin typeface="Microsoft YaHei" pitchFamily="34" charset="0"/>
+                          <a:ea typeface="Microsoft YaHei" pitchFamily="34" charset="-122"/>
+                          <a:cs typeface="Microsoft YaHei" pitchFamily="34" charset="-120"/>
                         </a:rPr>
                         <a:t>本地深度模型</a:t>
                       </a:r>
                       <a:endParaRPr lang="en-US" sz="1200" dirty="0">
-                        <a:latin typeface="PingFang SC" charset="0"/>
-                        <a:ea typeface="PingFang SC" charset="0"/>
-                        <a:cs typeface="PingFang SC" charset="0"/>
+                        <a:latin typeface="Microsoft YaHei" charset="0"/>
+                        <a:ea typeface="Microsoft YaHei" charset="0"/>
+                        <a:cs typeface="Microsoft YaHei" charset="0"/>
                       </a:endParaRPr>
                     </a:p>
                   </a:txBody>
@@ -19702,16 +19704,16 @@
                           <a:solidFill>
                             <a:srgbClr val="6A7390"/>
                           </a:solidFill>
-                          <a:latin typeface="PingFang SC" pitchFamily="34" charset="0"/>
-                          <a:ea typeface="PingFang SC" pitchFamily="34" charset="-122"/>
-                          <a:cs typeface="PingFang SC" pitchFamily="34" charset="-120"/>
+                          <a:latin typeface="Microsoft YaHei" pitchFamily="34" charset="0"/>
+                          <a:ea typeface="Microsoft YaHei" pitchFamily="34" charset="-122"/>
+                          <a:cs typeface="Microsoft YaHei" pitchFamily="34" charset="-120"/>
                         </a:rPr>
                         <a:t>无 Key 如实回退 TF-IDF；配 Key 即切语义向量，接口不变</a:t>
                       </a:r>
                       <a:endParaRPr lang="en-US" sz="1200" dirty="0">
-                        <a:latin typeface="PingFang SC" charset="0"/>
-                        <a:ea typeface="PingFang SC" charset="0"/>
-                        <a:cs typeface="PingFang SC" charset="0"/>
+                        <a:latin typeface="Microsoft YaHei" charset="0"/>
+                        <a:ea typeface="Microsoft YaHei" charset="0"/>
+                        <a:cs typeface="Microsoft YaHei" charset="0"/>
                       </a:endParaRPr>
                     </a:p>
                   </a:txBody>

</xml_diff>

<commit_message>
fix: rebase economic-viability analysis on real paid pricing, drop free-tier dependency
User direction: the plan must reflect real deployment economics, not
promotional pricing. All materials now compute LLM cost from actual paid
tiers; current free promotion is noted honestly but NOT counted in.

- Pricing basis: GLM-4-Flash historical list price ¥0.06-0.1/M tok,
  conservative tier ¥1/M tok (baseline), stress tier ¥5/M tok
- Plan A monthly bill: ¥15-35 -> ¥210-230 (server + conservative API)
- SaaS margin restated: ~44% conservative / ~88% historical-list tier
- Slides 17/18 rebuilt + doc §1/2.2/3/4.2/7/8/9 regenerated (7 pages,
  visually accepted), narration seg18 re-recorded, video rebuilt 16:18
- README economics section synced
</commit_message>
<xml_diff>
--- a/ppt/智问校园CampusMind答辩PPT.pptx
+++ b/ppt/智问校园CampusMind答辩PPT.pptx
@@ -1613,7 +1613,7 @@
           <a:p>
             <a:r>
               <a:rPr lang="en-US" dirty="0"/>
-              <a:t>售卖模式三档:SaaS订阅、私有化买断、免费社区版。强调:定价是商业假设示例,真实依据是下一页的成本账单——默认链路无GPU无强制API费,边际成本近零。</a:t>
+              <a:t>售卖模式三档:SaaS订阅、私有化买断、免费社区版。强调:定价是商业假设示例,且全按真实收费价核算——保守价下月成本约210-230元仍有约45%毛利,本地抽取式兜底给成本硬上限。</a:t>
             </a:r>
             <a:endParaRPr lang="en-US" dirty="0"/>
           </a:p>
@@ -1701,7 +1701,7 @@
           <a:p>
             <a:r>
               <a:rPr lang="en-US" dirty="0"/>
-              <a:t>三种方案的月账单:云端SaaS约15-35元/月,私有化复用已有虚机边际为0,全离线GPU约1000-1500元/月。每问API成本给出敏感性:免费期0元,收费假设下日均5000问约195元/月。价格均为2026-10活动价,如实标注。</a:t>
+              <a:t>三种方案月账单(全按真实收费价):云端SaaS约210-230元/月(服务器+保守档API),私有化复用已有虚机边际为0,全离线GPU约1000-1500元/月。每问API三档:Flash历史挂牌价约12-20元/月,保守档1元/百万token约195元/月,上限975元/月;现行免费活动未计入。服务器为2026-10活动价,如实标注。</a:t>
             </a:r>
             <a:endParaRPr lang="en-US" dirty="0"/>
           </a:p>
@@ -10464,7 +10464,7 @@
                 <a:ea typeface="Microsoft YaHei" pitchFamily="34" charset="-122"/>
                 <a:cs typeface="Microsoft YaHei" pitchFamily="34" charset="-120"/>
               </a:rPr>
-              <a:t>定价为商业假设示例（非承诺）· 底气来自近零边际成本的结构</a:t>
+              <a:t>定价为商业假设示例（非承诺）· 全按真实收费价核算，不依赖任何免费活动</a:t>
             </a:r>
             <a:endParaRPr lang="en-US" sz="1250" dirty="0"/>
           </a:p>
@@ -10657,7 +10657,7 @@
                 <a:ea typeface="Microsoft YaHei" pitchFamily="34" charset="-122"/>
                 <a:cs typeface="Microsoft YaHei" pitchFamily="34" charset="-120"/>
               </a:rPr>
-              <a:t>我方托管：1 台轻量服务器 + 免费档模型；零运维、含升级与维保；按年续费，先试用后签约</a:t>
+              <a:t>我方托管：1 台轻量服务器 + 按量 API；零运维、含升级与维保；先试用后签约</a:t>
             </a:r>
             <a:endParaRPr lang="en-US" sz="1150" dirty="0"/>
           </a:p>
@@ -11014,7 +11014,7 @@
         <p:spPr>
           <a:xfrm>
             <a:off x="868680" y="4517136"/>
-            <a:ext cx="5486400" cy="365760"/>
+            <a:ext cx="6400800" cy="365760"/>
           </a:xfrm>
           <a:prstGeom prst="rect">
             <a:avLst/>
@@ -11038,7 +11038,7 @@
                 <a:ea typeface="Microsoft YaHei" pitchFamily="34" charset="-122"/>
                 <a:cs typeface="Microsoft YaHei" pitchFamily="34" charset="-120"/>
               </a:rPr>
-              <a:t>为什么敢定低价 —— 成本结构拆解</a:t>
+              <a:t>为什么敢定低价 —— 不依赖任何免费政策</a:t>
             </a:r>
             <a:endParaRPr lang="en-US" sz="1400" dirty="0"/>
           </a:p>
@@ -11080,7 +11080,7 @@
                 <a:ea typeface="Microsoft YaHei" pitchFamily="34" charset="-122"/>
                 <a:cs typeface="Microsoft YaHei" pitchFamily="34" charset="-120"/>
               </a:rPr>
-              <a:t>默认链路 0 GPU、0 强制 API 费：</a:t>
+              <a:t>全按真实收费价核算：</a:t>
             </a:r>
             <a:pPr indent="0" marL="0">
               <a:lnSpc>
@@ -11097,7 +11097,7 @@
                 <a:ea typeface="Microsoft YaHei" pitchFamily="34" charset="-122"/>
                 <a:cs typeface="Microsoft YaHei" pitchFamily="34" charset="-120"/>
               </a:rPr>
-              <a:t>GLM-4-Flash 限时免费 + 本地抽取式兜底（无 Key 也完整服务）；单实例实测 44 QPS 足以承载全校日问量。边际成本近零 —— 低价仍可保毛利，这正是「经济适用型架构」的商业回报。</a:t>
+              <a:t>保守价 ¥1/百万 token、日均 5,000 问，API 费 ≈¥195/月，月总成本 ≈¥210–230 —— 对 ¥4,999/年定价仍有 ≈45% 毛利；本地抽取式兜底内置零成本（无 Key 也完整服务），成本有硬上限。这正是「经济适用型架构」的商业回报。</a:t>
             </a:r>
             <a:endParaRPr lang="en-US" sz="1300" dirty="0"/>
           </a:p>
@@ -11708,7 +11708,7 @@
                           <a:ea typeface="Microsoft YaHei" pitchFamily="34" charset="-122"/>
                           <a:cs typeface="Microsoft YaHei" pitchFamily="34" charset="-120"/>
                         </a:rPr>
-                        <a:t>GLM-4-Flash 限时免费 · embedding-3 重建 ≈¥0.01/次</a:t>
+                        <a:t>GLM 按量计费（保守 ¥1/百万 token，5,000 问/日 ≈¥195/月）· embedding-3 ≈¥0.01/次</a:t>
                       </a:r>
                       <a:endParaRPr lang="en-US" sz="1150" dirty="0">
                         <a:latin typeface="Microsoft YaHei" charset="0"/>
@@ -11776,7 +11776,7 @@
                           <a:ea typeface="Microsoft YaHei" pitchFamily="34" charset="-122"/>
                           <a:cs typeface="Microsoft YaHei" pitchFamily="34" charset="-120"/>
                         </a:rPr>
-                        <a:t>≈ ¥15–35</a:t>
+                        <a:t>≈ ¥210–230</a:t>
                       </a:r>
                       <a:endParaRPr lang="en-US" sz="1150" dirty="0">
                         <a:latin typeface="Microsoft YaHei" charset="0"/>
@@ -12447,7 +12447,7 @@
                 <a:ea typeface="Microsoft YaHei" pitchFamily="34" charset="-122"/>
                 <a:cs typeface="Microsoft YaHei" pitchFamily="34" charset="-120"/>
               </a:rPr>
-              <a:t>每问调用成本（敏感性测算）</a:t>
+              <a:t>每问调用成本（真实收费价三档）</a:t>
             </a:r>
             <a:endParaRPr lang="en-US" sz="1350" dirty="0"/>
           </a:p>
@@ -12492,7 +12492,7 @@
                 <a:ea typeface="Microsoft YaHei" pitchFamily="34" charset="-122"/>
                 <a:cs typeface="Microsoft YaHei" pitchFamily="34" charset="-120"/>
               </a:rPr>
-              <a:t>实测每问 ≈ 1.3k token（系统提示 60 字 + 3 段上下文 + 回答）。
+              <a:t>每问 ≈ 1.3k token（系统提示 + 3 段上下文 + 回答）。日均 5,000 问：
 </a:t>
             </a:r>
             <a:pPr indent="0" marL="0">
@@ -12513,7 +12513,7 @@
                 <a:ea typeface="Microsoft YaHei" pitchFamily="34" charset="-122"/>
                 <a:cs typeface="Microsoft YaHei" pitchFamily="34" charset="-120"/>
               </a:rPr>
-              <a:t>Flash 免费期：¥0/问；</a:t>
+              <a:t>Flash 历史挂牌价 ¥0.06–0.1/百万 ≈ ¥12–20/月；</a:t>
             </a:r>
             <a:pPr indent="0" marL="0">
               <a:lnSpc>
@@ -12533,7 +12533,7 @@
                 <a:ea typeface="Microsoft YaHei" pitchFamily="34" charset="-122"/>
                 <a:cs typeface="Microsoft YaHei" pitchFamily="34" charset="-120"/>
               </a:rPr>
-              <a:t>若按 ¥1/百万 token 计费：每问 ¥0.0013 · 日均 5,000 问 ≈ ¥195/月。</a:t>
+              <a:t>保守档 ¥1/百万 ≈ ¥195/月（方案基准）；上限 ¥5/百万 ≈ ¥975/月。现行免费活动未计入。</a:t>
             </a:r>
             <a:endParaRPr lang="en-US" sz="1150" dirty="0"/>
           </a:p>

</xml_diff>